<commit_message>
Added team name and members to the slide deck
</commit_message>
<xml_diff>
--- a/demo/pitch deck template - UCT hackathon 2026.pptx
+++ b/demo/pitch deck template - UCT hackathon 2026.pptx
@@ -1,55 +1,55 @@
 
 <file path=ppt/presentation.xml><?xml version="1.0" encoding="utf-8"?>
-<p:presentation xmlns:a="http://schemas.openxmlformats.org/drawingml/2006/main" xmlns:r="http://schemas.openxmlformats.org/officeDocument/2006/relationships" xmlns:mc="http://schemas.openxmlformats.org/markup-compatibility/2006" xmlns:mv="urn:schemas-microsoft-com:mac:vml" xmlns:p="http://schemas.openxmlformats.org/presentationml/2006/main" xmlns:c="http://schemas.openxmlformats.org/drawingml/2006/chart" xmlns:dgm="http://schemas.openxmlformats.org/drawingml/2006/diagram" xmlns:o="urn:schemas-microsoft-com:office:office" xmlns:v="urn:schemas-microsoft-com:vml" xmlns:pvml="urn:schemas-microsoft-com:office:powerpoint" xmlns:com="http://schemas.openxmlformats.org/drawingml/2006/compatibility" xmlns:p14="http://schemas.microsoft.com/office/powerpoint/2010/main" xmlns:p15="http://schemas.microsoft.com/office/powerpoint/2012/main" xmlns:ahyp="http://schemas.microsoft.com/office/drawing/2018/hyperlinkcolor" autoCompressPictures="0" embedTrueTypeFonts="1" strictFirstAndLastChars="0" saveSubsetFonts="1">
+<p:presentation xmlns:a="http://schemas.openxmlformats.org/drawingml/2006/main" xmlns:r="http://schemas.openxmlformats.org/officeDocument/2006/relationships" xmlns:p="http://schemas.openxmlformats.org/presentationml/2006/main" strictFirstAndLastChars="0" embedTrueTypeFonts="1" saveSubsetFonts="1" autoCompressPictures="0">
   <p:sldMasterIdLst>
-    <p:sldMasterId id="2147483653" r:id="rId4"/>
+    <p:sldMasterId id="2147483653" r:id="rId1"/>
   </p:sldMasterIdLst>
   <p:notesMasterIdLst>
-    <p:notesMasterId r:id="rId5"/>
+    <p:notesMasterId r:id="rId9"/>
   </p:notesMasterIdLst>
   <p:sldIdLst>
-    <p:sldId id="256" r:id="rId6"/>
-    <p:sldId id="257" r:id="rId7"/>
-    <p:sldId id="258" r:id="rId8"/>
-    <p:sldId id="259" r:id="rId9"/>
-    <p:sldId id="260" r:id="rId10"/>
-    <p:sldId id="261" r:id="rId11"/>
-    <p:sldId id="262" r:id="rId12"/>
+    <p:sldId id="256" r:id="rId2"/>
+    <p:sldId id="257" r:id="rId3"/>
+    <p:sldId id="258" r:id="rId4"/>
+    <p:sldId id="259" r:id="rId5"/>
+    <p:sldId id="260" r:id="rId6"/>
+    <p:sldId id="261" r:id="rId7"/>
+    <p:sldId id="262" r:id="rId8"/>
   </p:sldIdLst>
-  <p:sldSz cy="5143500" cx="9144000"/>
+  <p:sldSz cx="9144000" cy="5143500" type="screen16x9"/>
   <p:notesSz cx="6858000" cy="9144000"/>
   <p:embeddedFontLst>
     <p:embeddedFont>
-      <p:font typeface="Titillium Web SemiBold"/>
-      <p:regular r:id="rId13"/>
-      <p:bold r:id="rId14"/>
-      <p:italic r:id="rId15"/>
-      <p:boldItalic r:id="rId16"/>
+      <p:font typeface="Helvetica Neue" panose="020B0604020202020204" charset="0"/>
+      <p:regular r:id="rId10"/>
+      <p:bold r:id="rId11"/>
+      <p:italic r:id="rId12"/>
+      <p:boldItalic r:id="rId13"/>
     </p:embeddedFont>
     <p:embeddedFont>
-      <p:font typeface="Libre Franklin"/>
-      <p:regular r:id="rId17"/>
-      <p:bold r:id="rId18"/>
-      <p:italic r:id="rId19"/>
-      <p:boldItalic r:id="rId20"/>
+      <p:font typeface="Libre Franklin" panose="020F0502020204030204" pitchFamily="2" charset="0"/>
+      <p:regular r:id="rId14"/>
+      <p:bold r:id="rId15"/>
+      <p:italic r:id="rId16"/>
+      <p:boldItalic r:id="rId17"/>
     </p:embeddedFont>
     <p:embeddedFont>
-      <p:font typeface="Titillium Web"/>
-      <p:regular r:id="rId21"/>
-      <p:bold r:id="rId22"/>
-      <p:italic r:id="rId23"/>
-      <p:boldItalic r:id="rId24"/>
+      <p:font typeface="Titillium Web" panose="020F0502020204030204" pitchFamily="2" charset="0"/>
+      <p:regular r:id="rId18"/>
+      <p:bold r:id="rId19"/>
+      <p:italic r:id="rId20"/>
+      <p:boldItalic r:id="rId21"/>
     </p:embeddedFont>
     <p:embeddedFont>
-      <p:font typeface="Helvetica Neue"/>
-      <p:regular r:id="rId25"/>
-      <p:bold r:id="rId26"/>
-      <p:italic r:id="rId27"/>
-      <p:boldItalic r:id="rId28"/>
+      <p:font typeface="Titillium Web SemiBold" panose="020F0502020204030204" pitchFamily="2" charset="0"/>
+      <p:regular r:id="rId22"/>
+      <p:bold r:id="rId23"/>
+      <p:italic r:id="rId24"/>
+      <p:boldItalic r:id="rId25"/>
     </p:embeddedFont>
   </p:embeddedFontLst>
   <p:defaultTextStyle>
-    <a:defPPr lvl="0" marR="0" rtl="0" algn="l">
+    <a:defPPr marR="0" lvl="0" algn="l" rtl="0">
       <a:lnSpc>
         <a:spcPct val="100000"/>
       </a:lnSpc>
@@ -60,7 +60,7 @@
         <a:spcPts val="0"/>
       </a:spcAft>
     </a:defPPr>
-    <a:lvl1pPr lvl="0" marR="0" rtl="0" algn="l">
+    <a:lvl1pPr marR="0" lvl="0" algn="l" rtl="0">
       <a:lnSpc>
         <a:spcPct val="100000"/>
       </a:lnSpc>
@@ -74,7 +74,7 @@
         <a:srgbClr val="000000"/>
       </a:buClr>
       <a:buFont typeface="Arial"/>
-      <a:defRPr b="0" i="0" sz="1400" u="none" cap="none" strike="noStrike">
+      <a:defRPr sz="1400" b="0" i="0" u="none" strike="noStrike" cap="none">
         <a:solidFill>
           <a:srgbClr val="000000"/>
         </a:solidFill>
@@ -84,7 +84,7 @@
         <a:sym typeface="Arial"/>
       </a:defRPr>
     </a:lvl1pPr>
-    <a:lvl2pPr lvl="1" marR="0" rtl="0" algn="l">
+    <a:lvl2pPr marR="0" lvl="1" algn="l" rtl="0">
       <a:lnSpc>
         <a:spcPct val="100000"/>
       </a:lnSpc>
@@ -98,7 +98,7 @@
         <a:srgbClr val="000000"/>
       </a:buClr>
       <a:buFont typeface="Arial"/>
-      <a:defRPr b="0" i="0" sz="1400" u="none" cap="none" strike="noStrike">
+      <a:defRPr sz="1400" b="0" i="0" u="none" strike="noStrike" cap="none">
         <a:solidFill>
           <a:srgbClr val="000000"/>
         </a:solidFill>
@@ -108,7 +108,7 @@
         <a:sym typeface="Arial"/>
       </a:defRPr>
     </a:lvl2pPr>
-    <a:lvl3pPr lvl="2" marR="0" rtl="0" algn="l">
+    <a:lvl3pPr marR="0" lvl="2" algn="l" rtl="0">
       <a:lnSpc>
         <a:spcPct val="100000"/>
       </a:lnSpc>
@@ -122,7 +122,7 @@
         <a:srgbClr val="000000"/>
       </a:buClr>
       <a:buFont typeface="Arial"/>
-      <a:defRPr b="0" i="0" sz="1400" u="none" cap="none" strike="noStrike">
+      <a:defRPr sz="1400" b="0" i="0" u="none" strike="noStrike" cap="none">
         <a:solidFill>
           <a:srgbClr val="000000"/>
         </a:solidFill>
@@ -132,7 +132,7 @@
         <a:sym typeface="Arial"/>
       </a:defRPr>
     </a:lvl3pPr>
-    <a:lvl4pPr lvl="3" marR="0" rtl="0" algn="l">
+    <a:lvl4pPr marR="0" lvl="3" algn="l" rtl="0">
       <a:lnSpc>
         <a:spcPct val="100000"/>
       </a:lnSpc>
@@ -146,7 +146,7 @@
         <a:srgbClr val="000000"/>
       </a:buClr>
       <a:buFont typeface="Arial"/>
-      <a:defRPr b="0" i="0" sz="1400" u="none" cap="none" strike="noStrike">
+      <a:defRPr sz="1400" b="0" i="0" u="none" strike="noStrike" cap="none">
         <a:solidFill>
           <a:srgbClr val="000000"/>
         </a:solidFill>
@@ -156,7 +156,7 @@
         <a:sym typeface="Arial"/>
       </a:defRPr>
     </a:lvl4pPr>
-    <a:lvl5pPr lvl="4" marR="0" rtl="0" algn="l">
+    <a:lvl5pPr marR="0" lvl="4" algn="l" rtl="0">
       <a:lnSpc>
         <a:spcPct val="100000"/>
       </a:lnSpc>
@@ -170,7 +170,7 @@
         <a:srgbClr val="000000"/>
       </a:buClr>
       <a:buFont typeface="Arial"/>
-      <a:defRPr b="0" i="0" sz="1400" u="none" cap="none" strike="noStrike">
+      <a:defRPr sz="1400" b="0" i="0" u="none" strike="noStrike" cap="none">
         <a:solidFill>
           <a:srgbClr val="000000"/>
         </a:solidFill>
@@ -180,7 +180,7 @@
         <a:sym typeface="Arial"/>
       </a:defRPr>
     </a:lvl5pPr>
-    <a:lvl6pPr lvl="5" marR="0" rtl="0" algn="l">
+    <a:lvl6pPr marR="0" lvl="5" algn="l" rtl="0">
       <a:lnSpc>
         <a:spcPct val="100000"/>
       </a:lnSpc>
@@ -194,7 +194,7 @@
         <a:srgbClr val="000000"/>
       </a:buClr>
       <a:buFont typeface="Arial"/>
-      <a:defRPr b="0" i="0" sz="1400" u="none" cap="none" strike="noStrike">
+      <a:defRPr sz="1400" b="0" i="0" u="none" strike="noStrike" cap="none">
         <a:solidFill>
           <a:srgbClr val="000000"/>
         </a:solidFill>
@@ -204,7 +204,7 @@
         <a:sym typeface="Arial"/>
       </a:defRPr>
     </a:lvl6pPr>
-    <a:lvl7pPr lvl="6" marR="0" rtl="0" algn="l">
+    <a:lvl7pPr marR="0" lvl="6" algn="l" rtl="0">
       <a:lnSpc>
         <a:spcPct val="100000"/>
       </a:lnSpc>
@@ -218,7 +218,7 @@
         <a:srgbClr val="000000"/>
       </a:buClr>
       <a:buFont typeface="Arial"/>
-      <a:defRPr b="0" i="0" sz="1400" u="none" cap="none" strike="noStrike">
+      <a:defRPr sz="1400" b="0" i="0" u="none" strike="noStrike" cap="none">
         <a:solidFill>
           <a:srgbClr val="000000"/>
         </a:solidFill>
@@ -228,7 +228,7 @@
         <a:sym typeface="Arial"/>
       </a:defRPr>
     </a:lvl7pPr>
-    <a:lvl8pPr lvl="7" marR="0" rtl="0" algn="l">
+    <a:lvl8pPr marR="0" lvl="7" algn="l" rtl="0">
       <a:lnSpc>
         <a:spcPct val="100000"/>
       </a:lnSpc>
@@ -242,7 +242,7 @@
         <a:srgbClr val="000000"/>
       </a:buClr>
       <a:buFont typeface="Arial"/>
-      <a:defRPr b="0" i="0" sz="1400" u="none" cap="none" strike="noStrike">
+      <a:defRPr sz="1400" b="0" i="0" u="none" strike="noStrike" cap="none">
         <a:solidFill>
           <a:srgbClr val="000000"/>
         </a:solidFill>
@@ -252,7 +252,7 @@
         <a:sym typeface="Arial"/>
       </a:defRPr>
     </a:lvl8pPr>
-    <a:lvl9pPr lvl="8" marR="0" rtl="0" algn="l">
+    <a:lvl9pPr marR="0" lvl="8" algn="l" rtl="0">
       <a:lnSpc>
         <a:spcPct val="100000"/>
       </a:lnSpc>
@@ -266,7 +266,7 @@
         <a:srgbClr val="000000"/>
       </a:buClr>
       <a:buFont typeface="Arial"/>
-      <a:defRPr b="0" i="0" sz="1400" u="none" cap="none" strike="noStrike">
+      <a:defRPr sz="1400" b="0" i="0" u="none" strike="noStrike" cap="none">
         <a:solidFill>
           <a:srgbClr val="000000"/>
         </a:solidFill>
@@ -279,7 +279,7 @@
   </p:defaultTextStyle>
   <p:extLst>
     <p:ext uri="{EFAFB233-063F-42B5-8137-9DF3F51BA10A}">
-      <p15:sldGuideLst>
+      <p15:sldGuideLst xmlns:p15="http://schemas.microsoft.com/office/powerpoint/2012/main">
         <p15:guide id="1" orient="horz" pos="1620">
           <p15:clr>
             <a:srgbClr val="747775"/>
@@ -297,11 +297,16 @@
 </file>
 
 <file path=ppt/notesMasters/notesMaster1.xml><?xml version="1.0" encoding="utf-8"?>
-<p:notesMaster xmlns:a="http://schemas.openxmlformats.org/drawingml/2006/main" xmlns:r="http://schemas.openxmlformats.org/officeDocument/2006/relationships" xmlns:mc="http://schemas.openxmlformats.org/markup-compatibility/2006" xmlns:mv="urn:schemas-microsoft-com:mac:vml" xmlns:p="http://schemas.openxmlformats.org/presentationml/2006/main" xmlns:c="http://schemas.openxmlformats.org/drawingml/2006/chart" xmlns:dgm="http://schemas.openxmlformats.org/drawingml/2006/diagram" xmlns:o="urn:schemas-microsoft-com:office:office" xmlns:v="urn:schemas-microsoft-com:vml" xmlns:pvml="urn:schemas-microsoft-com:office:powerpoint" xmlns:com="http://schemas.openxmlformats.org/drawingml/2006/compatibility" xmlns:p14="http://schemas.microsoft.com/office/powerpoint/2010/main" xmlns:p15="http://schemas.microsoft.com/office/powerpoint/2012/main" xmlns:ahyp="http://schemas.microsoft.com/office/drawing/2018/hyperlinkcolor">
+<p:notesMaster xmlns:a="http://schemas.openxmlformats.org/drawingml/2006/main" xmlns:r="http://schemas.openxmlformats.org/officeDocument/2006/relationships" xmlns:p="http://schemas.openxmlformats.org/presentationml/2006/main">
   <p:cSld>
+    <p:bg>
+      <p:bgRef idx="1001">
+        <a:schemeClr val="bg1"/>
+      </p:bgRef>
+    </p:bg>
     <p:spTree>
       <p:nvGrpSpPr>
-        <p:cNvPr id="2" name="Shape 2"/>
+        <p:cNvPr id="1" name="Shape 2"/>
         <p:cNvGrpSpPr/>
         <p:nvPr/>
       </p:nvGrpSpPr>
@@ -316,9 +321,11 @@
       <p:sp>
         <p:nvSpPr>
           <p:cNvPr id="3" name="Google Shape;3;n"/>
-          <p:cNvSpPr/>
+          <p:cNvSpPr>
+            <a:spLocks noGrp="1" noRot="1" noChangeAspect="1"/>
+          </p:cNvSpPr>
           <p:nvPr>
-            <p:ph idx="2" type="sldImg"/>
+            <p:ph type="sldImg" idx="2"/>
           </p:nvPr>
         </p:nvSpPr>
         <p:spPr>
@@ -327,9 +334,13 @@
             <a:ext cx="6096075" cy="3429000"/>
           </a:xfrm>
           <a:custGeom>
-            <a:rect b="b" l="l" r="r" t="t"/>
+            <a:avLst/>
+            <a:gdLst/>
+            <a:ahLst/>
+            <a:cxnLst/>
+            <a:rect l="l" t="t" r="r" b="b"/>
             <a:pathLst>
-              <a:path extrusionOk="0" h="120000" w="120000">
+              <a:path w="120000" h="120000" extrusionOk="0">
                 <a:moveTo>
                   <a:pt x="0" y="0"/>
                 </a:moveTo>
@@ -347,23 +358,25 @@
             </a:pathLst>
           </a:custGeom>
           <a:noFill/>
-          <a:ln cap="flat" cmpd="sng" w="9525">
+          <a:ln w="9525" cap="flat" cmpd="sng">
             <a:solidFill>
               <a:srgbClr val="000000"/>
             </a:solidFill>
             <a:prstDash val="solid"/>
             <a:round/>
-            <a:headEnd len="sm" w="sm" type="none"/>
-            <a:tailEnd len="sm" w="sm" type="none"/>
+            <a:headEnd type="none" w="sm" len="sm"/>
+            <a:tailEnd type="none" w="sm" len="sm"/>
           </a:ln>
         </p:spPr>
       </p:sp>
       <p:sp>
         <p:nvSpPr>
           <p:cNvPr id="4" name="Google Shape;4;n"/>
-          <p:cNvSpPr txBox="1"/>
+          <p:cNvSpPr txBox="1">
+            <a:spLocks noGrp="1"/>
+          </p:cNvSpPr>
           <p:nvPr>
-            <p:ph idx="1" type="body"/>
+            <p:ph type="body" idx="1"/>
           </p:nvPr>
         </p:nvSpPr>
         <p:spPr>
@@ -380,11 +393,11 @@
           </a:ln>
         </p:spPr>
         <p:txBody>
-          <a:bodyPr anchorCtr="0" anchor="t" bIns="91425" lIns="91425" spcFirstLastPara="1" rIns="91425" wrap="square" tIns="91425">
+          <a:bodyPr spcFirstLastPara="1" wrap="square" lIns="91425" tIns="91425" rIns="91425" bIns="91425" anchor="t" anchorCtr="0">
             <a:noAutofit/>
           </a:bodyPr>
           <a:lstStyle>
-            <a:lvl1pPr indent="-298450" lvl="0" marL="457200" marR="0" rtl="0" algn="l">
+            <a:lvl1pPr marL="457200" marR="0" lvl="0" indent="-298450" algn="l" rtl="0">
               <a:lnSpc>
                 <a:spcPct val="100000"/>
               </a:lnSpc>
@@ -400,7 +413,7 @@
               <a:buSzPts val="1100"/>
               <a:buFont typeface="Arial"/>
               <a:buChar char="●"/>
-              <a:defRPr b="0" i="0" sz="1100" u="none" cap="none" strike="noStrike">
+              <a:defRPr sz="1100" b="0" i="0" u="none" strike="noStrike" cap="none">
                 <a:solidFill>
                   <a:srgbClr val="000000"/>
                 </a:solidFill>
@@ -410,7 +423,7 @@
                 <a:sym typeface="Arial"/>
               </a:defRPr>
             </a:lvl1pPr>
-            <a:lvl2pPr indent="-298450" lvl="1" marL="914400" marR="0" rtl="0" algn="l">
+            <a:lvl2pPr marL="914400" marR="0" lvl="1" indent="-298450" algn="l" rtl="0">
               <a:lnSpc>
                 <a:spcPct val="100000"/>
               </a:lnSpc>
@@ -426,7 +439,7 @@
               <a:buSzPts val="1100"/>
               <a:buFont typeface="Arial"/>
               <a:buChar char="○"/>
-              <a:defRPr b="0" i="0" sz="1100" u="none" cap="none" strike="noStrike">
+              <a:defRPr sz="1100" b="0" i="0" u="none" strike="noStrike" cap="none">
                 <a:solidFill>
                   <a:srgbClr val="000000"/>
                 </a:solidFill>
@@ -436,7 +449,7 @@
                 <a:sym typeface="Arial"/>
               </a:defRPr>
             </a:lvl2pPr>
-            <a:lvl3pPr indent="-298450" lvl="2" marL="1371600" marR="0" rtl="0" algn="l">
+            <a:lvl3pPr marL="1371600" marR="0" lvl="2" indent="-298450" algn="l" rtl="0">
               <a:lnSpc>
                 <a:spcPct val="100000"/>
               </a:lnSpc>
@@ -452,7 +465,7 @@
               <a:buSzPts val="1100"/>
               <a:buFont typeface="Arial"/>
               <a:buChar char="■"/>
-              <a:defRPr b="0" i="0" sz="1100" u="none" cap="none" strike="noStrike">
+              <a:defRPr sz="1100" b="0" i="0" u="none" strike="noStrike" cap="none">
                 <a:solidFill>
                   <a:srgbClr val="000000"/>
                 </a:solidFill>
@@ -462,7 +475,7 @@
                 <a:sym typeface="Arial"/>
               </a:defRPr>
             </a:lvl3pPr>
-            <a:lvl4pPr indent="-298450" lvl="3" marL="1828800" marR="0" rtl="0" algn="l">
+            <a:lvl4pPr marL="1828800" marR="0" lvl="3" indent="-298450" algn="l" rtl="0">
               <a:lnSpc>
                 <a:spcPct val="100000"/>
               </a:lnSpc>
@@ -478,7 +491,7 @@
               <a:buSzPts val="1100"/>
               <a:buFont typeface="Arial"/>
               <a:buChar char="●"/>
-              <a:defRPr b="0" i="0" sz="1100" u="none" cap="none" strike="noStrike">
+              <a:defRPr sz="1100" b="0" i="0" u="none" strike="noStrike" cap="none">
                 <a:solidFill>
                   <a:srgbClr val="000000"/>
                 </a:solidFill>
@@ -488,7 +501,7 @@
                 <a:sym typeface="Arial"/>
               </a:defRPr>
             </a:lvl4pPr>
-            <a:lvl5pPr indent="-298450" lvl="4" marL="2286000" marR="0" rtl="0" algn="l">
+            <a:lvl5pPr marL="2286000" marR="0" lvl="4" indent="-298450" algn="l" rtl="0">
               <a:lnSpc>
                 <a:spcPct val="100000"/>
               </a:lnSpc>
@@ -504,7 +517,7 @@
               <a:buSzPts val="1100"/>
               <a:buFont typeface="Arial"/>
               <a:buChar char="○"/>
-              <a:defRPr b="0" i="0" sz="1100" u="none" cap="none" strike="noStrike">
+              <a:defRPr sz="1100" b="0" i="0" u="none" strike="noStrike" cap="none">
                 <a:solidFill>
                   <a:srgbClr val="000000"/>
                 </a:solidFill>
@@ -514,7 +527,7 @@
                 <a:sym typeface="Arial"/>
               </a:defRPr>
             </a:lvl5pPr>
-            <a:lvl6pPr indent="-298450" lvl="5" marL="2743200" marR="0" rtl="0" algn="l">
+            <a:lvl6pPr marL="2743200" marR="0" lvl="5" indent="-298450" algn="l" rtl="0">
               <a:lnSpc>
                 <a:spcPct val="100000"/>
               </a:lnSpc>
@@ -530,7 +543,7 @@
               <a:buSzPts val="1100"/>
               <a:buFont typeface="Arial"/>
               <a:buChar char="■"/>
-              <a:defRPr b="0" i="0" sz="1100" u="none" cap="none" strike="noStrike">
+              <a:defRPr sz="1100" b="0" i="0" u="none" strike="noStrike" cap="none">
                 <a:solidFill>
                   <a:srgbClr val="000000"/>
                 </a:solidFill>
@@ -540,7 +553,7 @@
                 <a:sym typeface="Arial"/>
               </a:defRPr>
             </a:lvl6pPr>
-            <a:lvl7pPr indent="-298450" lvl="6" marL="3200400" marR="0" rtl="0" algn="l">
+            <a:lvl7pPr marL="3200400" marR="0" lvl="6" indent="-298450" algn="l" rtl="0">
               <a:lnSpc>
                 <a:spcPct val="100000"/>
               </a:lnSpc>
@@ -556,7 +569,7 @@
               <a:buSzPts val="1100"/>
               <a:buFont typeface="Arial"/>
               <a:buChar char="●"/>
-              <a:defRPr b="0" i="0" sz="1100" u="none" cap="none" strike="noStrike">
+              <a:defRPr sz="1100" b="0" i="0" u="none" strike="noStrike" cap="none">
                 <a:solidFill>
                   <a:srgbClr val="000000"/>
                 </a:solidFill>
@@ -566,7 +579,7 @@
                 <a:sym typeface="Arial"/>
               </a:defRPr>
             </a:lvl7pPr>
-            <a:lvl8pPr indent="-298450" lvl="7" marL="3657600" marR="0" rtl="0" algn="l">
+            <a:lvl8pPr marL="3657600" marR="0" lvl="7" indent="-298450" algn="l" rtl="0">
               <a:lnSpc>
                 <a:spcPct val="100000"/>
               </a:lnSpc>
@@ -582,7 +595,7 @@
               <a:buSzPts val="1100"/>
               <a:buFont typeface="Arial"/>
               <a:buChar char="○"/>
-              <a:defRPr b="0" i="0" sz="1100" u="none" cap="none" strike="noStrike">
+              <a:defRPr sz="1100" b="0" i="0" u="none" strike="noStrike" cap="none">
                 <a:solidFill>
                   <a:srgbClr val="000000"/>
                 </a:solidFill>
@@ -592,7 +605,7 @@
                 <a:sym typeface="Arial"/>
               </a:defRPr>
             </a:lvl8pPr>
-            <a:lvl9pPr indent="-298450" lvl="8" marL="4114800" marR="0" rtl="0" algn="l">
+            <a:lvl9pPr marL="4114800" marR="0" lvl="8" indent="-298450" algn="l" rtl="0">
               <a:lnSpc>
                 <a:spcPct val="100000"/>
               </a:lnSpc>
@@ -608,7 +621,7 @@
               <a:buSzPts val="1100"/>
               <a:buFont typeface="Arial"/>
               <a:buChar char="■"/>
-              <a:defRPr b="0" i="0" sz="1100" u="none" cap="none" strike="noStrike">
+              <a:defRPr sz="1100" b="0" i="0" u="none" strike="noStrike" cap="none">
                 <a:solidFill>
                   <a:srgbClr val="000000"/>
                 </a:solidFill>
@@ -619,14 +632,16 @@
               </a:defRPr>
             </a:lvl9pPr>
           </a:lstStyle>
-          <a:p/>
+          <a:p>
+            <a:endParaRPr/>
+          </a:p>
         </p:txBody>
       </p:sp>
     </p:spTree>
   </p:cSld>
-  <p:clrMap accent1="accent1" accent2="accent2" accent3="accent3" accent4="accent4" accent5="accent5" accent6="accent6" bg1="lt1" bg2="dk2" tx1="dk1" tx2="lt2" folHlink="folHlink" hlink="hlink"/>
+  <p:clrMap bg1="lt1" tx1="dk1" bg2="dk2" tx2="lt2" accent1="accent1" accent2="accent2" accent3="accent3" accent4="accent4" accent5="accent5" accent6="accent6" hlink="hlink" folHlink="folHlink"/>
   <p:notesStyle>
-    <a:defPPr lvl="0" marR="0" rtl="0" algn="l">
+    <a:defPPr marR="0" lvl="0" algn="l" rtl="0">
       <a:lnSpc>
         <a:spcPct val="100000"/>
       </a:lnSpc>
@@ -637,7 +652,7 @@
         <a:spcPts val="0"/>
       </a:spcAft>
     </a:defPPr>
-    <a:lvl1pPr lvl="0" marR="0" rtl="0" algn="l">
+    <a:lvl1pPr marR="0" lvl="0" algn="l" rtl="0">
       <a:lnSpc>
         <a:spcPct val="100000"/>
       </a:lnSpc>
@@ -651,7 +666,7 @@
         <a:srgbClr val="000000"/>
       </a:buClr>
       <a:buFont typeface="Arial"/>
-      <a:defRPr b="0" i="0" sz="1400" u="none" cap="none" strike="noStrike">
+      <a:defRPr sz="1400" b="0" i="0" u="none" strike="noStrike" cap="none">
         <a:solidFill>
           <a:srgbClr val="000000"/>
         </a:solidFill>
@@ -661,7 +676,7 @@
         <a:sym typeface="Arial"/>
       </a:defRPr>
     </a:lvl1pPr>
-    <a:lvl2pPr lvl="1" marR="0" rtl="0" algn="l">
+    <a:lvl2pPr marR="0" lvl="1" algn="l" rtl="0">
       <a:lnSpc>
         <a:spcPct val="100000"/>
       </a:lnSpc>
@@ -675,7 +690,7 @@
         <a:srgbClr val="000000"/>
       </a:buClr>
       <a:buFont typeface="Arial"/>
-      <a:defRPr b="0" i="0" sz="1400" u="none" cap="none" strike="noStrike">
+      <a:defRPr sz="1400" b="0" i="0" u="none" strike="noStrike" cap="none">
         <a:solidFill>
           <a:srgbClr val="000000"/>
         </a:solidFill>
@@ -685,7 +700,7 @@
         <a:sym typeface="Arial"/>
       </a:defRPr>
     </a:lvl2pPr>
-    <a:lvl3pPr lvl="2" marR="0" rtl="0" algn="l">
+    <a:lvl3pPr marR="0" lvl="2" algn="l" rtl="0">
       <a:lnSpc>
         <a:spcPct val="100000"/>
       </a:lnSpc>
@@ -699,7 +714,7 @@
         <a:srgbClr val="000000"/>
       </a:buClr>
       <a:buFont typeface="Arial"/>
-      <a:defRPr b="0" i="0" sz="1400" u="none" cap="none" strike="noStrike">
+      <a:defRPr sz="1400" b="0" i="0" u="none" strike="noStrike" cap="none">
         <a:solidFill>
           <a:srgbClr val="000000"/>
         </a:solidFill>
@@ -709,7 +724,7 @@
         <a:sym typeface="Arial"/>
       </a:defRPr>
     </a:lvl3pPr>
-    <a:lvl4pPr lvl="3" marR="0" rtl="0" algn="l">
+    <a:lvl4pPr marR="0" lvl="3" algn="l" rtl="0">
       <a:lnSpc>
         <a:spcPct val="100000"/>
       </a:lnSpc>
@@ -723,7 +738,7 @@
         <a:srgbClr val="000000"/>
       </a:buClr>
       <a:buFont typeface="Arial"/>
-      <a:defRPr b="0" i="0" sz="1400" u="none" cap="none" strike="noStrike">
+      <a:defRPr sz="1400" b="0" i="0" u="none" strike="noStrike" cap="none">
         <a:solidFill>
           <a:srgbClr val="000000"/>
         </a:solidFill>
@@ -733,7 +748,7 @@
         <a:sym typeface="Arial"/>
       </a:defRPr>
     </a:lvl4pPr>
-    <a:lvl5pPr lvl="4" marR="0" rtl="0" algn="l">
+    <a:lvl5pPr marR="0" lvl="4" algn="l" rtl="0">
       <a:lnSpc>
         <a:spcPct val="100000"/>
       </a:lnSpc>
@@ -747,7 +762,7 @@
         <a:srgbClr val="000000"/>
       </a:buClr>
       <a:buFont typeface="Arial"/>
-      <a:defRPr b="0" i="0" sz="1400" u="none" cap="none" strike="noStrike">
+      <a:defRPr sz="1400" b="0" i="0" u="none" strike="noStrike" cap="none">
         <a:solidFill>
           <a:srgbClr val="000000"/>
         </a:solidFill>
@@ -757,7 +772,7 @@
         <a:sym typeface="Arial"/>
       </a:defRPr>
     </a:lvl5pPr>
-    <a:lvl6pPr lvl="5" marR="0" rtl="0" algn="l">
+    <a:lvl6pPr marR="0" lvl="5" algn="l" rtl="0">
       <a:lnSpc>
         <a:spcPct val="100000"/>
       </a:lnSpc>
@@ -771,7 +786,7 @@
         <a:srgbClr val="000000"/>
       </a:buClr>
       <a:buFont typeface="Arial"/>
-      <a:defRPr b="0" i="0" sz="1400" u="none" cap="none" strike="noStrike">
+      <a:defRPr sz="1400" b="0" i="0" u="none" strike="noStrike" cap="none">
         <a:solidFill>
           <a:srgbClr val="000000"/>
         </a:solidFill>
@@ -781,7 +796,7 @@
         <a:sym typeface="Arial"/>
       </a:defRPr>
     </a:lvl6pPr>
-    <a:lvl7pPr lvl="6" marR="0" rtl="0" algn="l">
+    <a:lvl7pPr marR="0" lvl="6" algn="l" rtl="0">
       <a:lnSpc>
         <a:spcPct val="100000"/>
       </a:lnSpc>
@@ -795,7 +810,7 @@
         <a:srgbClr val="000000"/>
       </a:buClr>
       <a:buFont typeface="Arial"/>
-      <a:defRPr b="0" i="0" sz="1400" u="none" cap="none" strike="noStrike">
+      <a:defRPr sz="1400" b="0" i="0" u="none" strike="noStrike" cap="none">
         <a:solidFill>
           <a:srgbClr val="000000"/>
         </a:solidFill>
@@ -805,7 +820,7 @@
         <a:sym typeface="Arial"/>
       </a:defRPr>
     </a:lvl7pPr>
-    <a:lvl8pPr lvl="7" marR="0" rtl="0" algn="l">
+    <a:lvl8pPr marR="0" lvl="7" algn="l" rtl="0">
       <a:lnSpc>
         <a:spcPct val="100000"/>
       </a:lnSpc>
@@ -819,7 +834,7 @@
         <a:srgbClr val="000000"/>
       </a:buClr>
       <a:buFont typeface="Arial"/>
-      <a:defRPr b="0" i="0" sz="1400" u="none" cap="none" strike="noStrike">
+      <a:defRPr sz="1400" b="0" i="0" u="none" strike="noStrike" cap="none">
         <a:solidFill>
           <a:srgbClr val="000000"/>
         </a:solidFill>
@@ -829,7 +844,7 @@
         <a:sym typeface="Arial"/>
       </a:defRPr>
     </a:lvl8pPr>
-    <a:lvl9pPr lvl="8" marR="0" rtl="0" algn="l">
+    <a:lvl9pPr marR="0" lvl="8" algn="l" rtl="0">
       <a:lnSpc>
         <a:spcPct val="100000"/>
       </a:lnSpc>
@@ -843,7 +858,7 @@
         <a:srgbClr val="000000"/>
       </a:buClr>
       <a:buFont typeface="Arial"/>
-      <a:defRPr b="0" i="0" sz="1400" u="none" cap="none" strike="noStrike">
+      <a:defRPr sz="1400" b="0" i="0" u="none" strike="noStrike" cap="none">
         <a:solidFill>
           <a:srgbClr val="000000"/>
         </a:solidFill>
@@ -858,11 +873,11 @@
 </file>
 
 <file path=ppt/notesSlides/notesSlide1.xml><?xml version="1.0" encoding="utf-8"?>
-<p:notes xmlns:a="http://schemas.openxmlformats.org/drawingml/2006/main" xmlns:r="http://schemas.openxmlformats.org/officeDocument/2006/relationships" xmlns:mc="http://schemas.openxmlformats.org/markup-compatibility/2006" xmlns:mv="urn:schemas-microsoft-com:mac:vml" xmlns:p="http://schemas.openxmlformats.org/presentationml/2006/main" xmlns:c="http://schemas.openxmlformats.org/drawingml/2006/chart" xmlns:dgm="http://schemas.openxmlformats.org/drawingml/2006/diagram" xmlns:o="urn:schemas-microsoft-com:office:office" xmlns:v="urn:schemas-microsoft-com:vml" xmlns:pvml="urn:schemas-microsoft-com:office:powerpoint" xmlns:com="http://schemas.openxmlformats.org/drawingml/2006/compatibility" xmlns:p14="http://schemas.microsoft.com/office/powerpoint/2010/main" xmlns:p15="http://schemas.microsoft.com/office/powerpoint/2012/main" xmlns:ahyp="http://schemas.microsoft.com/office/drawing/2018/hyperlinkcolor" showMasterPhAnim="0" showMasterSp="0">
+<p:notes xmlns:a="http://schemas.openxmlformats.org/drawingml/2006/main" xmlns:r="http://schemas.openxmlformats.org/officeDocument/2006/relationships" xmlns:p="http://schemas.openxmlformats.org/presentationml/2006/main" showMasterSp="0" showMasterPhAnim="0">
   <p:cSld>
     <p:spTree>
       <p:nvGrpSpPr>
-        <p:cNvPr id="30" name="Shape 30"/>
+        <p:cNvPr id="1" name="Shape 30"/>
         <p:cNvGrpSpPr/>
         <p:nvPr/>
       </p:nvGrpSpPr>
@@ -877,20 +892,26 @@
       <p:sp>
         <p:nvSpPr>
           <p:cNvPr id="31" name="Google Shape;31;p1:notes"/>
-          <p:cNvSpPr/>
+          <p:cNvSpPr>
+            <a:spLocks noGrp="1" noRot="1" noChangeAspect="1"/>
+          </p:cNvSpPr>
           <p:nvPr>
-            <p:ph idx="2" type="sldImg"/>
+            <p:ph type="sldImg" idx="2"/>
           </p:nvPr>
         </p:nvSpPr>
         <p:spPr>
           <a:xfrm>
-            <a:off x="381300" y="685800"/>
+            <a:off x="381000" y="685800"/>
             <a:ext cx="6096000" cy="3429000"/>
           </a:xfrm>
           <a:custGeom>
-            <a:rect b="b" l="l" r="r" t="t"/>
+            <a:avLst/>
+            <a:gdLst/>
+            <a:ahLst/>
+            <a:cxnLst/>
+            <a:rect l="l" t="t" r="r" b="b"/>
             <a:pathLst>
-              <a:path extrusionOk="0" h="120000" w="120000">
+              <a:path w="120000" h="120000" extrusionOk="0">
                 <a:moveTo>
                   <a:pt x="0" y="0"/>
                 </a:moveTo>
@@ -908,23 +929,25 @@
             </a:pathLst>
           </a:custGeom>
           <a:noFill/>
-          <a:ln cap="flat" cmpd="sng" w="9525">
+          <a:ln w="9525" cap="flat" cmpd="sng">
             <a:solidFill>
               <a:srgbClr val="000000"/>
             </a:solidFill>
             <a:prstDash val="solid"/>
             <a:round/>
-            <a:headEnd len="sm" w="sm" type="none"/>
-            <a:tailEnd len="sm" w="sm" type="none"/>
+            <a:headEnd type="none" w="sm" len="sm"/>
+            <a:tailEnd type="none" w="sm" len="sm"/>
           </a:ln>
         </p:spPr>
       </p:sp>
       <p:sp>
         <p:nvSpPr>
           <p:cNvPr id="32" name="Google Shape;32;p1:notes"/>
-          <p:cNvSpPr txBox="1"/>
+          <p:cNvSpPr txBox="1">
+            <a:spLocks noGrp="1"/>
+          </p:cNvSpPr>
           <p:nvPr>
-            <p:ph idx="1" type="body"/>
+            <p:ph type="body" idx="1"/>
           </p:nvPr>
         </p:nvSpPr>
         <p:spPr>
@@ -941,12 +964,12 @@
           </a:ln>
         </p:spPr>
         <p:txBody>
-          <a:bodyPr anchorCtr="0" anchor="t" bIns="91425" lIns="91425" spcFirstLastPara="1" rIns="91425" wrap="square" tIns="91425">
+          <a:bodyPr spcFirstLastPara="1" wrap="square" lIns="91425" tIns="91425" rIns="91425" bIns="91425" anchor="t" anchorCtr="0">
             <a:noAutofit/>
           </a:bodyPr>
           <a:lstStyle/>
           <a:p>
-            <a:pPr indent="0" lvl="0" marL="0" rtl="0" algn="l">
+            <a:pPr marL="0" lvl="0" indent="0" algn="l" rtl="0">
               <a:lnSpc>
                 <a:spcPct val="100000"/>
               </a:lnSpc>
@@ -959,9 +982,6 @@
               <a:buSzPts val="1100"/>
               <a:buNone/>
             </a:pPr>
-            <a:r>
-              <a:t/>
-            </a:r>
             <a:endParaRPr/>
           </a:p>
         </p:txBody>
@@ -975,11 +995,11 @@
 </file>
 
 <file path=ppt/notesSlides/notesSlide2.xml><?xml version="1.0" encoding="utf-8"?>
-<p:notes xmlns:a="http://schemas.openxmlformats.org/drawingml/2006/main" xmlns:r="http://schemas.openxmlformats.org/officeDocument/2006/relationships" xmlns:mc="http://schemas.openxmlformats.org/markup-compatibility/2006" xmlns:mv="urn:schemas-microsoft-com:mac:vml" xmlns:p="http://schemas.openxmlformats.org/presentationml/2006/main" xmlns:c="http://schemas.openxmlformats.org/drawingml/2006/chart" xmlns:dgm="http://schemas.openxmlformats.org/drawingml/2006/diagram" xmlns:o="urn:schemas-microsoft-com:office:office" xmlns:v="urn:schemas-microsoft-com:vml" xmlns:pvml="urn:schemas-microsoft-com:office:powerpoint" xmlns:com="http://schemas.openxmlformats.org/drawingml/2006/compatibility" xmlns:p14="http://schemas.microsoft.com/office/powerpoint/2010/main" xmlns:p15="http://schemas.microsoft.com/office/powerpoint/2012/main" xmlns:ahyp="http://schemas.microsoft.com/office/drawing/2018/hyperlinkcolor" showMasterPhAnim="0" showMasterSp="0">
+<p:notes xmlns:a="http://schemas.openxmlformats.org/drawingml/2006/main" xmlns:r="http://schemas.openxmlformats.org/officeDocument/2006/relationships" xmlns:p="http://schemas.openxmlformats.org/presentationml/2006/main" showMasterSp="0" showMasterPhAnim="0">
   <p:cSld>
     <p:spTree>
       <p:nvGrpSpPr>
-        <p:cNvPr id="37" name="Shape 37"/>
+        <p:cNvPr id="1" name="Shape 37"/>
         <p:cNvGrpSpPr/>
         <p:nvPr/>
       </p:nvGrpSpPr>
@@ -994,9 +1014,11 @@
       <p:sp>
         <p:nvSpPr>
           <p:cNvPr id="38" name="Google Shape;38;p2:notes"/>
-          <p:cNvSpPr txBox="1"/>
+          <p:cNvSpPr txBox="1">
+            <a:spLocks noGrp="1"/>
+          </p:cNvSpPr>
           <p:nvPr>
-            <p:ph idx="1" type="body"/>
+            <p:ph type="body" idx="1"/>
           </p:nvPr>
         </p:nvSpPr>
         <p:spPr>
@@ -1013,12 +1035,12 @@
           </a:ln>
         </p:spPr>
         <p:txBody>
-          <a:bodyPr anchorCtr="0" anchor="t" bIns="91425" lIns="91425" spcFirstLastPara="1" rIns="91425" wrap="square" tIns="91425">
+          <a:bodyPr spcFirstLastPara="1" wrap="square" lIns="91425" tIns="91425" rIns="91425" bIns="91425" anchor="t" anchorCtr="0">
             <a:noAutofit/>
           </a:bodyPr>
           <a:lstStyle/>
           <a:p>
-            <a:pPr indent="0" lvl="0" marL="0" rtl="0" algn="l">
+            <a:pPr marL="0" lvl="0" indent="0" algn="l" rtl="0">
               <a:lnSpc>
                 <a:spcPct val="100000"/>
               </a:lnSpc>
@@ -1031,9 +1053,6 @@
               <a:buSzPts val="1100"/>
               <a:buNone/>
             </a:pPr>
-            <a:r>
-              <a:t/>
-            </a:r>
             <a:endParaRPr/>
           </a:p>
         </p:txBody>
@@ -1041,20 +1060,26 @@
       <p:sp>
         <p:nvSpPr>
           <p:cNvPr id="39" name="Google Shape;39;p2:notes"/>
-          <p:cNvSpPr/>
+          <p:cNvSpPr>
+            <a:spLocks noGrp="1" noRot="1" noChangeAspect="1"/>
+          </p:cNvSpPr>
           <p:nvPr>
-            <p:ph idx="2" type="sldImg"/>
+            <p:ph type="sldImg" idx="2"/>
           </p:nvPr>
         </p:nvSpPr>
         <p:spPr>
           <a:xfrm>
-            <a:off x="1143000" y="685800"/>
-            <a:ext cx="4572000" cy="3429000"/>
+            <a:off x="381000" y="685800"/>
+            <a:ext cx="6096000" cy="3429000"/>
           </a:xfrm>
           <a:custGeom>
-            <a:rect b="b" l="l" r="r" t="t"/>
+            <a:avLst/>
+            <a:gdLst/>
+            <a:ahLst/>
+            <a:cxnLst/>
+            <a:rect l="l" t="t" r="r" b="b"/>
             <a:pathLst>
-              <a:path extrusionOk="0" h="120000" w="120000">
+              <a:path w="120000" h="120000" extrusionOk="0">
                 <a:moveTo>
                   <a:pt x="0" y="0"/>
                 </a:moveTo>
@@ -1072,14 +1097,14 @@
             </a:pathLst>
           </a:custGeom>
           <a:noFill/>
-          <a:ln cap="flat" cmpd="sng" w="9525">
+          <a:ln w="9525" cap="flat" cmpd="sng">
             <a:solidFill>
               <a:srgbClr val="000000"/>
             </a:solidFill>
             <a:prstDash val="solid"/>
             <a:round/>
-            <a:headEnd len="sm" w="sm" type="none"/>
-            <a:tailEnd len="sm" w="sm" type="none"/>
+            <a:headEnd type="none" w="sm" len="sm"/>
+            <a:tailEnd type="none" w="sm" len="sm"/>
           </a:ln>
         </p:spPr>
       </p:sp>
@@ -1092,11 +1117,11 @@
 </file>
 
 <file path=ppt/notesSlides/notesSlide3.xml><?xml version="1.0" encoding="utf-8"?>
-<p:notes xmlns:a="http://schemas.openxmlformats.org/drawingml/2006/main" xmlns:r="http://schemas.openxmlformats.org/officeDocument/2006/relationships" xmlns:mc="http://schemas.openxmlformats.org/markup-compatibility/2006" xmlns:mv="urn:schemas-microsoft-com:mac:vml" xmlns:p="http://schemas.openxmlformats.org/presentationml/2006/main" xmlns:c="http://schemas.openxmlformats.org/drawingml/2006/chart" xmlns:dgm="http://schemas.openxmlformats.org/drawingml/2006/diagram" xmlns:o="urn:schemas-microsoft-com:office:office" xmlns:v="urn:schemas-microsoft-com:vml" xmlns:pvml="urn:schemas-microsoft-com:office:powerpoint" xmlns:com="http://schemas.openxmlformats.org/drawingml/2006/compatibility" xmlns:p14="http://schemas.microsoft.com/office/powerpoint/2010/main" xmlns:p15="http://schemas.microsoft.com/office/powerpoint/2012/main" xmlns:ahyp="http://schemas.microsoft.com/office/drawing/2018/hyperlinkcolor" showMasterPhAnim="0" showMasterSp="0">
+<p:notes xmlns:a="http://schemas.openxmlformats.org/drawingml/2006/main" xmlns:r="http://schemas.openxmlformats.org/officeDocument/2006/relationships" xmlns:p="http://schemas.openxmlformats.org/presentationml/2006/main" showMasterSp="0" showMasterPhAnim="0">
   <p:cSld>
     <p:spTree>
       <p:nvGrpSpPr>
-        <p:cNvPr id="46" name="Shape 46"/>
+        <p:cNvPr id="1" name="Shape 46"/>
         <p:cNvGrpSpPr/>
         <p:nvPr/>
       </p:nvGrpSpPr>
@@ -1111,9 +1136,11 @@
       <p:sp>
         <p:nvSpPr>
           <p:cNvPr id="47" name="Google Shape;47;p3:notes"/>
-          <p:cNvSpPr txBox="1"/>
+          <p:cNvSpPr txBox="1">
+            <a:spLocks noGrp="1"/>
+          </p:cNvSpPr>
           <p:nvPr>
-            <p:ph idx="1" type="body"/>
+            <p:ph type="body" idx="1"/>
           </p:nvPr>
         </p:nvSpPr>
         <p:spPr>
@@ -1130,12 +1157,12 @@
           </a:ln>
         </p:spPr>
         <p:txBody>
-          <a:bodyPr anchorCtr="0" anchor="t" bIns="91425" lIns="91425" spcFirstLastPara="1" rIns="91425" wrap="square" tIns="91425">
+          <a:bodyPr spcFirstLastPara="1" wrap="square" lIns="91425" tIns="91425" rIns="91425" bIns="91425" anchor="t" anchorCtr="0">
             <a:noAutofit/>
           </a:bodyPr>
           <a:lstStyle/>
           <a:p>
-            <a:pPr indent="0" lvl="0" marL="0" rtl="0" algn="l">
+            <a:pPr marL="0" lvl="0" indent="0" algn="l" rtl="0">
               <a:lnSpc>
                 <a:spcPct val="100000"/>
               </a:lnSpc>
@@ -1148,9 +1175,6 @@
               <a:buSzPts val="1100"/>
               <a:buNone/>
             </a:pPr>
-            <a:r>
-              <a:t/>
-            </a:r>
             <a:endParaRPr/>
           </a:p>
         </p:txBody>
@@ -1158,9 +1182,11 @@
       <p:sp>
         <p:nvSpPr>
           <p:cNvPr id="48" name="Google Shape;48;p3:notes"/>
-          <p:cNvSpPr/>
+          <p:cNvSpPr>
+            <a:spLocks noGrp="1" noRot="1" noChangeAspect="1"/>
+          </p:cNvSpPr>
           <p:nvPr>
-            <p:ph idx="2" type="sldImg"/>
+            <p:ph type="sldImg" idx="2"/>
           </p:nvPr>
         </p:nvSpPr>
         <p:spPr>
@@ -1169,9 +1195,13 @@
             <a:ext cx="4572000" cy="3429000"/>
           </a:xfrm>
           <a:custGeom>
-            <a:rect b="b" l="l" r="r" t="t"/>
+            <a:avLst/>
+            <a:gdLst/>
+            <a:ahLst/>
+            <a:cxnLst/>
+            <a:rect l="l" t="t" r="r" b="b"/>
             <a:pathLst>
-              <a:path extrusionOk="0" h="120000" w="120000">
+              <a:path w="120000" h="120000" extrusionOk="0">
                 <a:moveTo>
                   <a:pt x="0" y="0"/>
                 </a:moveTo>
@@ -1189,14 +1219,14 @@
             </a:pathLst>
           </a:custGeom>
           <a:noFill/>
-          <a:ln cap="flat" cmpd="sng" w="9525">
+          <a:ln w="9525" cap="flat" cmpd="sng">
             <a:solidFill>
               <a:srgbClr val="000000"/>
             </a:solidFill>
             <a:prstDash val="solid"/>
             <a:round/>
-            <a:headEnd len="sm" w="sm" type="none"/>
-            <a:tailEnd len="sm" w="sm" type="none"/>
+            <a:headEnd type="none" w="sm" len="sm"/>
+            <a:tailEnd type="none" w="sm" len="sm"/>
           </a:ln>
         </p:spPr>
       </p:sp>
@@ -1209,11 +1239,11 @@
 </file>
 
 <file path=ppt/notesSlides/notesSlide4.xml><?xml version="1.0" encoding="utf-8"?>
-<p:notes xmlns:a="http://schemas.openxmlformats.org/drawingml/2006/main" xmlns:r="http://schemas.openxmlformats.org/officeDocument/2006/relationships" xmlns:mc="http://schemas.openxmlformats.org/markup-compatibility/2006" xmlns:mv="urn:schemas-microsoft-com:mac:vml" xmlns:p="http://schemas.openxmlformats.org/presentationml/2006/main" xmlns:c="http://schemas.openxmlformats.org/drawingml/2006/chart" xmlns:dgm="http://schemas.openxmlformats.org/drawingml/2006/diagram" xmlns:o="urn:schemas-microsoft-com:office:office" xmlns:v="urn:schemas-microsoft-com:vml" xmlns:pvml="urn:schemas-microsoft-com:office:powerpoint" xmlns:com="http://schemas.openxmlformats.org/drawingml/2006/compatibility" xmlns:p14="http://schemas.microsoft.com/office/powerpoint/2010/main" xmlns:p15="http://schemas.microsoft.com/office/powerpoint/2012/main" xmlns:ahyp="http://schemas.microsoft.com/office/drawing/2018/hyperlinkcolor" showMasterPhAnim="0" showMasterSp="0">
+<p:notes xmlns:a="http://schemas.openxmlformats.org/drawingml/2006/main" xmlns:r="http://schemas.openxmlformats.org/officeDocument/2006/relationships" xmlns:p="http://schemas.openxmlformats.org/presentationml/2006/main" showMasterSp="0" showMasterPhAnim="0">
   <p:cSld>
     <p:spTree>
       <p:nvGrpSpPr>
-        <p:cNvPr id="54" name="Shape 54"/>
+        <p:cNvPr id="1" name="Shape 54"/>
         <p:cNvGrpSpPr/>
         <p:nvPr/>
       </p:nvGrpSpPr>
@@ -1228,9 +1258,11 @@
       <p:sp>
         <p:nvSpPr>
           <p:cNvPr id="55" name="Google Shape;55;p4:notes"/>
-          <p:cNvSpPr txBox="1"/>
+          <p:cNvSpPr txBox="1">
+            <a:spLocks noGrp="1"/>
+          </p:cNvSpPr>
           <p:nvPr>
-            <p:ph idx="1" type="body"/>
+            <p:ph type="body" idx="1"/>
           </p:nvPr>
         </p:nvSpPr>
         <p:spPr>
@@ -1247,12 +1279,12 @@
           </a:ln>
         </p:spPr>
         <p:txBody>
-          <a:bodyPr anchorCtr="0" anchor="t" bIns="91425" lIns="91425" spcFirstLastPara="1" rIns="91425" wrap="square" tIns="91425">
+          <a:bodyPr spcFirstLastPara="1" wrap="square" lIns="91425" tIns="91425" rIns="91425" bIns="91425" anchor="t" anchorCtr="0">
             <a:noAutofit/>
           </a:bodyPr>
           <a:lstStyle/>
           <a:p>
-            <a:pPr indent="0" lvl="0" marL="0" rtl="0" algn="l">
+            <a:pPr marL="0" lvl="0" indent="0" algn="l" rtl="0">
               <a:lnSpc>
                 <a:spcPct val="100000"/>
               </a:lnSpc>
@@ -1265,9 +1297,6 @@
               <a:buSzPts val="1100"/>
               <a:buNone/>
             </a:pPr>
-            <a:r>
-              <a:t/>
-            </a:r>
             <a:endParaRPr/>
           </a:p>
         </p:txBody>
@@ -1275,9 +1304,11 @@
       <p:sp>
         <p:nvSpPr>
           <p:cNvPr id="56" name="Google Shape;56;p4:notes"/>
-          <p:cNvSpPr/>
+          <p:cNvSpPr>
+            <a:spLocks noGrp="1" noRot="1" noChangeAspect="1"/>
+          </p:cNvSpPr>
           <p:nvPr>
-            <p:ph idx="2" type="sldImg"/>
+            <p:ph type="sldImg" idx="2"/>
           </p:nvPr>
         </p:nvSpPr>
         <p:spPr>
@@ -1286,9 +1317,13 @@
             <a:ext cx="4572000" cy="3429000"/>
           </a:xfrm>
           <a:custGeom>
-            <a:rect b="b" l="l" r="r" t="t"/>
+            <a:avLst/>
+            <a:gdLst/>
+            <a:ahLst/>
+            <a:cxnLst/>
+            <a:rect l="l" t="t" r="r" b="b"/>
             <a:pathLst>
-              <a:path extrusionOk="0" h="120000" w="120000">
+              <a:path w="120000" h="120000" extrusionOk="0">
                 <a:moveTo>
                   <a:pt x="0" y="0"/>
                 </a:moveTo>
@@ -1306,14 +1341,14 @@
             </a:pathLst>
           </a:custGeom>
           <a:noFill/>
-          <a:ln cap="flat" cmpd="sng" w="9525">
+          <a:ln w="9525" cap="flat" cmpd="sng">
             <a:solidFill>
               <a:srgbClr val="000000"/>
             </a:solidFill>
             <a:prstDash val="solid"/>
             <a:round/>
-            <a:headEnd len="sm" w="sm" type="none"/>
-            <a:tailEnd len="sm" w="sm" type="none"/>
+            <a:headEnd type="none" w="sm" len="sm"/>
+            <a:tailEnd type="none" w="sm" len="sm"/>
           </a:ln>
         </p:spPr>
       </p:sp>
@@ -1326,11 +1361,11 @@
 </file>
 
 <file path=ppt/notesSlides/notesSlide5.xml><?xml version="1.0" encoding="utf-8"?>
-<p:notes xmlns:a="http://schemas.openxmlformats.org/drawingml/2006/main" xmlns:r="http://schemas.openxmlformats.org/officeDocument/2006/relationships" xmlns:mc="http://schemas.openxmlformats.org/markup-compatibility/2006" xmlns:mv="urn:schemas-microsoft-com:mac:vml" xmlns:p="http://schemas.openxmlformats.org/presentationml/2006/main" xmlns:c="http://schemas.openxmlformats.org/drawingml/2006/chart" xmlns:dgm="http://schemas.openxmlformats.org/drawingml/2006/diagram" xmlns:o="urn:schemas-microsoft-com:office:office" xmlns:v="urn:schemas-microsoft-com:vml" xmlns:pvml="urn:schemas-microsoft-com:office:powerpoint" xmlns:com="http://schemas.openxmlformats.org/drawingml/2006/compatibility" xmlns:p14="http://schemas.microsoft.com/office/powerpoint/2010/main" xmlns:p15="http://schemas.microsoft.com/office/powerpoint/2012/main" xmlns:ahyp="http://schemas.microsoft.com/office/drawing/2018/hyperlinkcolor" showMasterPhAnim="0" showMasterSp="0">
+<p:notes xmlns:a="http://schemas.openxmlformats.org/drawingml/2006/main" xmlns:r="http://schemas.openxmlformats.org/officeDocument/2006/relationships" xmlns:p="http://schemas.openxmlformats.org/presentationml/2006/main" showMasterSp="0" showMasterPhAnim="0">
   <p:cSld>
     <p:spTree>
       <p:nvGrpSpPr>
-        <p:cNvPr id="62" name="Shape 62"/>
+        <p:cNvPr id="1" name="Shape 62"/>
         <p:cNvGrpSpPr/>
         <p:nvPr/>
       </p:nvGrpSpPr>
@@ -1345,9 +1380,11 @@
       <p:sp>
         <p:nvSpPr>
           <p:cNvPr id="63" name="Google Shape;63;p5:notes"/>
-          <p:cNvSpPr txBox="1"/>
+          <p:cNvSpPr txBox="1">
+            <a:spLocks noGrp="1"/>
+          </p:cNvSpPr>
           <p:nvPr>
-            <p:ph idx="1" type="body"/>
+            <p:ph type="body" idx="1"/>
           </p:nvPr>
         </p:nvSpPr>
         <p:spPr>
@@ -1364,12 +1401,12 @@
           </a:ln>
         </p:spPr>
         <p:txBody>
-          <a:bodyPr anchorCtr="0" anchor="t" bIns="91425" lIns="91425" spcFirstLastPara="1" rIns="91425" wrap="square" tIns="91425">
+          <a:bodyPr spcFirstLastPara="1" wrap="square" lIns="91425" tIns="91425" rIns="91425" bIns="91425" anchor="t" anchorCtr="0">
             <a:noAutofit/>
           </a:bodyPr>
           <a:lstStyle/>
           <a:p>
-            <a:pPr indent="0" lvl="0" marL="0" rtl="0" algn="l">
+            <a:pPr marL="0" lvl="0" indent="0" algn="l" rtl="0">
               <a:lnSpc>
                 <a:spcPct val="100000"/>
               </a:lnSpc>
@@ -1382,9 +1419,6 @@
               <a:buSzPts val="1100"/>
               <a:buNone/>
             </a:pPr>
-            <a:r>
-              <a:t/>
-            </a:r>
             <a:endParaRPr/>
           </a:p>
         </p:txBody>
@@ -1392,9 +1426,11 @@
       <p:sp>
         <p:nvSpPr>
           <p:cNvPr id="64" name="Google Shape;64;p5:notes"/>
-          <p:cNvSpPr/>
+          <p:cNvSpPr>
+            <a:spLocks noGrp="1" noRot="1" noChangeAspect="1"/>
+          </p:cNvSpPr>
           <p:nvPr>
-            <p:ph idx="2" type="sldImg"/>
+            <p:ph type="sldImg" idx="2"/>
           </p:nvPr>
         </p:nvSpPr>
         <p:spPr>
@@ -1403,9 +1439,13 @@
             <a:ext cx="4572000" cy="3429000"/>
           </a:xfrm>
           <a:custGeom>
-            <a:rect b="b" l="l" r="r" t="t"/>
+            <a:avLst/>
+            <a:gdLst/>
+            <a:ahLst/>
+            <a:cxnLst/>
+            <a:rect l="l" t="t" r="r" b="b"/>
             <a:pathLst>
-              <a:path extrusionOk="0" h="120000" w="120000">
+              <a:path w="120000" h="120000" extrusionOk="0">
                 <a:moveTo>
                   <a:pt x="0" y="0"/>
                 </a:moveTo>
@@ -1423,14 +1463,14 @@
             </a:pathLst>
           </a:custGeom>
           <a:noFill/>
-          <a:ln cap="flat" cmpd="sng" w="9525">
+          <a:ln w="9525" cap="flat" cmpd="sng">
             <a:solidFill>
               <a:srgbClr val="000000"/>
             </a:solidFill>
             <a:prstDash val="solid"/>
             <a:round/>
-            <a:headEnd len="sm" w="sm" type="none"/>
-            <a:tailEnd len="sm" w="sm" type="none"/>
+            <a:headEnd type="none" w="sm" len="sm"/>
+            <a:tailEnd type="none" w="sm" len="sm"/>
           </a:ln>
         </p:spPr>
       </p:sp>
@@ -1443,11 +1483,11 @@
 </file>
 
 <file path=ppt/notesSlides/notesSlide6.xml><?xml version="1.0" encoding="utf-8"?>
-<p:notes xmlns:a="http://schemas.openxmlformats.org/drawingml/2006/main" xmlns:r="http://schemas.openxmlformats.org/officeDocument/2006/relationships" xmlns:mc="http://schemas.openxmlformats.org/markup-compatibility/2006" xmlns:mv="urn:schemas-microsoft-com:mac:vml" xmlns:p="http://schemas.openxmlformats.org/presentationml/2006/main" xmlns:c="http://schemas.openxmlformats.org/drawingml/2006/chart" xmlns:dgm="http://schemas.openxmlformats.org/drawingml/2006/diagram" xmlns:o="urn:schemas-microsoft-com:office:office" xmlns:v="urn:schemas-microsoft-com:vml" xmlns:pvml="urn:schemas-microsoft-com:office:powerpoint" xmlns:com="http://schemas.openxmlformats.org/drawingml/2006/compatibility" xmlns:p14="http://schemas.microsoft.com/office/powerpoint/2010/main" xmlns:p15="http://schemas.microsoft.com/office/powerpoint/2012/main" xmlns:ahyp="http://schemas.microsoft.com/office/drawing/2018/hyperlinkcolor" showMasterPhAnim="0" showMasterSp="0">
+<p:notes xmlns:a="http://schemas.openxmlformats.org/drawingml/2006/main" xmlns:r="http://schemas.openxmlformats.org/officeDocument/2006/relationships" xmlns:p="http://schemas.openxmlformats.org/presentationml/2006/main" showMasterSp="0" showMasterPhAnim="0">
   <p:cSld>
     <p:spTree>
       <p:nvGrpSpPr>
-        <p:cNvPr id="70" name="Shape 70"/>
+        <p:cNvPr id="1" name="Shape 70"/>
         <p:cNvGrpSpPr/>
         <p:nvPr/>
       </p:nvGrpSpPr>
@@ -1462,9 +1502,11 @@
       <p:sp>
         <p:nvSpPr>
           <p:cNvPr id="71" name="Google Shape;71;p6:notes"/>
-          <p:cNvSpPr txBox="1"/>
+          <p:cNvSpPr txBox="1">
+            <a:spLocks noGrp="1"/>
+          </p:cNvSpPr>
           <p:nvPr>
-            <p:ph idx="1" type="body"/>
+            <p:ph type="body" idx="1"/>
           </p:nvPr>
         </p:nvSpPr>
         <p:spPr>
@@ -1481,12 +1523,12 @@
           </a:ln>
         </p:spPr>
         <p:txBody>
-          <a:bodyPr anchorCtr="0" anchor="t" bIns="91425" lIns="91425" spcFirstLastPara="1" rIns="91425" wrap="square" tIns="91425">
+          <a:bodyPr spcFirstLastPara="1" wrap="square" lIns="91425" tIns="91425" rIns="91425" bIns="91425" anchor="t" anchorCtr="0">
             <a:noAutofit/>
           </a:bodyPr>
           <a:lstStyle/>
           <a:p>
-            <a:pPr indent="0" lvl="0" marL="0" rtl="0" algn="l">
+            <a:pPr marL="0" lvl="0" indent="0" algn="l" rtl="0">
               <a:lnSpc>
                 <a:spcPct val="100000"/>
               </a:lnSpc>
@@ -1499,9 +1541,6 @@
               <a:buSzPts val="1100"/>
               <a:buNone/>
             </a:pPr>
-            <a:r>
-              <a:t/>
-            </a:r>
             <a:endParaRPr/>
           </a:p>
         </p:txBody>
@@ -1509,9 +1548,11 @@
       <p:sp>
         <p:nvSpPr>
           <p:cNvPr id="72" name="Google Shape;72;p6:notes"/>
-          <p:cNvSpPr/>
+          <p:cNvSpPr>
+            <a:spLocks noGrp="1" noRot="1" noChangeAspect="1"/>
+          </p:cNvSpPr>
           <p:nvPr>
-            <p:ph idx="2" type="sldImg"/>
+            <p:ph type="sldImg" idx="2"/>
           </p:nvPr>
         </p:nvSpPr>
         <p:spPr>
@@ -1520,9 +1561,13 @@
             <a:ext cx="4572000" cy="3429000"/>
           </a:xfrm>
           <a:custGeom>
-            <a:rect b="b" l="l" r="r" t="t"/>
+            <a:avLst/>
+            <a:gdLst/>
+            <a:ahLst/>
+            <a:cxnLst/>
+            <a:rect l="l" t="t" r="r" b="b"/>
             <a:pathLst>
-              <a:path extrusionOk="0" h="120000" w="120000">
+              <a:path w="120000" h="120000" extrusionOk="0">
                 <a:moveTo>
                   <a:pt x="0" y="0"/>
                 </a:moveTo>
@@ -1540,14 +1585,14 @@
             </a:pathLst>
           </a:custGeom>
           <a:noFill/>
-          <a:ln cap="flat" cmpd="sng" w="9525">
+          <a:ln w="9525" cap="flat" cmpd="sng">
             <a:solidFill>
               <a:srgbClr val="000000"/>
             </a:solidFill>
             <a:prstDash val="solid"/>
             <a:round/>
-            <a:headEnd len="sm" w="sm" type="none"/>
-            <a:tailEnd len="sm" w="sm" type="none"/>
+            <a:headEnd type="none" w="sm" len="sm"/>
+            <a:tailEnd type="none" w="sm" len="sm"/>
           </a:ln>
         </p:spPr>
       </p:sp>
@@ -1560,11 +1605,11 @@
 </file>
 
 <file path=ppt/notesSlides/notesSlide7.xml><?xml version="1.0" encoding="utf-8"?>
-<p:notes xmlns:a="http://schemas.openxmlformats.org/drawingml/2006/main" xmlns:r="http://schemas.openxmlformats.org/officeDocument/2006/relationships" xmlns:mc="http://schemas.openxmlformats.org/markup-compatibility/2006" xmlns:mv="urn:schemas-microsoft-com:mac:vml" xmlns:p="http://schemas.openxmlformats.org/presentationml/2006/main" xmlns:c="http://schemas.openxmlformats.org/drawingml/2006/chart" xmlns:dgm="http://schemas.openxmlformats.org/drawingml/2006/diagram" xmlns:o="urn:schemas-microsoft-com:office:office" xmlns:v="urn:schemas-microsoft-com:vml" xmlns:pvml="urn:schemas-microsoft-com:office:powerpoint" xmlns:com="http://schemas.openxmlformats.org/drawingml/2006/compatibility" xmlns:p14="http://schemas.microsoft.com/office/powerpoint/2010/main" xmlns:p15="http://schemas.microsoft.com/office/powerpoint/2012/main" xmlns:ahyp="http://schemas.microsoft.com/office/drawing/2018/hyperlinkcolor" showMasterPhAnim="0" showMasterSp="0">
+<p:notes xmlns:a="http://schemas.openxmlformats.org/drawingml/2006/main" xmlns:r="http://schemas.openxmlformats.org/officeDocument/2006/relationships" xmlns:p="http://schemas.openxmlformats.org/presentationml/2006/main" showMasterSp="0" showMasterPhAnim="0">
   <p:cSld>
     <p:spTree>
       <p:nvGrpSpPr>
-        <p:cNvPr id="78" name="Shape 78"/>
+        <p:cNvPr id="1" name="Shape 78"/>
         <p:cNvGrpSpPr/>
         <p:nvPr/>
       </p:nvGrpSpPr>
@@ -1579,9 +1624,11 @@
       <p:sp>
         <p:nvSpPr>
           <p:cNvPr id="79" name="Google Shape;79;p7:notes"/>
-          <p:cNvSpPr txBox="1"/>
+          <p:cNvSpPr txBox="1">
+            <a:spLocks noGrp="1"/>
+          </p:cNvSpPr>
           <p:nvPr>
-            <p:ph idx="1" type="body"/>
+            <p:ph type="body" idx="1"/>
           </p:nvPr>
         </p:nvSpPr>
         <p:spPr>
@@ -1598,12 +1645,12 @@
           </a:ln>
         </p:spPr>
         <p:txBody>
-          <a:bodyPr anchorCtr="0" anchor="t" bIns="91425" lIns="91425" spcFirstLastPara="1" rIns="91425" wrap="square" tIns="91425">
+          <a:bodyPr spcFirstLastPara="1" wrap="square" lIns="91425" tIns="91425" rIns="91425" bIns="91425" anchor="t" anchorCtr="0">
             <a:noAutofit/>
           </a:bodyPr>
           <a:lstStyle/>
           <a:p>
-            <a:pPr indent="0" lvl="0" marL="0" rtl="0" algn="l">
+            <a:pPr marL="0" lvl="0" indent="0" algn="l" rtl="0">
               <a:lnSpc>
                 <a:spcPct val="100000"/>
               </a:lnSpc>
@@ -1616,9 +1663,6 @@
               <a:buSzPts val="1100"/>
               <a:buNone/>
             </a:pPr>
-            <a:r>
-              <a:t/>
-            </a:r>
             <a:endParaRPr/>
           </a:p>
         </p:txBody>
@@ -1626,9 +1670,11 @@
       <p:sp>
         <p:nvSpPr>
           <p:cNvPr id="80" name="Google Shape;80;p7:notes"/>
-          <p:cNvSpPr/>
+          <p:cNvSpPr>
+            <a:spLocks noGrp="1" noRot="1" noChangeAspect="1"/>
+          </p:cNvSpPr>
           <p:nvPr>
-            <p:ph idx="2" type="sldImg"/>
+            <p:ph type="sldImg" idx="2"/>
           </p:nvPr>
         </p:nvSpPr>
         <p:spPr>
@@ -1637,9 +1683,13 @@
             <a:ext cx="4572000" cy="3429000"/>
           </a:xfrm>
           <a:custGeom>
-            <a:rect b="b" l="l" r="r" t="t"/>
+            <a:avLst/>
+            <a:gdLst/>
+            <a:ahLst/>
+            <a:cxnLst/>
+            <a:rect l="l" t="t" r="r" b="b"/>
             <a:pathLst>
-              <a:path extrusionOk="0" h="120000" w="120000">
+              <a:path w="120000" h="120000" extrusionOk="0">
                 <a:moveTo>
                   <a:pt x="0" y="0"/>
                 </a:moveTo>
@@ -1657,14 +1707,14 @@
             </a:pathLst>
           </a:custGeom>
           <a:noFill/>
-          <a:ln cap="flat" cmpd="sng" w="9525">
+          <a:ln w="9525" cap="flat" cmpd="sng">
             <a:solidFill>
               <a:srgbClr val="000000"/>
             </a:solidFill>
             <a:prstDash val="solid"/>
             <a:round/>
-            <a:headEnd len="sm" w="sm" type="none"/>
-            <a:tailEnd len="sm" w="sm" type="none"/>
+            <a:headEnd type="none" w="sm" len="sm"/>
+            <a:tailEnd type="none" w="sm" len="sm"/>
           </a:ln>
         </p:spPr>
       </p:sp>
@@ -1677,11 +1727,11 @@
 </file>
 
 <file path=ppt/slideLayouts/slideLayout1.xml><?xml version="1.0" encoding="utf-8"?>
-<p:sldLayout xmlns:a="http://schemas.openxmlformats.org/drawingml/2006/main" xmlns:r="http://schemas.openxmlformats.org/officeDocument/2006/relationships" xmlns:mc="http://schemas.openxmlformats.org/markup-compatibility/2006" xmlns:mv="urn:schemas-microsoft-com:mac:vml" xmlns:p="http://schemas.openxmlformats.org/presentationml/2006/main" xmlns:c="http://schemas.openxmlformats.org/drawingml/2006/chart" xmlns:dgm="http://schemas.openxmlformats.org/drawingml/2006/diagram" xmlns:o="urn:schemas-microsoft-com:office:office" xmlns:v="urn:schemas-microsoft-com:vml" xmlns:pvml="urn:schemas-microsoft-com:office:powerpoint" xmlns:com="http://schemas.openxmlformats.org/drawingml/2006/compatibility" xmlns:p14="http://schemas.microsoft.com/office/powerpoint/2010/main" xmlns:p15="http://schemas.microsoft.com/office/powerpoint/2012/main" xmlns:ahyp="http://schemas.microsoft.com/office/drawing/2018/hyperlinkcolor" matchingName="Title slide dark (phone)" type="tx">
+<p:sldLayout xmlns:a="http://schemas.openxmlformats.org/drawingml/2006/main" xmlns:r="http://schemas.openxmlformats.org/officeDocument/2006/relationships" xmlns:p="http://schemas.openxmlformats.org/presentationml/2006/main" matchingName="Title slide dark (phone)" type="tx">
   <p:cSld name="TITLE_AND_BODY">
     <p:spTree>
       <p:nvGrpSpPr>
-        <p:cNvPr id="9" name="Shape 9"/>
+        <p:cNvPr id="1" name="Shape 9"/>
         <p:cNvGrpSpPr/>
         <p:nvPr/>
       </p:nvGrpSpPr>
@@ -1703,7 +1753,7 @@
           <a:blip r:embed="rId2">
             <a:alphaModFix/>
           </a:blip>
-          <a:srcRect b="0" l="0" r="0" t="0"/>
+          <a:srcRect/>
           <a:stretch/>
         </p:blipFill>
         <p:spPr>
@@ -1723,9 +1773,11 @@
       <p:sp>
         <p:nvSpPr>
           <p:cNvPr id="11" name="Google Shape;11;p2"/>
-          <p:cNvSpPr txBox="1"/>
+          <p:cNvSpPr txBox="1">
+            <a:spLocks noGrp="1"/>
+          </p:cNvSpPr>
           <p:nvPr>
-            <p:ph idx="12" type="sldNum"/>
+            <p:ph type="sldNum" idx="12"/>
           </p:nvPr>
         </p:nvSpPr>
         <p:spPr>
@@ -1742,11 +1794,11 @@
           </a:ln>
         </p:spPr>
         <p:txBody>
-          <a:bodyPr anchorCtr="0" anchor="ctr" bIns="91425" lIns="91425" spcFirstLastPara="1" rIns="91425" wrap="square" tIns="91425">
+          <a:bodyPr spcFirstLastPara="1" wrap="square" lIns="91425" tIns="91425" rIns="91425" bIns="91425" anchor="ctr" anchorCtr="0">
             <a:normAutofit/>
           </a:bodyPr>
           <a:lstStyle>
-            <a:lvl1pPr indent="0" lvl="0" marL="0" marR="0" algn="r">
+            <a:lvl1pPr marL="0" marR="0" lvl="0" indent="0" algn="r">
               <a:lnSpc>
                 <a:spcPct val="100000"/>
               </a:lnSpc>
@@ -1762,7 +1814,7 @@
               <a:buSzPts val="1000"/>
               <a:buFont typeface="Arial"/>
               <a:buNone/>
-              <a:defRPr b="0" i="0" sz="1000" u="none" cap="none" strike="noStrike">
+              <a:defRPr sz="1000" b="0" i="0" u="none" strike="noStrike" cap="none">
                 <a:solidFill>
                   <a:schemeClr val="dk2"/>
                 </a:solidFill>
@@ -1772,7 +1824,7 @@
                 <a:sym typeface="Arial"/>
               </a:defRPr>
             </a:lvl1pPr>
-            <a:lvl2pPr indent="0" lvl="1" marL="0" marR="0" algn="r">
+            <a:lvl2pPr marL="0" marR="0" lvl="1" indent="0" algn="r">
               <a:lnSpc>
                 <a:spcPct val="100000"/>
               </a:lnSpc>
@@ -1788,7 +1840,7 @@
               <a:buSzPts val="1000"/>
               <a:buFont typeface="Arial"/>
               <a:buNone/>
-              <a:defRPr b="0" i="0" sz="1000" u="none" cap="none" strike="noStrike">
+              <a:defRPr sz="1000" b="0" i="0" u="none" strike="noStrike" cap="none">
                 <a:solidFill>
                   <a:schemeClr val="dk2"/>
                 </a:solidFill>
@@ -1798,7 +1850,7 @@
                 <a:sym typeface="Arial"/>
               </a:defRPr>
             </a:lvl2pPr>
-            <a:lvl3pPr indent="0" lvl="2" marL="0" marR="0" algn="r">
+            <a:lvl3pPr marL="0" marR="0" lvl="2" indent="0" algn="r">
               <a:lnSpc>
                 <a:spcPct val="100000"/>
               </a:lnSpc>
@@ -1814,7 +1866,7 @@
               <a:buSzPts val="1000"/>
               <a:buFont typeface="Arial"/>
               <a:buNone/>
-              <a:defRPr b="0" i="0" sz="1000" u="none" cap="none" strike="noStrike">
+              <a:defRPr sz="1000" b="0" i="0" u="none" strike="noStrike" cap="none">
                 <a:solidFill>
                   <a:schemeClr val="dk2"/>
                 </a:solidFill>
@@ -1824,7 +1876,7 @@
                 <a:sym typeface="Arial"/>
               </a:defRPr>
             </a:lvl3pPr>
-            <a:lvl4pPr indent="0" lvl="3" marL="0" marR="0" algn="r">
+            <a:lvl4pPr marL="0" marR="0" lvl="3" indent="0" algn="r">
               <a:lnSpc>
                 <a:spcPct val="100000"/>
               </a:lnSpc>
@@ -1840,7 +1892,7 @@
               <a:buSzPts val="1000"/>
               <a:buFont typeface="Arial"/>
               <a:buNone/>
-              <a:defRPr b="0" i="0" sz="1000" u="none" cap="none" strike="noStrike">
+              <a:defRPr sz="1000" b="0" i="0" u="none" strike="noStrike" cap="none">
                 <a:solidFill>
                   <a:schemeClr val="dk2"/>
                 </a:solidFill>
@@ -1850,7 +1902,7 @@
                 <a:sym typeface="Arial"/>
               </a:defRPr>
             </a:lvl4pPr>
-            <a:lvl5pPr indent="0" lvl="4" marL="0" marR="0" algn="r">
+            <a:lvl5pPr marL="0" marR="0" lvl="4" indent="0" algn="r">
               <a:lnSpc>
                 <a:spcPct val="100000"/>
               </a:lnSpc>
@@ -1866,7 +1918,7 @@
               <a:buSzPts val="1000"/>
               <a:buFont typeface="Arial"/>
               <a:buNone/>
-              <a:defRPr b="0" i="0" sz="1000" u="none" cap="none" strike="noStrike">
+              <a:defRPr sz="1000" b="0" i="0" u="none" strike="noStrike" cap="none">
                 <a:solidFill>
                   <a:schemeClr val="dk2"/>
                 </a:solidFill>
@@ -1876,7 +1928,7 @@
                 <a:sym typeface="Arial"/>
               </a:defRPr>
             </a:lvl5pPr>
-            <a:lvl6pPr indent="0" lvl="5" marL="0" marR="0" algn="r">
+            <a:lvl6pPr marL="0" marR="0" lvl="5" indent="0" algn="r">
               <a:lnSpc>
                 <a:spcPct val="100000"/>
               </a:lnSpc>
@@ -1892,7 +1944,7 @@
               <a:buSzPts val="1000"/>
               <a:buFont typeface="Arial"/>
               <a:buNone/>
-              <a:defRPr b="0" i="0" sz="1000" u="none" cap="none" strike="noStrike">
+              <a:defRPr sz="1000" b="0" i="0" u="none" strike="noStrike" cap="none">
                 <a:solidFill>
                   <a:schemeClr val="dk2"/>
                 </a:solidFill>
@@ -1902,7 +1954,7 @@
                 <a:sym typeface="Arial"/>
               </a:defRPr>
             </a:lvl6pPr>
-            <a:lvl7pPr indent="0" lvl="6" marL="0" marR="0" algn="r">
+            <a:lvl7pPr marL="0" marR="0" lvl="6" indent="0" algn="r">
               <a:lnSpc>
                 <a:spcPct val="100000"/>
               </a:lnSpc>
@@ -1918,7 +1970,7 @@
               <a:buSzPts val="1000"/>
               <a:buFont typeface="Arial"/>
               <a:buNone/>
-              <a:defRPr b="0" i="0" sz="1000" u="none" cap="none" strike="noStrike">
+              <a:defRPr sz="1000" b="0" i="0" u="none" strike="noStrike" cap="none">
                 <a:solidFill>
                   <a:schemeClr val="dk2"/>
                 </a:solidFill>
@@ -1928,7 +1980,7 @@
                 <a:sym typeface="Arial"/>
               </a:defRPr>
             </a:lvl7pPr>
-            <a:lvl8pPr indent="0" lvl="7" marL="0" marR="0" algn="r">
+            <a:lvl8pPr marL="0" marR="0" lvl="7" indent="0" algn="r">
               <a:lnSpc>
                 <a:spcPct val="100000"/>
               </a:lnSpc>
@@ -1944,7 +1996,7 @@
               <a:buSzPts val="1000"/>
               <a:buFont typeface="Arial"/>
               <a:buNone/>
-              <a:defRPr b="0" i="0" sz="1000" u="none" cap="none" strike="noStrike">
+              <a:defRPr sz="1000" b="0" i="0" u="none" strike="noStrike" cap="none">
                 <a:solidFill>
                   <a:schemeClr val="dk2"/>
                 </a:solidFill>
@@ -1954,7 +2006,7 @@
                 <a:sym typeface="Arial"/>
               </a:defRPr>
             </a:lvl8pPr>
-            <a:lvl9pPr indent="0" lvl="8" marL="0" marR="0" algn="r">
+            <a:lvl9pPr marL="0" marR="0" lvl="8" indent="0" algn="r">
               <a:lnSpc>
                 <a:spcPct val="100000"/>
               </a:lnSpc>
@@ -1970,7 +2022,7 @@
               <a:buSzPts val="1000"/>
               <a:buFont typeface="Arial"/>
               <a:buNone/>
-              <a:defRPr b="0" i="0" sz="1000" u="none" cap="none" strike="noStrike">
+              <a:defRPr sz="1000" b="0" i="0" u="none" strike="noStrike" cap="none">
                 <a:solidFill>
                   <a:schemeClr val="dk2"/>
                 </a:solidFill>
@@ -1982,7 +2034,7 @@
             </a:lvl9pPr>
           </a:lstStyle>
           <a:p>
-            <a:pPr indent="0" lvl="0" marL="0" rtl="0" algn="r">
+            <a:pPr marL="0" lvl="0" indent="0" algn="r" rtl="0">
               <a:spcBef>
                 <a:spcPts val="0"/>
               </a:spcBef>
@@ -2009,7 +2061,7 @@
           <a:blip r:embed="rId3">
             <a:alphaModFix/>
           </a:blip>
-          <a:srcRect b="0" l="0" r="0" t="0"/>
+          <a:srcRect/>
           <a:stretch/>
         </p:blipFill>
         <p:spPr>
@@ -2036,7 +2088,7 @@
           <a:blip r:embed="rId4">
             <a:alphaModFix/>
           </a:blip>
-          <a:srcRect b="0" l="0" r="0" t="0"/>
+          <a:srcRect/>
           <a:stretch/>
         </p:blipFill>
         <p:spPr>
@@ -2062,11 +2114,11 @@
 </file>
 
 <file path=ppt/slideLayouts/slideLayout2.xml><?xml version="1.0" encoding="utf-8"?>
-<p:sldLayout xmlns:a="http://schemas.openxmlformats.org/drawingml/2006/main" xmlns:r="http://schemas.openxmlformats.org/officeDocument/2006/relationships" xmlns:mc="http://schemas.openxmlformats.org/markup-compatibility/2006" xmlns:mv="urn:schemas-microsoft-com:mac:vml" xmlns:p="http://schemas.openxmlformats.org/presentationml/2006/main" xmlns:c="http://schemas.openxmlformats.org/drawingml/2006/chart" xmlns:dgm="http://schemas.openxmlformats.org/drawingml/2006/diagram" xmlns:o="urn:schemas-microsoft-com:office:office" xmlns:v="urn:schemas-microsoft-com:vml" xmlns:pvml="urn:schemas-microsoft-com:office:powerpoint" xmlns:com="http://schemas.openxmlformats.org/drawingml/2006/compatibility" xmlns:p14="http://schemas.microsoft.com/office/powerpoint/2010/main" xmlns:p15="http://schemas.microsoft.com/office/powerpoint/2012/main" xmlns:ahyp="http://schemas.microsoft.com/office/drawing/2018/hyperlinkcolor" matchingName="Content slide light texture A">
+<p:sldLayout xmlns:a="http://schemas.openxmlformats.org/drawingml/2006/main" xmlns:r="http://schemas.openxmlformats.org/officeDocument/2006/relationships" xmlns:p="http://schemas.openxmlformats.org/presentationml/2006/main" matchingName="Content slide light texture A">
   <p:cSld name="CUSTOM_2">
     <p:spTree>
       <p:nvGrpSpPr>
-        <p:cNvPr id="14" name="Shape 14"/>
+        <p:cNvPr id="1" name="Shape 14"/>
         <p:cNvGrpSpPr/>
         <p:nvPr/>
       </p:nvGrpSpPr>
@@ -2088,7 +2140,7 @@
           <a:blip r:embed="rId2">
             <a:alphaModFix/>
           </a:blip>
-          <a:srcRect b="0" l="0" r="0" t="0"/>
+          <a:srcRect/>
           <a:stretch/>
         </p:blipFill>
         <p:spPr>
@@ -2115,7 +2167,7 @@
           <a:blip r:embed="rId3">
             <a:alphaModFix/>
           </a:blip>
-          <a:srcRect b="0" l="0" r="0" t="0"/>
+          <a:srcRect/>
           <a:stretch/>
         </p:blipFill>
         <p:spPr>
@@ -2154,12 +2206,12 @@
           </a:ln>
         </p:spPr>
         <p:txBody>
-          <a:bodyPr anchorCtr="0" anchor="ctr" bIns="91425" lIns="91425" spcFirstLastPara="1" rIns="91425" wrap="square" tIns="91425">
+          <a:bodyPr spcFirstLastPara="1" wrap="square" lIns="91425" tIns="91425" rIns="91425" bIns="91425" anchor="ctr" anchorCtr="0">
             <a:noAutofit/>
           </a:bodyPr>
           <a:lstStyle/>
           <a:p>
-            <a:pPr indent="0" lvl="0" marL="0" marR="0" rtl="0" algn="ctr">
+            <a:pPr marL="0" marR="0" lvl="0" indent="0" algn="ctr" rtl="0">
               <a:lnSpc>
                 <a:spcPct val="100000"/>
               </a:lnSpc>
@@ -2176,10 +2228,7 @@
               <a:buFont typeface="Arial"/>
               <a:buNone/>
             </a:pPr>
-            <a:r>
-              <a:t/>
-            </a:r>
-            <a:endParaRPr b="0" i="0" sz="1400" u="none" cap="none" strike="noStrike">
+            <a:endParaRPr sz="1400" b="0" i="0" u="none" strike="noStrike" cap="none">
               <a:solidFill>
                 <a:schemeClr val="lt1"/>
               </a:solidFill>
@@ -2211,12 +2260,12 @@
           </a:ln>
         </p:spPr>
         <p:txBody>
-          <a:bodyPr anchorCtr="0" anchor="ctr" bIns="19050" lIns="19050" spcFirstLastPara="1" rIns="19050" wrap="square" tIns="19050">
+          <a:bodyPr spcFirstLastPara="1" wrap="square" lIns="19050" tIns="19050" rIns="19050" bIns="19050" anchor="ctr" anchorCtr="0">
             <a:spAutoFit/>
           </a:bodyPr>
           <a:lstStyle/>
           <a:p>
-            <a:pPr indent="0" lvl="0" marL="0" marR="0" rtl="0" algn="r">
+            <a:pPr marL="0" marR="0" lvl="0" indent="0" algn="r" rtl="0">
               <a:lnSpc>
                 <a:spcPct val="90000"/>
               </a:lnSpc>
@@ -2234,7 +2283,7 @@
               <a:buNone/>
             </a:pPr>
             <a:r>
-              <a:rPr b="1" i="0" lang="en" sz="1200" u="none" cap="none" strike="noStrike">
+              <a:rPr lang="en" sz="1200" b="1" i="0" u="none" strike="noStrike" cap="none">
                 <a:solidFill>
                   <a:schemeClr val="dk1"/>
                 </a:solidFill>
@@ -2246,7 +2295,7 @@
               <a:t>@interledger  </a:t>
             </a:r>
             <a:r>
-              <a:rPr b="1" lang="en" sz="1200">
+              <a:rPr lang="en" sz="1200" b="1">
                 <a:solidFill>
                   <a:schemeClr val="dk1"/>
                 </a:solidFill>
@@ -2257,7 +2306,7 @@
               </a:rPr>
               <a:t>#OpenPayments</a:t>
             </a:r>
-            <a:endParaRPr b="1" i="0" sz="500" u="none" cap="none" strike="noStrike">
+            <a:endParaRPr sz="500" b="1" i="0" u="none" strike="noStrike" cap="none">
               <a:solidFill>
                 <a:schemeClr val="dk1"/>
               </a:solidFill>
@@ -2289,12 +2338,12 @@
           </a:ln>
         </p:spPr>
         <p:txBody>
-          <a:bodyPr anchorCtr="0" anchor="t" bIns="19050" lIns="19050" spcFirstLastPara="1" rIns="19050" wrap="square" tIns="19050">
+          <a:bodyPr spcFirstLastPara="1" wrap="square" lIns="19050" tIns="19050" rIns="19050" bIns="19050" anchor="t" anchorCtr="0">
             <a:noAutofit/>
           </a:bodyPr>
           <a:lstStyle/>
           <a:p>
-            <a:pPr indent="0" lvl="1" marL="0" marR="0" rtl="0" algn="l">
+            <a:pPr marL="0" marR="0" lvl="1" indent="0" algn="l" rtl="0">
               <a:lnSpc>
                 <a:spcPct val="90000"/>
               </a:lnSpc>
@@ -2312,7 +2361,7 @@
               <a:buNone/>
             </a:pPr>
             <a:r>
-              <a:rPr b="1" i="0" lang="en" sz="1400" u="none" cap="none" strike="noStrike">
+              <a:rPr lang="en" sz="1400" b="1" i="0" u="none" strike="noStrike" cap="none">
                 <a:solidFill>
                   <a:schemeClr val="dk1"/>
                 </a:solidFill>
@@ -2324,7 +2373,7 @@
               <a:t>#</a:t>
             </a:r>
             <a:r>
-              <a:rPr b="1" lang="en">
+              <a:rPr lang="en" b="1">
                 <a:solidFill>
                   <a:schemeClr val="dk1"/>
                 </a:solidFill>
@@ -2335,7 +2384,7 @@
               </a:rPr>
               <a:t>ILPHacks</a:t>
             </a:r>
-            <a:endParaRPr b="1" i="0" sz="1400" u="none" cap="none" strike="noStrike">
+            <a:endParaRPr sz="1400" b="1" i="0" u="none" strike="noStrike" cap="none">
               <a:solidFill>
                 <a:schemeClr val="dk1"/>
               </a:solidFill>
@@ -2357,7 +2406,7 @@
           <a:blip r:embed="rId4">
             <a:alphaModFix/>
           </a:blip>
-          <a:srcRect b="0" l="0" r="0" t="0"/>
+          <a:srcRect/>
           <a:stretch/>
         </p:blipFill>
         <p:spPr>
@@ -2383,11 +2432,11 @@
 </file>
 
 <file path=ppt/slideLayouts/slideLayout3.xml><?xml version="1.0" encoding="utf-8"?>
-<p:sldLayout xmlns:a="http://schemas.openxmlformats.org/drawingml/2006/main" xmlns:r="http://schemas.openxmlformats.org/officeDocument/2006/relationships" xmlns:mc="http://schemas.openxmlformats.org/markup-compatibility/2006" xmlns:mv="urn:schemas-microsoft-com:mac:vml" xmlns:p="http://schemas.openxmlformats.org/presentationml/2006/main" xmlns:c="http://schemas.openxmlformats.org/drawingml/2006/chart" xmlns:dgm="http://schemas.openxmlformats.org/drawingml/2006/diagram" xmlns:o="urn:schemas-microsoft-com:office:office" xmlns:v="urn:schemas-microsoft-com:vml" xmlns:pvml="urn:schemas-microsoft-com:office:powerpoint" xmlns:com="http://schemas.openxmlformats.org/drawingml/2006/compatibility" xmlns:p14="http://schemas.microsoft.com/office/powerpoint/2010/main" xmlns:p15="http://schemas.microsoft.com/office/powerpoint/2012/main" xmlns:ahyp="http://schemas.microsoft.com/office/drawing/2018/hyperlinkcolor" matchingName="Title slide dark (phone) 1">
+<p:sldLayout xmlns:a="http://schemas.openxmlformats.org/drawingml/2006/main" xmlns:r="http://schemas.openxmlformats.org/officeDocument/2006/relationships" xmlns:p="http://schemas.openxmlformats.org/presentationml/2006/main" matchingName="Title slide dark (phone) 1">
   <p:cSld name="TITLE_AND_BODY_1">
     <p:spTree>
       <p:nvGrpSpPr>
-        <p:cNvPr id="21" name="Shape 21"/>
+        <p:cNvPr id="1" name="Shape 21"/>
         <p:cNvGrpSpPr/>
         <p:nvPr/>
       </p:nvGrpSpPr>
@@ -2409,7 +2458,7 @@
           <a:blip r:embed="rId2">
             <a:alphaModFix/>
           </a:blip>
-          <a:srcRect b="0" l="0" r="0" t="0"/>
+          <a:srcRect/>
           <a:stretch/>
         </p:blipFill>
         <p:spPr>
@@ -2429,9 +2478,11 @@
       <p:sp>
         <p:nvSpPr>
           <p:cNvPr id="23" name="Google Shape;23;p4"/>
-          <p:cNvSpPr txBox="1"/>
+          <p:cNvSpPr txBox="1">
+            <a:spLocks noGrp="1"/>
+          </p:cNvSpPr>
           <p:nvPr>
-            <p:ph idx="12" type="sldNum"/>
+            <p:ph type="sldNum" idx="12"/>
           </p:nvPr>
         </p:nvSpPr>
         <p:spPr>
@@ -2448,11 +2499,11 @@
           </a:ln>
         </p:spPr>
         <p:txBody>
-          <a:bodyPr anchorCtr="0" anchor="ctr" bIns="91425" lIns="91425" spcFirstLastPara="1" rIns="91425" wrap="square" tIns="91425">
+          <a:bodyPr spcFirstLastPara="1" wrap="square" lIns="91425" tIns="91425" rIns="91425" bIns="91425" anchor="ctr" anchorCtr="0">
             <a:normAutofit/>
           </a:bodyPr>
           <a:lstStyle>
-            <a:lvl1pPr indent="0" lvl="0" marL="0" marR="0" algn="r">
+            <a:lvl1pPr marL="0" marR="0" lvl="0" indent="0" algn="r">
               <a:lnSpc>
                 <a:spcPct val="100000"/>
               </a:lnSpc>
@@ -2468,7 +2519,7 @@
               <a:buSzPts val="1000"/>
               <a:buFont typeface="Arial"/>
               <a:buNone/>
-              <a:defRPr b="0" i="0" sz="1000" u="none" cap="none" strike="noStrike">
+              <a:defRPr sz="1000" b="0" i="0" u="none" strike="noStrike" cap="none">
                 <a:solidFill>
                   <a:schemeClr val="dk2"/>
                 </a:solidFill>
@@ -2478,7 +2529,7 @@
                 <a:sym typeface="Arial"/>
               </a:defRPr>
             </a:lvl1pPr>
-            <a:lvl2pPr indent="0" lvl="1" marL="0" marR="0" algn="r">
+            <a:lvl2pPr marL="0" marR="0" lvl="1" indent="0" algn="r">
               <a:lnSpc>
                 <a:spcPct val="100000"/>
               </a:lnSpc>
@@ -2494,7 +2545,7 @@
               <a:buSzPts val="1000"/>
               <a:buFont typeface="Arial"/>
               <a:buNone/>
-              <a:defRPr b="0" i="0" sz="1000" u="none" cap="none" strike="noStrike">
+              <a:defRPr sz="1000" b="0" i="0" u="none" strike="noStrike" cap="none">
                 <a:solidFill>
                   <a:schemeClr val="dk2"/>
                 </a:solidFill>
@@ -2504,7 +2555,7 @@
                 <a:sym typeface="Arial"/>
               </a:defRPr>
             </a:lvl2pPr>
-            <a:lvl3pPr indent="0" lvl="2" marL="0" marR="0" algn="r">
+            <a:lvl3pPr marL="0" marR="0" lvl="2" indent="0" algn="r">
               <a:lnSpc>
                 <a:spcPct val="100000"/>
               </a:lnSpc>
@@ -2520,7 +2571,7 @@
               <a:buSzPts val="1000"/>
               <a:buFont typeface="Arial"/>
               <a:buNone/>
-              <a:defRPr b="0" i="0" sz="1000" u="none" cap="none" strike="noStrike">
+              <a:defRPr sz="1000" b="0" i="0" u="none" strike="noStrike" cap="none">
                 <a:solidFill>
                   <a:schemeClr val="dk2"/>
                 </a:solidFill>
@@ -2530,7 +2581,7 @@
                 <a:sym typeface="Arial"/>
               </a:defRPr>
             </a:lvl3pPr>
-            <a:lvl4pPr indent="0" lvl="3" marL="0" marR="0" algn="r">
+            <a:lvl4pPr marL="0" marR="0" lvl="3" indent="0" algn="r">
               <a:lnSpc>
                 <a:spcPct val="100000"/>
               </a:lnSpc>
@@ -2546,7 +2597,7 @@
               <a:buSzPts val="1000"/>
               <a:buFont typeface="Arial"/>
               <a:buNone/>
-              <a:defRPr b="0" i="0" sz="1000" u="none" cap="none" strike="noStrike">
+              <a:defRPr sz="1000" b="0" i="0" u="none" strike="noStrike" cap="none">
                 <a:solidFill>
                   <a:schemeClr val="dk2"/>
                 </a:solidFill>
@@ -2556,7 +2607,7 @@
                 <a:sym typeface="Arial"/>
               </a:defRPr>
             </a:lvl4pPr>
-            <a:lvl5pPr indent="0" lvl="4" marL="0" marR="0" algn="r">
+            <a:lvl5pPr marL="0" marR="0" lvl="4" indent="0" algn="r">
               <a:lnSpc>
                 <a:spcPct val="100000"/>
               </a:lnSpc>
@@ -2572,7 +2623,7 @@
               <a:buSzPts val="1000"/>
               <a:buFont typeface="Arial"/>
               <a:buNone/>
-              <a:defRPr b="0" i="0" sz="1000" u="none" cap="none" strike="noStrike">
+              <a:defRPr sz="1000" b="0" i="0" u="none" strike="noStrike" cap="none">
                 <a:solidFill>
                   <a:schemeClr val="dk2"/>
                 </a:solidFill>
@@ -2582,7 +2633,7 @@
                 <a:sym typeface="Arial"/>
               </a:defRPr>
             </a:lvl5pPr>
-            <a:lvl6pPr indent="0" lvl="5" marL="0" marR="0" algn="r">
+            <a:lvl6pPr marL="0" marR="0" lvl="5" indent="0" algn="r">
               <a:lnSpc>
                 <a:spcPct val="100000"/>
               </a:lnSpc>
@@ -2598,7 +2649,7 @@
               <a:buSzPts val="1000"/>
               <a:buFont typeface="Arial"/>
               <a:buNone/>
-              <a:defRPr b="0" i="0" sz="1000" u="none" cap="none" strike="noStrike">
+              <a:defRPr sz="1000" b="0" i="0" u="none" strike="noStrike" cap="none">
                 <a:solidFill>
                   <a:schemeClr val="dk2"/>
                 </a:solidFill>
@@ -2608,7 +2659,7 @@
                 <a:sym typeface="Arial"/>
               </a:defRPr>
             </a:lvl6pPr>
-            <a:lvl7pPr indent="0" lvl="6" marL="0" marR="0" algn="r">
+            <a:lvl7pPr marL="0" marR="0" lvl="6" indent="0" algn="r">
               <a:lnSpc>
                 <a:spcPct val="100000"/>
               </a:lnSpc>
@@ -2624,7 +2675,7 @@
               <a:buSzPts val="1000"/>
               <a:buFont typeface="Arial"/>
               <a:buNone/>
-              <a:defRPr b="0" i="0" sz="1000" u="none" cap="none" strike="noStrike">
+              <a:defRPr sz="1000" b="0" i="0" u="none" strike="noStrike" cap="none">
                 <a:solidFill>
                   <a:schemeClr val="dk2"/>
                 </a:solidFill>
@@ -2634,7 +2685,7 @@
                 <a:sym typeface="Arial"/>
               </a:defRPr>
             </a:lvl7pPr>
-            <a:lvl8pPr indent="0" lvl="7" marL="0" marR="0" algn="r">
+            <a:lvl8pPr marL="0" marR="0" lvl="7" indent="0" algn="r">
               <a:lnSpc>
                 <a:spcPct val="100000"/>
               </a:lnSpc>
@@ -2650,7 +2701,7 @@
               <a:buSzPts val="1000"/>
               <a:buFont typeface="Arial"/>
               <a:buNone/>
-              <a:defRPr b="0" i="0" sz="1000" u="none" cap="none" strike="noStrike">
+              <a:defRPr sz="1000" b="0" i="0" u="none" strike="noStrike" cap="none">
                 <a:solidFill>
                   <a:schemeClr val="dk2"/>
                 </a:solidFill>
@@ -2660,7 +2711,7 @@
                 <a:sym typeface="Arial"/>
               </a:defRPr>
             </a:lvl8pPr>
-            <a:lvl9pPr indent="0" lvl="8" marL="0" marR="0" algn="r">
+            <a:lvl9pPr marL="0" marR="0" lvl="8" indent="0" algn="r">
               <a:lnSpc>
                 <a:spcPct val="100000"/>
               </a:lnSpc>
@@ -2676,7 +2727,7 @@
               <a:buSzPts val="1000"/>
               <a:buFont typeface="Arial"/>
               <a:buNone/>
-              <a:defRPr b="0" i="0" sz="1000" u="none" cap="none" strike="noStrike">
+              <a:defRPr sz="1000" b="0" i="0" u="none" strike="noStrike" cap="none">
                 <a:solidFill>
                   <a:schemeClr val="dk2"/>
                 </a:solidFill>
@@ -2688,7 +2739,7 @@
             </a:lvl9pPr>
           </a:lstStyle>
           <a:p>
-            <a:pPr indent="0" lvl="0" marL="0" rtl="0" algn="r">
+            <a:pPr marL="0" lvl="0" indent="0" algn="r" rtl="0">
               <a:spcBef>
                 <a:spcPts val="0"/>
               </a:spcBef>
@@ -2715,7 +2766,7 @@
           <a:blip r:embed="rId3">
             <a:alphaModFix/>
           </a:blip>
-          <a:srcRect b="0" l="0" r="0" t="0"/>
+          <a:srcRect/>
           <a:stretch/>
         </p:blipFill>
         <p:spPr>
@@ -2741,11 +2792,11 @@
 </file>
 
 <file path=ppt/slideLayouts/slideLayout4.xml><?xml version="1.0" encoding="utf-8"?>
-<p:sldLayout xmlns:a="http://schemas.openxmlformats.org/drawingml/2006/main" xmlns:r="http://schemas.openxmlformats.org/officeDocument/2006/relationships" xmlns:mc="http://schemas.openxmlformats.org/markup-compatibility/2006" xmlns:mv="urn:schemas-microsoft-com:mac:vml" xmlns:p="http://schemas.openxmlformats.org/presentationml/2006/main" xmlns:c="http://schemas.openxmlformats.org/drawingml/2006/chart" xmlns:dgm="http://schemas.openxmlformats.org/drawingml/2006/diagram" xmlns:o="urn:schemas-microsoft-com:office:office" xmlns:v="urn:schemas-microsoft-com:vml" xmlns:pvml="urn:schemas-microsoft-com:office:powerpoint" xmlns:com="http://schemas.openxmlformats.org/drawingml/2006/compatibility" xmlns:p14="http://schemas.microsoft.com/office/powerpoint/2010/main" xmlns:p15="http://schemas.microsoft.com/office/powerpoint/2012/main" xmlns:ahyp="http://schemas.microsoft.com/office/drawing/2018/hyperlinkcolor" matchingName="Content slide dark gradient">
+<p:sldLayout xmlns:a="http://schemas.openxmlformats.org/drawingml/2006/main" xmlns:r="http://schemas.openxmlformats.org/officeDocument/2006/relationships" xmlns:p="http://schemas.openxmlformats.org/presentationml/2006/main" matchingName="Content slide dark gradient">
   <p:cSld name="CUSTOM_1">
     <p:spTree>
       <p:nvGrpSpPr>
-        <p:cNvPr id="25" name="Shape 25"/>
+        <p:cNvPr id="1" name="Shape 25"/>
         <p:cNvGrpSpPr/>
         <p:nvPr/>
       </p:nvGrpSpPr>
@@ -2767,7 +2818,7 @@
           <a:blip r:embed="rId2">
             <a:alphaModFix/>
           </a:blip>
-          <a:srcRect b="0" l="0" r="0" t="0"/>
+          <a:srcRect/>
           <a:stretch/>
         </p:blipFill>
         <p:spPr>
@@ -2794,7 +2845,7 @@
           <a:blip r:embed="rId3">
             <a:alphaModFix/>
           </a:blip>
-          <a:srcRect b="0" l="0" r="0" t="0"/>
+          <a:srcRect/>
           <a:stretch/>
         </p:blipFill>
         <p:spPr>
@@ -2820,11 +2871,11 @@
 </file>
 
 <file path=ppt/slideLayouts/slideLayout5.xml><?xml version="1.0" encoding="utf-8"?>
-<p:sldLayout xmlns:a="http://schemas.openxmlformats.org/drawingml/2006/main" xmlns:r="http://schemas.openxmlformats.org/officeDocument/2006/relationships" xmlns:mc="http://schemas.openxmlformats.org/markup-compatibility/2006" xmlns:mv="urn:schemas-microsoft-com:mac:vml" xmlns:p="http://schemas.openxmlformats.org/presentationml/2006/main" xmlns:c="http://schemas.openxmlformats.org/drawingml/2006/chart" xmlns:dgm="http://schemas.openxmlformats.org/drawingml/2006/diagram" xmlns:o="urn:schemas-microsoft-com:office:office" xmlns:v="urn:schemas-microsoft-com:vml" xmlns:pvml="urn:schemas-microsoft-com:office:powerpoint" xmlns:com="http://schemas.openxmlformats.org/drawingml/2006/compatibility" xmlns:p14="http://schemas.microsoft.com/office/powerpoint/2010/main" xmlns:p15="http://schemas.microsoft.com/office/powerpoint/2012/main" xmlns:ahyp="http://schemas.microsoft.com/office/drawing/2018/hyperlinkcolor" matchingName="Content slide no background B">
+<p:sldLayout xmlns:a="http://schemas.openxmlformats.org/drawingml/2006/main" xmlns:r="http://schemas.openxmlformats.org/officeDocument/2006/relationships" xmlns:p="http://schemas.openxmlformats.org/presentationml/2006/main" matchingName="Content slide no background B">
   <p:cSld name="CUSTOM_4">
     <p:spTree>
       <p:nvGrpSpPr>
-        <p:cNvPr id="28" name="Shape 28"/>
+        <p:cNvPr id="1" name="Shape 28"/>
         <p:cNvGrpSpPr/>
         <p:nvPr/>
       </p:nvGrpSpPr>
@@ -2846,7 +2897,7 @@
           <a:blip r:embed="rId2">
             <a:alphaModFix/>
           </a:blip>
-          <a:srcRect b="0" l="0" r="0" t="0"/>
+          <a:srcRect/>
           <a:stretch/>
         </p:blipFill>
         <p:spPr>
@@ -2872,18 +2923,19 @@
 </file>
 
 <file path=ppt/slideMasters/slideMaster1.xml><?xml version="1.0" encoding="utf-8"?>
-<p:sldMaster xmlns:a="http://schemas.openxmlformats.org/drawingml/2006/main" xmlns:r="http://schemas.openxmlformats.org/officeDocument/2006/relationships" xmlns:mc="http://schemas.openxmlformats.org/markup-compatibility/2006" xmlns:mv="urn:schemas-microsoft-com:mac:vml" xmlns:p="http://schemas.openxmlformats.org/presentationml/2006/main" xmlns:c="http://schemas.openxmlformats.org/drawingml/2006/chart" xmlns:dgm="http://schemas.openxmlformats.org/drawingml/2006/diagram" xmlns:o="urn:schemas-microsoft-com:office:office" xmlns:v="urn:schemas-microsoft-com:vml" xmlns:pvml="urn:schemas-microsoft-com:office:powerpoint" xmlns:com="http://schemas.openxmlformats.org/drawingml/2006/compatibility" xmlns:p14="http://schemas.microsoft.com/office/powerpoint/2010/main" xmlns:p15="http://schemas.microsoft.com/office/powerpoint/2012/main" xmlns:ahyp="http://schemas.microsoft.com/office/drawing/2018/hyperlinkcolor">
+<p:sldMaster xmlns:a="http://schemas.openxmlformats.org/drawingml/2006/main" xmlns:r="http://schemas.openxmlformats.org/officeDocument/2006/relationships" xmlns:p="http://schemas.openxmlformats.org/presentationml/2006/main">
   <p:cSld name="simple-light-2">
     <p:bg>
       <p:bgPr>
         <a:solidFill>
           <a:schemeClr val="lt1"/>
         </a:solidFill>
+        <a:effectLst/>
       </p:bgPr>
     </p:bg>
     <p:spTree>
       <p:nvGrpSpPr>
-        <p:cNvPr id="5" name="Shape 5"/>
+        <p:cNvPr id="1" name="Shape 5"/>
         <p:cNvGrpSpPr/>
         <p:nvPr/>
       </p:nvGrpSpPr>
@@ -2898,7 +2950,9 @@
       <p:sp>
         <p:nvSpPr>
           <p:cNvPr id="6" name="Google Shape;6;p1"/>
-          <p:cNvSpPr txBox="1"/>
+          <p:cNvSpPr txBox="1">
+            <a:spLocks noGrp="1"/>
+          </p:cNvSpPr>
           <p:nvPr>
             <p:ph type="title"/>
           </p:nvPr>
@@ -2917,11 +2971,11 @@
           </a:ln>
         </p:spPr>
         <p:txBody>
-          <a:bodyPr anchorCtr="0" anchor="t" bIns="91425" lIns="91425" spcFirstLastPara="1" rIns="91425" wrap="square" tIns="91425">
+          <a:bodyPr spcFirstLastPara="1" wrap="square" lIns="91425" tIns="91425" rIns="91425" bIns="91425" anchor="t" anchorCtr="0">
             <a:normAutofit/>
           </a:bodyPr>
           <a:lstStyle>
-            <a:lvl1pPr lvl="0" marR="0" rtl="0" algn="l">
+            <a:lvl1pPr marR="0" lvl="0" algn="l" rtl="0">
               <a:lnSpc>
                 <a:spcPct val="100000"/>
               </a:lnSpc>
@@ -2937,7 +2991,7 @@
               <a:buSzPts val="2800"/>
               <a:buFont typeface="Titillium Web"/>
               <a:buNone/>
-              <a:defRPr b="0" i="0" sz="2800" u="none" cap="none" strike="noStrike">
+              <a:defRPr sz="2800" b="0" i="0" u="none" strike="noStrike" cap="none">
                 <a:solidFill>
                   <a:schemeClr val="dk1"/>
                 </a:solidFill>
@@ -2947,7 +3001,7 @@
                 <a:sym typeface="Titillium Web"/>
               </a:defRPr>
             </a:lvl1pPr>
-            <a:lvl2pPr lvl="1" marR="0" rtl="0" algn="l">
+            <a:lvl2pPr marR="0" lvl="1" algn="l" rtl="0">
               <a:lnSpc>
                 <a:spcPct val="100000"/>
               </a:lnSpc>
@@ -2963,7 +3017,7 @@
               <a:buSzPts val="2800"/>
               <a:buFont typeface="Arial"/>
               <a:buNone/>
-              <a:defRPr b="0" i="0" sz="2800" u="none" cap="none" strike="noStrike">
+              <a:defRPr sz="2800" b="0" i="0" u="none" strike="noStrike" cap="none">
                 <a:solidFill>
                   <a:schemeClr val="dk1"/>
                 </a:solidFill>
@@ -2973,7 +3027,7 @@
                 <a:sym typeface="Arial"/>
               </a:defRPr>
             </a:lvl2pPr>
-            <a:lvl3pPr lvl="2" marR="0" rtl="0" algn="l">
+            <a:lvl3pPr marR="0" lvl="2" algn="l" rtl="0">
               <a:lnSpc>
                 <a:spcPct val="100000"/>
               </a:lnSpc>
@@ -2989,7 +3043,7 @@
               <a:buSzPts val="2800"/>
               <a:buFont typeface="Arial"/>
               <a:buNone/>
-              <a:defRPr b="0" i="0" sz="2800" u="none" cap="none" strike="noStrike">
+              <a:defRPr sz="2800" b="0" i="0" u="none" strike="noStrike" cap="none">
                 <a:solidFill>
                   <a:schemeClr val="dk1"/>
                 </a:solidFill>
@@ -2999,7 +3053,7 @@
                 <a:sym typeface="Arial"/>
               </a:defRPr>
             </a:lvl3pPr>
-            <a:lvl4pPr lvl="3" marR="0" rtl="0" algn="l">
+            <a:lvl4pPr marR="0" lvl="3" algn="l" rtl="0">
               <a:lnSpc>
                 <a:spcPct val="100000"/>
               </a:lnSpc>
@@ -3015,7 +3069,7 @@
               <a:buSzPts val="2800"/>
               <a:buFont typeface="Arial"/>
               <a:buNone/>
-              <a:defRPr b="0" i="0" sz="2800" u="none" cap="none" strike="noStrike">
+              <a:defRPr sz="2800" b="0" i="0" u="none" strike="noStrike" cap="none">
                 <a:solidFill>
                   <a:schemeClr val="dk1"/>
                 </a:solidFill>
@@ -3025,7 +3079,7 @@
                 <a:sym typeface="Arial"/>
               </a:defRPr>
             </a:lvl4pPr>
-            <a:lvl5pPr lvl="4" marR="0" rtl="0" algn="l">
+            <a:lvl5pPr marR="0" lvl="4" algn="l" rtl="0">
               <a:lnSpc>
                 <a:spcPct val="100000"/>
               </a:lnSpc>
@@ -3041,7 +3095,7 @@
               <a:buSzPts val="2800"/>
               <a:buFont typeface="Arial"/>
               <a:buNone/>
-              <a:defRPr b="0" i="0" sz="2800" u="none" cap="none" strike="noStrike">
+              <a:defRPr sz="2800" b="0" i="0" u="none" strike="noStrike" cap="none">
                 <a:solidFill>
                   <a:schemeClr val="dk1"/>
                 </a:solidFill>
@@ -3051,7 +3105,7 @@
                 <a:sym typeface="Arial"/>
               </a:defRPr>
             </a:lvl5pPr>
-            <a:lvl6pPr lvl="5" marR="0" rtl="0" algn="l">
+            <a:lvl6pPr marR="0" lvl="5" algn="l" rtl="0">
               <a:lnSpc>
                 <a:spcPct val="100000"/>
               </a:lnSpc>
@@ -3067,7 +3121,7 @@
               <a:buSzPts val="2800"/>
               <a:buFont typeface="Arial"/>
               <a:buNone/>
-              <a:defRPr b="0" i="0" sz="2800" u="none" cap="none" strike="noStrike">
+              <a:defRPr sz="2800" b="0" i="0" u="none" strike="noStrike" cap="none">
                 <a:solidFill>
                   <a:schemeClr val="dk1"/>
                 </a:solidFill>
@@ -3077,7 +3131,7 @@
                 <a:sym typeface="Arial"/>
               </a:defRPr>
             </a:lvl6pPr>
-            <a:lvl7pPr lvl="6" marR="0" rtl="0" algn="l">
+            <a:lvl7pPr marR="0" lvl="6" algn="l" rtl="0">
               <a:lnSpc>
                 <a:spcPct val="100000"/>
               </a:lnSpc>
@@ -3093,7 +3147,7 @@
               <a:buSzPts val="2800"/>
               <a:buFont typeface="Arial"/>
               <a:buNone/>
-              <a:defRPr b="0" i="0" sz="2800" u="none" cap="none" strike="noStrike">
+              <a:defRPr sz="2800" b="0" i="0" u="none" strike="noStrike" cap="none">
                 <a:solidFill>
                   <a:schemeClr val="dk1"/>
                 </a:solidFill>
@@ -3103,7 +3157,7 @@
                 <a:sym typeface="Arial"/>
               </a:defRPr>
             </a:lvl7pPr>
-            <a:lvl8pPr lvl="7" marR="0" rtl="0" algn="l">
+            <a:lvl8pPr marR="0" lvl="7" algn="l" rtl="0">
               <a:lnSpc>
                 <a:spcPct val="100000"/>
               </a:lnSpc>
@@ -3119,7 +3173,7 @@
               <a:buSzPts val="2800"/>
               <a:buFont typeface="Arial"/>
               <a:buNone/>
-              <a:defRPr b="0" i="0" sz="2800" u="none" cap="none" strike="noStrike">
+              <a:defRPr sz="2800" b="0" i="0" u="none" strike="noStrike" cap="none">
                 <a:solidFill>
                   <a:schemeClr val="dk1"/>
                 </a:solidFill>
@@ -3129,7 +3183,7 @@
                 <a:sym typeface="Arial"/>
               </a:defRPr>
             </a:lvl8pPr>
-            <a:lvl9pPr lvl="8" marR="0" rtl="0" algn="l">
+            <a:lvl9pPr marR="0" lvl="8" algn="l" rtl="0">
               <a:lnSpc>
                 <a:spcPct val="100000"/>
               </a:lnSpc>
@@ -3145,7 +3199,7 @@
               <a:buSzPts val="2800"/>
               <a:buFont typeface="Arial"/>
               <a:buNone/>
-              <a:defRPr b="0" i="0" sz="2800" u="none" cap="none" strike="noStrike">
+              <a:defRPr sz="2800" b="0" i="0" u="none" strike="noStrike" cap="none">
                 <a:solidFill>
                   <a:schemeClr val="dk1"/>
                 </a:solidFill>
@@ -3156,15 +3210,19 @@
               </a:defRPr>
             </a:lvl9pPr>
           </a:lstStyle>
-          <a:p/>
+          <a:p>
+            <a:endParaRPr/>
+          </a:p>
         </p:txBody>
       </p:sp>
       <p:sp>
         <p:nvSpPr>
           <p:cNvPr id="7" name="Google Shape;7;p1"/>
-          <p:cNvSpPr txBox="1"/>
+          <p:cNvSpPr txBox="1">
+            <a:spLocks noGrp="1"/>
+          </p:cNvSpPr>
           <p:nvPr>
-            <p:ph idx="1" type="body"/>
+            <p:ph type="body" idx="1"/>
           </p:nvPr>
         </p:nvSpPr>
         <p:spPr>
@@ -3181,11 +3239,11 @@
           </a:ln>
         </p:spPr>
         <p:txBody>
-          <a:bodyPr anchorCtr="0" anchor="t" bIns="91425" lIns="91425" spcFirstLastPara="1" rIns="91425" wrap="square" tIns="91425">
+          <a:bodyPr spcFirstLastPara="1" wrap="square" lIns="91425" tIns="91425" rIns="91425" bIns="91425" anchor="t" anchorCtr="0">
             <a:normAutofit/>
           </a:bodyPr>
           <a:lstStyle>
-            <a:lvl1pPr indent="-342900" lvl="0" marL="457200" marR="0" rtl="0" algn="l">
+            <a:lvl1pPr marL="457200" marR="0" lvl="0" indent="-342900" algn="l" rtl="0">
               <a:lnSpc>
                 <a:spcPct val="115000"/>
               </a:lnSpc>
@@ -3201,7 +3259,7 @@
               <a:buSzPts val="1800"/>
               <a:buFont typeface="Titillium Web"/>
               <a:buChar char="●"/>
-              <a:defRPr b="0" i="0" sz="1800" u="none" cap="none" strike="noStrike">
+              <a:defRPr sz="1800" b="0" i="0" u="none" strike="noStrike" cap="none">
                 <a:solidFill>
                   <a:schemeClr val="dk2"/>
                 </a:solidFill>
@@ -3211,7 +3269,7 @@
                 <a:sym typeface="Titillium Web"/>
               </a:defRPr>
             </a:lvl1pPr>
-            <a:lvl2pPr indent="-317500" lvl="1" marL="914400" marR="0" rtl="0" algn="l">
+            <a:lvl2pPr marL="914400" marR="0" lvl="1" indent="-317500" algn="l" rtl="0">
               <a:lnSpc>
                 <a:spcPct val="115000"/>
               </a:lnSpc>
@@ -3227,7 +3285,7 @@
               <a:buSzPts val="1400"/>
               <a:buFont typeface="Titillium Web"/>
               <a:buChar char="○"/>
-              <a:defRPr b="0" i="0" sz="1400" u="none" cap="none" strike="noStrike">
+              <a:defRPr sz="1400" b="0" i="0" u="none" strike="noStrike" cap="none">
                 <a:solidFill>
                   <a:schemeClr val="dk2"/>
                 </a:solidFill>
@@ -3237,7 +3295,7 @@
                 <a:sym typeface="Titillium Web"/>
               </a:defRPr>
             </a:lvl2pPr>
-            <a:lvl3pPr indent="-317500" lvl="2" marL="1371600" marR="0" rtl="0" algn="l">
+            <a:lvl3pPr marL="1371600" marR="0" lvl="2" indent="-317500" algn="l" rtl="0">
               <a:lnSpc>
                 <a:spcPct val="115000"/>
               </a:lnSpc>
@@ -3253,7 +3311,7 @@
               <a:buSzPts val="1400"/>
               <a:buFont typeface="Titillium Web"/>
               <a:buChar char="■"/>
-              <a:defRPr b="0" i="0" sz="1400" u="none" cap="none" strike="noStrike">
+              <a:defRPr sz="1400" b="0" i="0" u="none" strike="noStrike" cap="none">
                 <a:solidFill>
                   <a:schemeClr val="dk2"/>
                 </a:solidFill>
@@ -3263,7 +3321,7 @@
                 <a:sym typeface="Titillium Web"/>
               </a:defRPr>
             </a:lvl3pPr>
-            <a:lvl4pPr indent="-317500" lvl="3" marL="1828800" marR="0" rtl="0" algn="l">
+            <a:lvl4pPr marL="1828800" marR="0" lvl="3" indent="-317500" algn="l" rtl="0">
               <a:lnSpc>
                 <a:spcPct val="115000"/>
               </a:lnSpc>
@@ -3279,7 +3337,7 @@
               <a:buSzPts val="1400"/>
               <a:buFont typeface="Titillium Web"/>
               <a:buChar char="●"/>
-              <a:defRPr b="0" i="0" sz="1400" u="none" cap="none" strike="noStrike">
+              <a:defRPr sz="1400" b="0" i="0" u="none" strike="noStrike" cap="none">
                 <a:solidFill>
                   <a:schemeClr val="dk2"/>
                 </a:solidFill>
@@ -3289,7 +3347,7 @@
                 <a:sym typeface="Titillium Web"/>
               </a:defRPr>
             </a:lvl4pPr>
-            <a:lvl5pPr indent="-317500" lvl="4" marL="2286000" marR="0" rtl="0" algn="l">
+            <a:lvl5pPr marL="2286000" marR="0" lvl="4" indent="-317500" algn="l" rtl="0">
               <a:lnSpc>
                 <a:spcPct val="115000"/>
               </a:lnSpc>
@@ -3305,7 +3363,7 @@
               <a:buSzPts val="1400"/>
               <a:buFont typeface="Titillium Web"/>
               <a:buChar char="○"/>
-              <a:defRPr b="0" i="0" sz="1400" u="none" cap="none" strike="noStrike">
+              <a:defRPr sz="1400" b="0" i="0" u="none" strike="noStrike" cap="none">
                 <a:solidFill>
                   <a:schemeClr val="dk2"/>
                 </a:solidFill>
@@ -3315,7 +3373,7 @@
                 <a:sym typeface="Titillium Web"/>
               </a:defRPr>
             </a:lvl5pPr>
-            <a:lvl6pPr indent="-317500" lvl="5" marL="2743200" marR="0" rtl="0" algn="l">
+            <a:lvl6pPr marL="2743200" marR="0" lvl="5" indent="-317500" algn="l" rtl="0">
               <a:lnSpc>
                 <a:spcPct val="115000"/>
               </a:lnSpc>
@@ -3331,7 +3389,7 @@
               <a:buSzPts val="1400"/>
               <a:buFont typeface="Titillium Web"/>
               <a:buChar char="■"/>
-              <a:defRPr b="0" i="0" sz="1400" u="none" cap="none" strike="noStrike">
+              <a:defRPr sz="1400" b="0" i="0" u="none" strike="noStrike" cap="none">
                 <a:solidFill>
                   <a:schemeClr val="dk2"/>
                 </a:solidFill>
@@ -3341,7 +3399,7 @@
                 <a:sym typeface="Titillium Web"/>
               </a:defRPr>
             </a:lvl6pPr>
-            <a:lvl7pPr indent="-317500" lvl="6" marL="3200400" marR="0" rtl="0" algn="l">
+            <a:lvl7pPr marL="3200400" marR="0" lvl="6" indent="-317500" algn="l" rtl="0">
               <a:lnSpc>
                 <a:spcPct val="115000"/>
               </a:lnSpc>
@@ -3357,7 +3415,7 @@
               <a:buSzPts val="1400"/>
               <a:buFont typeface="Titillium Web"/>
               <a:buChar char="●"/>
-              <a:defRPr b="0" i="0" sz="1400" u="none" cap="none" strike="noStrike">
+              <a:defRPr sz="1400" b="0" i="0" u="none" strike="noStrike" cap="none">
                 <a:solidFill>
                   <a:schemeClr val="dk2"/>
                 </a:solidFill>
@@ -3367,7 +3425,7 @@
                 <a:sym typeface="Titillium Web"/>
               </a:defRPr>
             </a:lvl7pPr>
-            <a:lvl8pPr indent="-317500" lvl="7" marL="3657600" marR="0" rtl="0" algn="l">
+            <a:lvl8pPr marL="3657600" marR="0" lvl="7" indent="-317500" algn="l" rtl="0">
               <a:lnSpc>
                 <a:spcPct val="115000"/>
               </a:lnSpc>
@@ -3383,7 +3441,7 @@
               <a:buSzPts val="1400"/>
               <a:buFont typeface="Titillium Web"/>
               <a:buChar char="○"/>
-              <a:defRPr b="0" i="0" sz="1400" u="none" cap="none" strike="noStrike">
+              <a:defRPr sz="1400" b="0" i="0" u="none" strike="noStrike" cap="none">
                 <a:solidFill>
                   <a:schemeClr val="dk2"/>
                 </a:solidFill>
@@ -3393,7 +3451,7 @@
                 <a:sym typeface="Titillium Web"/>
               </a:defRPr>
             </a:lvl8pPr>
-            <a:lvl9pPr indent="-317500" lvl="8" marL="4114800" marR="0" rtl="0" algn="l">
+            <a:lvl9pPr marL="4114800" marR="0" lvl="8" indent="-317500" algn="l" rtl="0">
               <a:lnSpc>
                 <a:spcPct val="115000"/>
               </a:lnSpc>
@@ -3409,7 +3467,7 @@
               <a:buSzPts val="1400"/>
               <a:buFont typeface="Titillium Web"/>
               <a:buChar char="■"/>
-              <a:defRPr b="0" i="0" sz="1400" u="none" cap="none" strike="noStrike">
+              <a:defRPr sz="1400" b="0" i="0" u="none" strike="noStrike" cap="none">
                 <a:solidFill>
                   <a:schemeClr val="dk2"/>
                 </a:solidFill>
@@ -3420,15 +3478,19 @@
               </a:defRPr>
             </a:lvl9pPr>
           </a:lstStyle>
-          <a:p/>
+          <a:p>
+            <a:endParaRPr/>
+          </a:p>
         </p:txBody>
       </p:sp>
       <p:sp>
         <p:nvSpPr>
           <p:cNvPr id="8" name="Google Shape;8;p1"/>
-          <p:cNvSpPr txBox="1"/>
+          <p:cNvSpPr txBox="1">
+            <a:spLocks noGrp="1"/>
+          </p:cNvSpPr>
           <p:nvPr>
-            <p:ph idx="12" type="sldNum"/>
+            <p:ph type="sldNum" idx="12"/>
           </p:nvPr>
         </p:nvSpPr>
         <p:spPr>
@@ -3445,11 +3507,11 @@
           </a:ln>
         </p:spPr>
         <p:txBody>
-          <a:bodyPr anchorCtr="0" anchor="ctr" bIns="91425" lIns="91425" spcFirstLastPara="1" rIns="91425" wrap="square" tIns="91425">
+          <a:bodyPr spcFirstLastPara="1" wrap="square" lIns="91425" tIns="91425" rIns="91425" bIns="91425" anchor="ctr" anchorCtr="0">
             <a:normAutofit/>
           </a:bodyPr>
           <a:lstStyle>
-            <a:lvl1pPr indent="0" lvl="0" marL="0" marR="0" rtl="0" algn="r">
+            <a:lvl1pPr marL="0" marR="0" lvl="0" indent="0" algn="r" rtl="0">
               <a:lnSpc>
                 <a:spcPct val="100000"/>
               </a:lnSpc>
@@ -3465,7 +3527,7 @@
               <a:buSzPts val="1000"/>
               <a:buFont typeface="Arial"/>
               <a:buNone/>
-              <a:defRPr b="0" i="0" sz="1000" u="none" cap="none" strike="noStrike">
+              <a:defRPr sz="1000" b="0" i="0" u="none" strike="noStrike" cap="none">
                 <a:solidFill>
                   <a:schemeClr val="dk2"/>
                 </a:solidFill>
@@ -3475,7 +3537,7 @@
                 <a:sym typeface="Arial"/>
               </a:defRPr>
             </a:lvl1pPr>
-            <a:lvl2pPr indent="0" lvl="1" marL="0" marR="0" rtl="0" algn="r">
+            <a:lvl2pPr marL="0" marR="0" lvl="1" indent="0" algn="r" rtl="0">
               <a:lnSpc>
                 <a:spcPct val="100000"/>
               </a:lnSpc>
@@ -3491,7 +3553,7 @@
               <a:buSzPts val="1000"/>
               <a:buFont typeface="Arial"/>
               <a:buNone/>
-              <a:defRPr b="0" i="0" sz="1000" u="none" cap="none" strike="noStrike">
+              <a:defRPr sz="1000" b="0" i="0" u="none" strike="noStrike" cap="none">
                 <a:solidFill>
                   <a:schemeClr val="dk2"/>
                 </a:solidFill>
@@ -3501,7 +3563,7 @@
                 <a:sym typeface="Arial"/>
               </a:defRPr>
             </a:lvl2pPr>
-            <a:lvl3pPr indent="0" lvl="2" marL="0" marR="0" rtl="0" algn="r">
+            <a:lvl3pPr marL="0" marR="0" lvl="2" indent="0" algn="r" rtl="0">
               <a:lnSpc>
                 <a:spcPct val="100000"/>
               </a:lnSpc>
@@ -3517,7 +3579,7 @@
               <a:buSzPts val="1000"/>
               <a:buFont typeface="Arial"/>
               <a:buNone/>
-              <a:defRPr b="0" i="0" sz="1000" u="none" cap="none" strike="noStrike">
+              <a:defRPr sz="1000" b="0" i="0" u="none" strike="noStrike" cap="none">
                 <a:solidFill>
                   <a:schemeClr val="dk2"/>
                 </a:solidFill>
@@ -3527,7 +3589,7 @@
                 <a:sym typeface="Arial"/>
               </a:defRPr>
             </a:lvl3pPr>
-            <a:lvl4pPr indent="0" lvl="3" marL="0" marR="0" rtl="0" algn="r">
+            <a:lvl4pPr marL="0" marR="0" lvl="3" indent="0" algn="r" rtl="0">
               <a:lnSpc>
                 <a:spcPct val="100000"/>
               </a:lnSpc>
@@ -3543,7 +3605,7 @@
               <a:buSzPts val="1000"/>
               <a:buFont typeface="Arial"/>
               <a:buNone/>
-              <a:defRPr b="0" i="0" sz="1000" u="none" cap="none" strike="noStrike">
+              <a:defRPr sz="1000" b="0" i="0" u="none" strike="noStrike" cap="none">
                 <a:solidFill>
                   <a:schemeClr val="dk2"/>
                 </a:solidFill>
@@ -3553,7 +3615,7 @@
                 <a:sym typeface="Arial"/>
               </a:defRPr>
             </a:lvl4pPr>
-            <a:lvl5pPr indent="0" lvl="4" marL="0" marR="0" rtl="0" algn="r">
+            <a:lvl5pPr marL="0" marR="0" lvl="4" indent="0" algn="r" rtl="0">
               <a:lnSpc>
                 <a:spcPct val="100000"/>
               </a:lnSpc>
@@ -3569,7 +3631,7 @@
               <a:buSzPts val="1000"/>
               <a:buFont typeface="Arial"/>
               <a:buNone/>
-              <a:defRPr b="0" i="0" sz="1000" u="none" cap="none" strike="noStrike">
+              <a:defRPr sz="1000" b="0" i="0" u="none" strike="noStrike" cap="none">
                 <a:solidFill>
                   <a:schemeClr val="dk2"/>
                 </a:solidFill>
@@ -3579,7 +3641,7 @@
                 <a:sym typeface="Arial"/>
               </a:defRPr>
             </a:lvl5pPr>
-            <a:lvl6pPr indent="0" lvl="5" marL="0" marR="0" rtl="0" algn="r">
+            <a:lvl6pPr marL="0" marR="0" lvl="5" indent="0" algn="r" rtl="0">
               <a:lnSpc>
                 <a:spcPct val="100000"/>
               </a:lnSpc>
@@ -3595,7 +3657,7 @@
               <a:buSzPts val="1000"/>
               <a:buFont typeface="Arial"/>
               <a:buNone/>
-              <a:defRPr b="0" i="0" sz="1000" u="none" cap="none" strike="noStrike">
+              <a:defRPr sz="1000" b="0" i="0" u="none" strike="noStrike" cap="none">
                 <a:solidFill>
                   <a:schemeClr val="dk2"/>
                 </a:solidFill>
@@ -3605,7 +3667,7 @@
                 <a:sym typeface="Arial"/>
               </a:defRPr>
             </a:lvl6pPr>
-            <a:lvl7pPr indent="0" lvl="6" marL="0" marR="0" rtl="0" algn="r">
+            <a:lvl7pPr marL="0" marR="0" lvl="6" indent="0" algn="r" rtl="0">
               <a:lnSpc>
                 <a:spcPct val="100000"/>
               </a:lnSpc>
@@ -3621,7 +3683,7 @@
               <a:buSzPts val="1000"/>
               <a:buFont typeface="Arial"/>
               <a:buNone/>
-              <a:defRPr b="0" i="0" sz="1000" u="none" cap="none" strike="noStrike">
+              <a:defRPr sz="1000" b="0" i="0" u="none" strike="noStrike" cap="none">
                 <a:solidFill>
                   <a:schemeClr val="dk2"/>
                 </a:solidFill>
@@ -3631,7 +3693,7 @@
                 <a:sym typeface="Arial"/>
               </a:defRPr>
             </a:lvl7pPr>
-            <a:lvl8pPr indent="0" lvl="7" marL="0" marR="0" rtl="0" algn="r">
+            <a:lvl8pPr marL="0" marR="0" lvl="7" indent="0" algn="r" rtl="0">
               <a:lnSpc>
                 <a:spcPct val="100000"/>
               </a:lnSpc>
@@ -3647,7 +3709,7 @@
               <a:buSzPts val="1000"/>
               <a:buFont typeface="Arial"/>
               <a:buNone/>
-              <a:defRPr b="0" i="0" sz="1000" u="none" cap="none" strike="noStrike">
+              <a:defRPr sz="1000" b="0" i="0" u="none" strike="noStrike" cap="none">
                 <a:solidFill>
                   <a:schemeClr val="dk2"/>
                 </a:solidFill>
@@ -3657,7 +3719,7 @@
                 <a:sym typeface="Arial"/>
               </a:defRPr>
             </a:lvl8pPr>
-            <a:lvl9pPr indent="0" lvl="8" marL="0" marR="0" rtl="0" algn="r">
+            <a:lvl9pPr marL="0" marR="0" lvl="8" indent="0" algn="r" rtl="0">
               <a:lnSpc>
                 <a:spcPct val="100000"/>
               </a:lnSpc>
@@ -3673,7 +3735,7 @@
               <a:buSzPts val="1000"/>
               <a:buFont typeface="Arial"/>
               <a:buNone/>
-              <a:defRPr b="0" i="0" sz="1000" u="none" cap="none" strike="noStrike">
+              <a:defRPr sz="1000" b="0" i="0" u="none" strike="noStrike" cap="none">
                 <a:solidFill>
                   <a:schemeClr val="dk2"/>
                 </a:solidFill>
@@ -3685,7 +3747,7 @@
             </a:lvl9pPr>
           </a:lstStyle>
           <a:p>
-            <a:pPr indent="0" lvl="0" marL="0" rtl="0" algn="r">
+            <a:pPr marL="0" lvl="0" indent="0" algn="r" rtl="0">
               <a:spcBef>
                 <a:spcPts val="0"/>
               </a:spcBef>
@@ -3704,7 +3766,7 @@
       </p:sp>
     </p:spTree>
   </p:cSld>
-  <p:clrMap accent1="accent1" accent2="accent2" accent3="accent3" accent4="accent4" accent5="accent5" accent6="accent6" bg1="lt1" bg2="dk2" tx1="dk1" tx2="lt2" folHlink="folHlink" hlink="hlink"/>
+  <p:clrMap bg1="lt1" tx1="dk1" bg2="dk2" tx2="lt2" accent1="accent1" accent2="accent2" accent3="accent3" accent4="accent4" accent5="accent5" accent6="accent6" hlink="hlink" folHlink="folHlink"/>
   <p:sldLayoutIdLst>
     <p:sldLayoutId id="2147483648" r:id="rId1"/>
     <p:sldLayoutId id="2147483649" r:id="rId2"/>
@@ -3712,10 +3774,10 @@
     <p:sldLayoutId id="2147483651" r:id="rId4"/>
     <p:sldLayoutId id="2147483652" r:id="rId5"/>
   </p:sldLayoutIdLst>
-  <p:hf dt="0" ftr="0" hdr="0" sldNum="0"/>
+  <p:hf sldNum="0" hdr="0" ftr="0" dt="0"/>
   <p:txStyles>
     <p:titleStyle>
-      <a:defPPr lvl="0" marR="0" rtl="0" algn="l">
+      <a:defPPr marR="0" lvl="0" algn="l" rtl="0">
         <a:lnSpc>
           <a:spcPct val="100000"/>
         </a:lnSpc>
@@ -3726,7 +3788,7 @@
           <a:spcPts val="0"/>
         </a:spcAft>
       </a:defPPr>
-      <a:lvl1pPr lvl="0" marR="0" rtl="0" algn="l">
+      <a:lvl1pPr marR="0" lvl="0" algn="l" rtl="0">
         <a:lnSpc>
           <a:spcPct val="100000"/>
         </a:lnSpc>
@@ -3740,7 +3802,7 @@
           <a:srgbClr val="000000"/>
         </a:buClr>
         <a:buFont typeface="Arial"/>
-        <a:defRPr b="0" i="0" sz="1400" u="none" cap="none" strike="noStrike">
+        <a:defRPr sz="1400" b="0" i="0" u="none" strike="noStrike" cap="none">
           <a:solidFill>
             <a:srgbClr val="000000"/>
           </a:solidFill>
@@ -3750,7 +3812,7 @@
           <a:sym typeface="Arial"/>
         </a:defRPr>
       </a:lvl1pPr>
-      <a:lvl2pPr lvl="1" marR="0" rtl="0" algn="l">
+      <a:lvl2pPr marR="0" lvl="1" algn="l" rtl="0">
         <a:lnSpc>
           <a:spcPct val="100000"/>
         </a:lnSpc>
@@ -3764,7 +3826,7 @@
           <a:srgbClr val="000000"/>
         </a:buClr>
         <a:buFont typeface="Arial"/>
-        <a:defRPr b="0" i="0" sz="1400" u="none" cap="none" strike="noStrike">
+        <a:defRPr sz="1400" b="0" i="0" u="none" strike="noStrike" cap="none">
           <a:solidFill>
             <a:srgbClr val="000000"/>
           </a:solidFill>
@@ -3774,7 +3836,7 @@
           <a:sym typeface="Arial"/>
         </a:defRPr>
       </a:lvl2pPr>
-      <a:lvl3pPr lvl="2" marR="0" rtl="0" algn="l">
+      <a:lvl3pPr marR="0" lvl="2" algn="l" rtl="0">
         <a:lnSpc>
           <a:spcPct val="100000"/>
         </a:lnSpc>
@@ -3788,7 +3850,7 @@
           <a:srgbClr val="000000"/>
         </a:buClr>
         <a:buFont typeface="Arial"/>
-        <a:defRPr b="0" i="0" sz="1400" u="none" cap="none" strike="noStrike">
+        <a:defRPr sz="1400" b="0" i="0" u="none" strike="noStrike" cap="none">
           <a:solidFill>
             <a:srgbClr val="000000"/>
           </a:solidFill>
@@ -3798,7 +3860,7 @@
           <a:sym typeface="Arial"/>
         </a:defRPr>
       </a:lvl3pPr>
-      <a:lvl4pPr lvl="3" marR="0" rtl="0" algn="l">
+      <a:lvl4pPr marR="0" lvl="3" algn="l" rtl="0">
         <a:lnSpc>
           <a:spcPct val="100000"/>
         </a:lnSpc>
@@ -3812,7 +3874,7 @@
           <a:srgbClr val="000000"/>
         </a:buClr>
         <a:buFont typeface="Arial"/>
-        <a:defRPr b="0" i="0" sz="1400" u="none" cap="none" strike="noStrike">
+        <a:defRPr sz="1400" b="0" i="0" u="none" strike="noStrike" cap="none">
           <a:solidFill>
             <a:srgbClr val="000000"/>
           </a:solidFill>
@@ -3822,7 +3884,7 @@
           <a:sym typeface="Arial"/>
         </a:defRPr>
       </a:lvl4pPr>
-      <a:lvl5pPr lvl="4" marR="0" rtl="0" algn="l">
+      <a:lvl5pPr marR="0" lvl="4" algn="l" rtl="0">
         <a:lnSpc>
           <a:spcPct val="100000"/>
         </a:lnSpc>
@@ -3836,7 +3898,7 @@
           <a:srgbClr val="000000"/>
         </a:buClr>
         <a:buFont typeface="Arial"/>
-        <a:defRPr b="0" i="0" sz="1400" u="none" cap="none" strike="noStrike">
+        <a:defRPr sz="1400" b="0" i="0" u="none" strike="noStrike" cap="none">
           <a:solidFill>
             <a:srgbClr val="000000"/>
           </a:solidFill>
@@ -3846,7 +3908,7 @@
           <a:sym typeface="Arial"/>
         </a:defRPr>
       </a:lvl5pPr>
-      <a:lvl6pPr lvl="5" marR="0" rtl="0" algn="l">
+      <a:lvl6pPr marR="0" lvl="5" algn="l" rtl="0">
         <a:lnSpc>
           <a:spcPct val="100000"/>
         </a:lnSpc>
@@ -3860,7 +3922,7 @@
           <a:srgbClr val="000000"/>
         </a:buClr>
         <a:buFont typeface="Arial"/>
-        <a:defRPr b="0" i="0" sz="1400" u="none" cap="none" strike="noStrike">
+        <a:defRPr sz="1400" b="0" i="0" u="none" strike="noStrike" cap="none">
           <a:solidFill>
             <a:srgbClr val="000000"/>
           </a:solidFill>
@@ -3870,7 +3932,7 @@
           <a:sym typeface="Arial"/>
         </a:defRPr>
       </a:lvl6pPr>
-      <a:lvl7pPr lvl="6" marR="0" rtl="0" algn="l">
+      <a:lvl7pPr marR="0" lvl="6" algn="l" rtl="0">
         <a:lnSpc>
           <a:spcPct val="100000"/>
         </a:lnSpc>
@@ -3884,7 +3946,7 @@
           <a:srgbClr val="000000"/>
         </a:buClr>
         <a:buFont typeface="Arial"/>
-        <a:defRPr b="0" i="0" sz="1400" u="none" cap="none" strike="noStrike">
+        <a:defRPr sz="1400" b="0" i="0" u="none" strike="noStrike" cap="none">
           <a:solidFill>
             <a:srgbClr val="000000"/>
           </a:solidFill>
@@ -3894,7 +3956,7 @@
           <a:sym typeface="Arial"/>
         </a:defRPr>
       </a:lvl7pPr>
-      <a:lvl8pPr lvl="7" marR="0" rtl="0" algn="l">
+      <a:lvl8pPr marR="0" lvl="7" algn="l" rtl="0">
         <a:lnSpc>
           <a:spcPct val="100000"/>
         </a:lnSpc>
@@ -3908,7 +3970,7 @@
           <a:srgbClr val="000000"/>
         </a:buClr>
         <a:buFont typeface="Arial"/>
-        <a:defRPr b="0" i="0" sz="1400" u="none" cap="none" strike="noStrike">
+        <a:defRPr sz="1400" b="0" i="0" u="none" strike="noStrike" cap="none">
           <a:solidFill>
             <a:srgbClr val="000000"/>
           </a:solidFill>
@@ -3918,7 +3980,7 @@
           <a:sym typeface="Arial"/>
         </a:defRPr>
       </a:lvl8pPr>
-      <a:lvl9pPr lvl="8" marR="0" rtl="0" algn="l">
+      <a:lvl9pPr marR="0" lvl="8" algn="l" rtl="0">
         <a:lnSpc>
           <a:spcPct val="100000"/>
         </a:lnSpc>
@@ -3932,7 +3994,7 @@
           <a:srgbClr val="000000"/>
         </a:buClr>
         <a:buFont typeface="Arial"/>
-        <a:defRPr b="0" i="0" sz="1400" u="none" cap="none" strike="noStrike">
+        <a:defRPr sz="1400" b="0" i="0" u="none" strike="noStrike" cap="none">
           <a:solidFill>
             <a:srgbClr val="000000"/>
           </a:solidFill>
@@ -3944,7 +4006,7 @@
       </a:lvl9pPr>
     </p:titleStyle>
     <p:bodyStyle>
-      <a:defPPr lvl="0" marR="0" rtl="0" algn="l">
+      <a:defPPr marR="0" lvl="0" algn="l" rtl="0">
         <a:lnSpc>
           <a:spcPct val="100000"/>
         </a:lnSpc>
@@ -3955,7 +4017,7 @@
           <a:spcPts val="0"/>
         </a:spcAft>
       </a:defPPr>
-      <a:lvl1pPr lvl="0" marR="0" rtl="0" algn="l">
+      <a:lvl1pPr marR="0" lvl="0" algn="l" rtl="0">
         <a:lnSpc>
           <a:spcPct val="100000"/>
         </a:lnSpc>
@@ -3969,7 +4031,7 @@
           <a:srgbClr val="000000"/>
         </a:buClr>
         <a:buFont typeface="Arial"/>
-        <a:defRPr b="0" i="0" sz="1400" u="none" cap="none" strike="noStrike">
+        <a:defRPr sz="1400" b="0" i="0" u="none" strike="noStrike" cap="none">
           <a:solidFill>
             <a:srgbClr val="000000"/>
           </a:solidFill>
@@ -3979,7 +4041,7 @@
           <a:sym typeface="Arial"/>
         </a:defRPr>
       </a:lvl1pPr>
-      <a:lvl2pPr lvl="1" marR="0" rtl="0" algn="l">
+      <a:lvl2pPr marR="0" lvl="1" algn="l" rtl="0">
         <a:lnSpc>
           <a:spcPct val="100000"/>
         </a:lnSpc>
@@ -3993,7 +4055,7 @@
           <a:srgbClr val="000000"/>
         </a:buClr>
         <a:buFont typeface="Arial"/>
-        <a:defRPr b="0" i="0" sz="1400" u="none" cap="none" strike="noStrike">
+        <a:defRPr sz="1400" b="0" i="0" u="none" strike="noStrike" cap="none">
           <a:solidFill>
             <a:srgbClr val="000000"/>
           </a:solidFill>
@@ -4003,7 +4065,7 @@
           <a:sym typeface="Arial"/>
         </a:defRPr>
       </a:lvl2pPr>
-      <a:lvl3pPr lvl="2" marR="0" rtl="0" algn="l">
+      <a:lvl3pPr marR="0" lvl="2" algn="l" rtl="0">
         <a:lnSpc>
           <a:spcPct val="100000"/>
         </a:lnSpc>
@@ -4017,7 +4079,7 @@
           <a:srgbClr val="000000"/>
         </a:buClr>
         <a:buFont typeface="Arial"/>
-        <a:defRPr b="0" i="0" sz="1400" u="none" cap="none" strike="noStrike">
+        <a:defRPr sz="1400" b="0" i="0" u="none" strike="noStrike" cap="none">
           <a:solidFill>
             <a:srgbClr val="000000"/>
           </a:solidFill>
@@ -4027,7 +4089,7 @@
           <a:sym typeface="Arial"/>
         </a:defRPr>
       </a:lvl3pPr>
-      <a:lvl4pPr lvl="3" marR="0" rtl="0" algn="l">
+      <a:lvl4pPr marR="0" lvl="3" algn="l" rtl="0">
         <a:lnSpc>
           <a:spcPct val="100000"/>
         </a:lnSpc>
@@ -4041,7 +4103,7 @@
           <a:srgbClr val="000000"/>
         </a:buClr>
         <a:buFont typeface="Arial"/>
-        <a:defRPr b="0" i="0" sz="1400" u="none" cap="none" strike="noStrike">
+        <a:defRPr sz="1400" b="0" i="0" u="none" strike="noStrike" cap="none">
           <a:solidFill>
             <a:srgbClr val="000000"/>
           </a:solidFill>
@@ -4051,7 +4113,7 @@
           <a:sym typeface="Arial"/>
         </a:defRPr>
       </a:lvl4pPr>
-      <a:lvl5pPr lvl="4" marR="0" rtl="0" algn="l">
+      <a:lvl5pPr marR="0" lvl="4" algn="l" rtl="0">
         <a:lnSpc>
           <a:spcPct val="100000"/>
         </a:lnSpc>
@@ -4065,7 +4127,7 @@
           <a:srgbClr val="000000"/>
         </a:buClr>
         <a:buFont typeface="Arial"/>
-        <a:defRPr b="0" i="0" sz="1400" u="none" cap="none" strike="noStrike">
+        <a:defRPr sz="1400" b="0" i="0" u="none" strike="noStrike" cap="none">
           <a:solidFill>
             <a:srgbClr val="000000"/>
           </a:solidFill>
@@ -4075,7 +4137,7 @@
           <a:sym typeface="Arial"/>
         </a:defRPr>
       </a:lvl5pPr>
-      <a:lvl6pPr lvl="5" marR="0" rtl="0" algn="l">
+      <a:lvl6pPr marR="0" lvl="5" algn="l" rtl="0">
         <a:lnSpc>
           <a:spcPct val="100000"/>
         </a:lnSpc>
@@ -4089,7 +4151,7 @@
           <a:srgbClr val="000000"/>
         </a:buClr>
         <a:buFont typeface="Arial"/>
-        <a:defRPr b="0" i="0" sz="1400" u="none" cap="none" strike="noStrike">
+        <a:defRPr sz="1400" b="0" i="0" u="none" strike="noStrike" cap="none">
           <a:solidFill>
             <a:srgbClr val="000000"/>
           </a:solidFill>
@@ -4099,7 +4161,7 @@
           <a:sym typeface="Arial"/>
         </a:defRPr>
       </a:lvl6pPr>
-      <a:lvl7pPr lvl="6" marR="0" rtl="0" algn="l">
+      <a:lvl7pPr marR="0" lvl="6" algn="l" rtl="0">
         <a:lnSpc>
           <a:spcPct val="100000"/>
         </a:lnSpc>
@@ -4113,7 +4175,7 @@
           <a:srgbClr val="000000"/>
         </a:buClr>
         <a:buFont typeface="Arial"/>
-        <a:defRPr b="0" i="0" sz="1400" u="none" cap="none" strike="noStrike">
+        <a:defRPr sz="1400" b="0" i="0" u="none" strike="noStrike" cap="none">
           <a:solidFill>
             <a:srgbClr val="000000"/>
           </a:solidFill>
@@ -4123,7 +4185,7 @@
           <a:sym typeface="Arial"/>
         </a:defRPr>
       </a:lvl7pPr>
-      <a:lvl8pPr lvl="7" marR="0" rtl="0" algn="l">
+      <a:lvl8pPr marR="0" lvl="7" algn="l" rtl="0">
         <a:lnSpc>
           <a:spcPct val="100000"/>
         </a:lnSpc>
@@ -4137,7 +4199,7 @@
           <a:srgbClr val="000000"/>
         </a:buClr>
         <a:buFont typeface="Arial"/>
-        <a:defRPr b="0" i="0" sz="1400" u="none" cap="none" strike="noStrike">
+        <a:defRPr sz="1400" b="0" i="0" u="none" strike="noStrike" cap="none">
           <a:solidFill>
             <a:srgbClr val="000000"/>
           </a:solidFill>
@@ -4147,7 +4209,7 @@
           <a:sym typeface="Arial"/>
         </a:defRPr>
       </a:lvl8pPr>
-      <a:lvl9pPr lvl="8" marR="0" rtl="0" algn="l">
+      <a:lvl9pPr marR="0" lvl="8" algn="l" rtl="0">
         <a:lnSpc>
           <a:spcPct val="100000"/>
         </a:lnSpc>
@@ -4161,7 +4223,7 @@
           <a:srgbClr val="000000"/>
         </a:buClr>
         <a:buFont typeface="Arial"/>
-        <a:defRPr b="0" i="0" sz="1400" u="none" cap="none" strike="noStrike">
+        <a:defRPr sz="1400" b="0" i="0" u="none" strike="noStrike" cap="none">
           <a:solidFill>
             <a:srgbClr val="000000"/>
           </a:solidFill>
@@ -4173,7 +4235,7 @@
       </a:lvl9pPr>
     </p:bodyStyle>
     <p:otherStyle>
-      <a:defPPr lvl="0" marR="0" rtl="0" algn="l">
+      <a:defPPr marR="0" lvl="0" algn="l" rtl="0">
         <a:lnSpc>
           <a:spcPct val="100000"/>
         </a:lnSpc>
@@ -4184,7 +4246,7 @@
           <a:spcPts val="0"/>
         </a:spcAft>
       </a:defPPr>
-      <a:lvl1pPr lvl="0" marR="0" rtl="0" algn="l">
+      <a:lvl1pPr marR="0" lvl="0" algn="l" rtl="0">
         <a:lnSpc>
           <a:spcPct val="100000"/>
         </a:lnSpc>
@@ -4198,7 +4260,7 @@
           <a:srgbClr val="000000"/>
         </a:buClr>
         <a:buFont typeface="Arial"/>
-        <a:defRPr b="0" i="0" sz="1400" u="none" cap="none" strike="noStrike">
+        <a:defRPr sz="1400" b="0" i="0" u="none" strike="noStrike" cap="none">
           <a:solidFill>
             <a:srgbClr val="000000"/>
           </a:solidFill>
@@ -4208,7 +4270,7 @@
           <a:sym typeface="Arial"/>
         </a:defRPr>
       </a:lvl1pPr>
-      <a:lvl2pPr lvl="1" marR="0" rtl="0" algn="l">
+      <a:lvl2pPr marR="0" lvl="1" algn="l" rtl="0">
         <a:lnSpc>
           <a:spcPct val="100000"/>
         </a:lnSpc>
@@ -4222,7 +4284,7 @@
           <a:srgbClr val="000000"/>
         </a:buClr>
         <a:buFont typeface="Arial"/>
-        <a:defRPr b="0" i="0" sz="1400" u="none" cap="none" strike="noStrike">
+        <a:defRPr sz="1400" b="0" i="0" u="none" strike="noStrike" cap="none">
           <a:solidFill>
             <a:srgbClr val="000000"/>
           </a:solidFill>
@@ -4232,7 +4294,7 @@
           <a:sym typeface="Arial"/>
         </a:defRPr>
       </a:lvl2pPr>
-      <a:lvl3pPr lvl="2" marR="0" rtl="0" algn="l">
+      <a:lvl3pPr marR="0" lvl="2" algn="l" rtl="0">
         <a:lnSpc>
           <a:spcPct val="100000"/>
         </a:lnSpc>
@@ -4246,7 +4308,7 @@
           <a:srgbClr val="000000"/>
         </a:buClr>
         <a:buFont typeface="Arial"/>
-        <a:defRPr b="0" i="0" sz="1400" u="none" cap="none" strike="noStrike">
+        <a:defRPr sz="1400" b="0" i="0" u="none" strike="noStrike" cap="none">
           <a:solidFill>
             <a:srgbClr val="000000"/>
           </a:solidFill>
@@ -4256,7 +4318,7 @@
           <a:sym typeface="Arial"/>
         </a:defRPr>
       </a:lvl3pPr>
-      <a:lvl4pPr lvl="3" marR="0" rtl="0" algn="l">
+      <a:lvl4pPr marR="0" lvl="3" algn="l" rtl="0">
         <a:lnSpc>
           <a:spcPct val="100000"/>
         </a:lnSpc>
@@ -4270,7 +4332,7 @@
           <a:srgbClr val="000000"/>
         </a:buClr>
         <a:buFont typeface="Arial"/>
-        <a:defRPr b="0" i="0" sz="1400" u="none" cap="none" strike="noStrike">
+        <a:defRPr sz="1400" b="0" i="0" u="none" strike="noStrike" cap="none">
           <a:solidFill>
             <a:srgbClr val="000000"/>
           </a:solidFill>
@@ -4280,7 +4342,7 @@
           <a:sym typeface="Arial"/>
         </a:defRPr>
       </a:lvl4pPr>
-      <a:lvl5pPr lvl="4" marR="0" rtl="0" algn="l">
+      <a:lvl5pPr marR="0" lvl="4" algn="l" rtl="0">
         <a:lnSpc>
           <a:spcPct val="100000"/>
         </a:lnSpc>
@@ -4294,7 +4356,7 @@
           <a:srgbClr val="000000"/>
         </a:buClr>
         <a:buFont typeface="Arial"/>
-        <a:defRPr b="0" i="0" sz="1400" u="none" cap="none" strike="noStrike">
+        <a:defRPr sz="1400" b="0" i="0" u="none" strike="noStrike" cap="none">
           <a:solidFill>
             <a:srgbClr val="000000"/>
           </a:solidFill>
@@ -4304,7 +4366,7 @@
           <a:sym typeface="Arial"/>
         </a:defRPr>
       </a:lvl5pPr>
-      <a:lvl6pPr lvl="5" marR="0" rtl="0" algn="l">
+      <a:lvl6pPr marR="0" lvl="5" algn="l" rtl="0">
         <a:lnSpc>
           <a:spcPct val="100000"/>
         </a:lnSpc>
@@ -4318,7 +4380,7 @@
           <a:srgbClr val="000000"/>
         </a:buClr>
         <a:buFont typeface="Arial"/>
-        <a:defRPr b="0" i="0" sz="1400" u="none" cap="none" strike="noStrike">
+        <a:defRPr sz="1400" b="0" i="0" u="none" strike="noStrike" cap="none">
           <a:solidFill>
             <a:srgbClr val="000000"/>
           </a:solidFill>
@@ -4328,7 +4390,7 @@
           <a:sym typeface="Arial"/>
         </a:defRPr>
       </a:lvl6pPr>
-      <a:lvl7pPr lvl="6" marR="0" rtl="0" algn="l">
+      <a:lvl7pPr marR="0" lvl="6" algn="l" rtl="0">
         <a:lnSpc>
           <a:spcPct val="100000"/>
         </a:lnSpc>
@@ -4342,7 +4404,7 @@
           <a:srgbClr val="000000"/>
         </a:buClr>
         <a:buFont typeface="Arial"/>
-        <a:defRPr b="0" i="0" sz="1400" u="none" cap="none" strike="noStrike">
+        <a:defRPr sz="1400" b="0" i="0" u="none" strike="noStrike" cap="none">
           <a:solidFill>
             <a:srgbClr val="000000"/>
           </a:solidFill>
@@ -4352,7 +4414,7 @@
           <a:sym typeface="Arial"/>
         </a:defRPr>
       </a:lvl7pPr>
-      <a:lvl8pPr lvl="7" marR="0" rtl="0" algn="l">
+      <a:lvl8pPr marR="0" lvl="7" algn="l" rtl="0">
         <a:lnSpc>
           <a:spcPct val="100000"/>
         </a:lnSpc>
@@ -4366,7 +4428,7 @@
           <a:srgbClr val="000000"/>
         </a:buClr>
         <a:buFont typeface="Arial"/>
-        <a:defRPr b="0" i="0" sz="1400" u="none" cap="none" strike="noStrike">
+        <a:defRPr sz="1400" b="0" i="0" u="none" strike="noStrike" cap="none">
           <a:solidFill>
             <a:srgbClr val="000000"/>
           </a:solidFill>
@@ -4376,7 +4438,7 @@
           <a:sym typeface="Arial"/>
         </a:defRPr>
       </a:lvl8pPr>
-      <a:lvl9pPr lvl="8" marR="0" rtl="0" algn="l">
+      <a:lvl9pPr marR="0" lvl="8" algn="l" rtl="0">
         <a:lnSpc>
           <a:spcPct val="100000"/>
         </a:lnSpc>
@@ -4390,7 +4452,7 @@
           <a:srgbClr val="000000"/>
         </a:buClr>
         <a:buFont typeface="Arial"/>
-        <a:defRPr b="0" i="0" sz="1400" u="none" cap="none" strike="noStrike">
+        <a:defRPr sz="1400" b="0" i="0" u="none" strike="noStrike" cap="none">
           <a:solidFill>
             <a:srgbClr val="000000"/>
           </a:solidFill>
@@ -4406,11 +4468,11 @@
 </file>
 
 <file path=ppt/slides/slide1.xml><?xml version="1.0" encoding="utf-8"?>
-<p:sld xmlns:a="http://schemas.openxmlformats.org/drawingml/2006/main" xmlns:r="http://schemas.openxmlformats.org/officeDocument/2006/relationships" xmlns:mc="http://schemas.openxmlformats.org/markup-compatibility/2006" xmlns:mv="urn:schemas-microsoft-com:mac:vml" xmlns:p="http://schemas.openxmlformats.org/presentationml/2006/main" xmlns:c="http://schemas.openxmlformats.org/drawingml/2006/chart" xmlns:dgm="http://schemas.openxmlformats.org/drawingml/2006/diagram" xmlns:o="urn:schemas-microsoft-com:office:office" xmlns:v="urn:schemas-microsoft-com:vml" xmlns:pvml="urn:schemas-microsoft-com:office:powerpoint" xmlns:com="http://schemas.openxmlformats.org/drawingml/2006/compatibility" xmlns:p14="http://schemas.microsoft.com/office/powerpoint/2010/main" xmlns:p15="http://schemas.microsoft.com/office/powerpoint/2012/main" xmlns:ahyp="http://schemas.microsoft.com/office/drawing/2018/hyperlinkcolor">
+<p:sld xmlns:a="http://schemas.openxmlformats.org/drawingml/2006/main" xmlns:r="http://schemas.openxmlformats.org/officeDocument/2006/relationships" xmlns:p="http://schemas.openxmlformats.org/presentationml/2006/main">
   <p:cSld>
     <p:spTree>
       <p:nvGrpSpPr>
-        <p:cNvPr id="33" name="Shape 33"/>
+        <p:cNvPr id="1" name="Shape 33"/>
         <p:cNvGrpSpPr/>
         <p:nvPr/>
       </p:nvGrpSpPr>
@@ -4444,12 +4506,12 @@
           </a:ln>
         </p:spPr>
         <p:txBody>
-          <a:bodyPr anchorCtr="0" anchor="ctr" bIns="91425" lIns="91425" spcFirstLastPara="1" rIns="91425" wrap="square" tIns="91425">
+          <a:bodyPr spcFirstLastPara="1" wrap="square" lIns="91425" tIns="91425" rIns="91425" bIns="91425" anchor="ctr" anchorCtr="0">
             <a:noAutofit/>
           </a:bodyPr>
           <a:lstStyle/>
           <a:p>
-            <a:pPr indent="0" lvl="0" marL="0" marR="0" rtl="0" algn="ctr">
+            <a:pPr marL="0" marR="0" lvl="0" indent="0" algn="ctr" rtl="0">
               <a:lnSpc>
                 <a:spcPct val="100000"/>
               </a:lnSpc>
@@ -4467,7 +4529,7 @@
               <a:buNone/>
             </a:pPr>
             <a:r>
-              <a:rPr b="1" i="0" lang="en" sz="1200" u="none" cap="none" strike="noStrike">
+              <a:rPr lang="en" sz="1200" b="1" i="0" u="none" strike="noStrike" cap="none">
                 <a:solidFill>
                   <a:srgbClr val="E69138"/>
                 </a:solidFill>
@@ -4478,7 +4540,7 @@
               </a:rPr>
               <a:t>OPEN PAYMENTS</a:t>
             </a:r>
-            <a:endParaRPr b="1" i="0" sz="1200" u="none" cap="none" strike="noStrike">
+            <a:endParaRPr sz="1200" b="1" i="0" u="none" strike="noStrike" cap="none">
               <a:solidFill>
                 <a:srgbClr val="E69138"/>
               </a:solidFill>
@@ -4510,12 +4572,12 @@
           </a:ln>
         </p:spPr>
         <p:txBody>
-          <a:bodyPr anchorCtr="0" anchor="t" bIns="91425" lIns="91425" spcFirstLastPara="1" rIns="91425" wrap="square" tIns="91425">
+          <a:bodyPr spcFirstLastPara="1" wrap="square" lIns="91425" tIns="91425" rIns="91425" bIns="91425" anchor="t" anchorCtr="0">
             <a:spAutoFit/>
           </a:bodyPr>
           <a:lstStyle/>
           <a:p>
-            <a:pPr indent="0" lvl="0" marL="0" marR="0" rtl="0" algn="l">
+            <a:pPr marL="0" marR="0" lvl="0" indent="0" algn="l" rtl="0">
               <a:lnSpc>
                 <a:spcPct val="100000"/>
               </a:lnSpc>
@@ -4533,7 +4595,7 @@
               <a:buNone/>
             </a:pPr>
             <a:r>
-              <a:rPr b="1" i="0" lang="en" sz="3500" u="none" cap="none" strike="noStrike">
+              <a:rPr lang="en-ZA" sz="3500" b="1" i="0" u="none" strike="noStrike" cap="none" dirty="0">
                 <a:solidFill>
                   <a:srgbClr val="EEFF41"/>
                 </a:solidFill>
@@ -4542,9 +4604,9 @@
                 <a:cs typeface="Titillium Web"/>
                 <a:sym typeface="Titillium Web"/>
               </a:rPr>
-              <a:t>{Insert team name}</a:t>
+              <a:t>REMMZ</a:t>
             </a:r>
-            <a:endParaRPr b="1" i="0" sz="2600" u="none" cap="none" strike="noStrike">
+            <a:endParaRPr sz="2600" b="1" i="0" u="none" strike="noStrike" cap="none" dirty="0">
               <a:solidFill>
                 <a:srgbClr val="EEFF41"/>
               </a:solidFill>
@@ -4555,7 +4617,7 @@
             </a:endParaRPr>
           </a:p>
           <a:p>
-            <a:pPr indent="0" lvl="0" marL="0" marR="0" rtl="0" algn="l">
+            <a:pPr marL="0" marR="0" lvl="0" indent="0" algn="l" rtl="0">
               <a:lnSpc>
                 <a:spcPct val="100000"/>
               </a:lnSpc>
@@ -4573,7 +4635,7 @@
               <a:buNone/>
             </a:pPr>
             <a:r>
-              <a:rPr b="0" i="0" lang="en" sz="3000" u="none" cap="none" strike="noStrike">
+              <a:rPr lang="en" sz="3000" b="0" i="0" u="none" strike="noStrike" cap="none" dirty="0">
                 <a:solidFill>
                   <a:srgbClr val="00FFFF"/>
                 </a:solidFill>
@@ -4584,7 +4646,7 @@
               </a:rPr>
               <a:t>Hackathon 2026</a:t>
             </a:r>
-            <a:endParaRPr b="1" i="0" sz="3300" u="none" cap="none" strike="noStrike">
+            <a:endParaRPr sz="3300" b="1" i="0" u="none" strike="noStrike" cap="none" dirty="0">
               <a:solidFill>
                 <a:srgbClr val="00FFFF"/>
               </a:solidFill>
@@ -4606,7 +4668,7 @@
           <a:blip r:embed="rId3">
             <a:alphaModFix/>
           </a:blip>
-          <a:srcRect b="0" l="0" r="0" t="0"/>
+          <a:srcRect/>
           <a:stretch/>
         </p:blipFill>
         <p:spPr>
@@ -4632,11 +4694,11 @@
 </file>
 
 <file path=ppt/slides/slide2.xml><?xml version="1.0" encoding="utf-8"?>
-<p:sld xmlns:a="http://schemas.openxmlformats.org/drawingml/2006/main" xmlns:r="http://schemas.openxmlformats.org/officeDocument/2006/relationships" xmlns:mc="http://schemas.openxmlformats.org/markup-compatibility/2006" xmlns:mv="urn:schemas-microsoft-com:mac:vml" xmlns:p="http://schemas.openxmlformats.org/presentationml/2006/main" xmlns:c="http://schemas.openxmlformats.org/drawingml/2006/chart" xmlns:dgm="http://schemas.openxmlformats.org/drawingml/2006/diagram" xmlns:o="urn:schemas-microsoft-com:office:office" xmlns:v="urn:schemas-microsoft-com:vml" xmlns:pvml="urn:schemas-microsoft-com:office:powerpoint" xmlns:com="http://schemas.openxmlformats.org/drawingml/2006/compatibility" xmlns:p14="http://schemas.microsoft.com/office/powerpoint/2010/main" xmlns:p15="http://schemas.microsoft.com/office/powerpoint/2012/main" xmlns:ahyp="http://schemas.microsoft.com/office/drawing/2018/hyperlinkcolor">
+<p:sld xmlns:a="http://schemas.openxmlformats.org/drawingml/2006/main" xmlns:r="http://schemas.openxmlformats.org/officeDocument/2006/relationships" xmlns:p="http://schemas.openxmlformats.org/presentationml/2006/main">
   <p:cSld>
     <p:spTree>
       <p:nvGrpSpPr>
-        <p:cNvPr id="40" name="Shape 40"/>
+        <p:cNvPr id="1" name="Shape 40"/>
         <p:cNvGrpSpPr/>
         <p:nvPr/>
       </p:nvGrpSpPr>
@@ -4668,12 +4730,12 @@
           </a:ln>
         </p:spPr>
         <p:txBody>
-          <a:bodyPr anchorCtr="0" anchor="t" bIns="19050" lIns="19050" spcFirstLastPara="1" rIns="19050" wrap="square" tIns="19050">
+          <a:bodyPr spcFirstLastPara="1" wrap="square" lIns="19050" tIns="19050" rIns="19050" bIns="19050" anchor="t" anchorCtr="0">
             <a:normAutofit/>
           </a:bodyPr>
           <a:lstStyle/>
           <a:p>
-            <a:pPr indent="0" lvl="0" marL="0" marR="0" rtl="0" algn="l">
+            <a:pPr marL="0" marR="0" lvl="0" indent="0" algn="l" rtl="0">
               <a:lnSpc>
                 <a:spcPct val="90000"/>
               </a:lnSpc>
@@ -4691,7 +4753,7 @@
               <a:buNone/>
             </a:pPr>
             <a:r>
-              <a:rPr b="1" i="0" lang="en" sz="3900" u="none" cap="none" strike="noStrike">
+              <a:rPr lang="en" sz="3900" b="1" i="0" u="none" strike="noStrike" cap="none">
                 <a:solidFill>
                   <a:srgbClr val="00E296"/>
                 </a:solidFill>
@@ -4702,7 +4764,7 @@
               </a:rPr>
               <a:t>Meet the team</a:t>
             </a:r>
-            <a:endParaRPr b="0" i="0" sz="500" u="none" cap="none" strike="noStrike">
+            <a:endParaRPr sz="500" b="0" i="0" u="none" strike="noStrike" cap="none">
               <a:solidFill>
                 <a:srgbClr val="00E296"/>
               </a:solidFill>
@@ -4722,7 +4784,7 @@
         </p:nvSpPr>
         <p:spPr>
           <a:xfrm>
-            <a:off x="405300" y="2187725"/>
+            <a:off x="550049" y="2168594"/>
             <a:ext cx="4620900" cy="1979700"/>
           </a:xfrm>
           <a:prstGeom prst="rect">
@@ -4734,12 +4796,12 @@
           </a:ln>
         </p:spPr>
         <p:txBody>
-          <a:bodyPr anchorCtr="0" anchor="t" bIns="91425" lIns="91425" spcFirstLastPara="1" rIns="91425" wrap="square" tIns="91425">
+          <a:bodyPr spcFirstLastPara="1" wrap="square" lIns="91425" tIns="91425" rIns="91425" bIns="91425" anchor="t" anchorCtr="0">
             <a:noAutofit/>
           </a:bodyPr>
           <a:lstStyle/>
           <a:p>
-            <a:pPr indent="0" lvl="0" marL="0" marR="0" rtl="0" algn="l">
+            <a:pPr marL="0" marR="0" lvl="0" indent="0" algn="l" rtl="0">
               <a:lnSpc>
                 <a:spcPct val="100000"/>
               </a:lnSpc>
@@ -4756,19 +4818,7 @@
               <a:buFont typeface="Arial"/>
               <a:buNone/>
             </a:pPr>
-            <a:r>
-              <a:rPr b="1" i="0" lang="en" sz="1600" u="none" cap="none" strike="noStrike">
-                <a:solidFill>
-                  <a:schemeClr val="lt1"/>
-                </a:solidFill>
-                <a:latin typeface="Titillium Web"/>
-                <a:ea typeface="Titillium Web"/>
-                <a:cs typeface="Titillium Web"/>
-                <a:sym typeface="Titillium Web"/>
-              </a:rPr>
-              <a:t> {Insert your team/solution name}</a:t>
-            </a:r>
-            <a:endParaRPr b="1" i="0" sz="1600" u="none" cap="none" strike="noStrike">
+            <a:endParaRPr sz="1600" b="0" i="0" u="none" strike="noStrike" cap="none" dirty="0">
               <a:solidFill>
                 <a:schemeClr val="lt1"/>
               </a:solidFill>
@@ -4779,27 +4829,36 @@
             </a:endParaRPr>
           </a:p>
           <a:p>
-            <a:pPr indent="0" lvl="0" marL="0" marR="0" rtl="0" algn="l">
-              <a:lnSpc>
-                <a:spcPct val="100000"/>
-              </a:lnSpc>
-              <a:spcBef>
-                <a:spcPts val="0"/>
-              </a:spcBef>
-              <a:spcAft>
-                <a:spcPts val="0"/>
-              </a:spcAft>
-              <a:buClr>
-                <a:schemeClr val="dk1"/>
-              </a:buClr>
-              <a:buSzPts val="1800"/>
-              <a:buFont typeface="Arial"/>
-              <a:buNone/>
+            <a:pPr marL="457200" marR="0" lvl="0" indent="-330200" algn="l" rtl="0">
+              <a:lnSpc>
+                <a:spcPct val="100000"/>
+              </a:lnSpc>
+              <a:spcBef>
+                <a:spcPts val="0"/>
+              </a:spcBef>
+              <a:spcAft>
+                <a:spcPts val="0"/>
+              </a:spcAft>
+              <a:buClr>
+                <a:schemeClr val="lt1"/>
+              </a:buClr>
+              <a:buSzPts val="1600"/>
+              <a:buFont typeface="Titillium Web"/>
+              <a:buChar char="●"/>
             </a:pPr>
             <a:r>
-              <a:t/>
+              <a:rPr lang="en-ZA" sz="1600" dirty="0">
+                <a:solidFill>
+                  <a:schemeClr val="lt1"/>
+                </a:solidFill>
+                <a:latin typeface="Titillium Web"/>
+                <a:ea typeface="Titillium Web"/>
+                <a:cs typeface="Titillium Web"/>
+                <a:sym typeface="Titillium Web"/>
+              </a:rPr>
+              <a:t>Misha Dick</a:t>
             </a:r>
-            <a:endParaRPr b="0" i="0" sz="1600" u="none" cap="none" strike="noStrike">
+            <a:endParaRPr sz="1600" b="0" i="0" u="none" strike="noStrike" cap="none" dirty="0">
               <a:solidFill>
                 <a:schemeClr val="lt1"/>
               </a:solidFill>
@@ -4810,7 +4869,7 @@
             </a:endParaRPr>
           </a:p>
           <a:p>
-            <a:pPr indent="-330200" lvl="0" marL="457200" marR="0" rtl="0" algn="l">
+            <a:pPr marL="457200" marR="0" lvl="0" indent="-330200" algn="l" rtl="0">
               <a:lnSpc>
                 <a:spcPct val="100000"/>
               </a:lnSpc>
@@ -4828,7 +4887,7 @@
               <a:buChar char="●"/>
             </a:pPr>
             <a:r>
-              <a:rPr b="0" i="0" lang="en" sz="1600" u="none" cap="none" strike="noStrike">
+              <a:rPr lang="en" sz="1600" dirty="0">
                 <a:solidFill>
                   <a:schemeClr val="lt1"/>
                 </a:solidFill>
@@ -4837,9 +4896,9 @@
                 <a:cs typeface="Titillium Web"/>
                 <a:sym typeface="Titillium Web"/>
               </a:rPr>
-              <a:t>{Insert your name}</a:t>
+              <a:t>Entisaar Elfadl</a:t>
             </a:r>
-            <a:endParaRPr b="0" i="0" sz="1600" u="none" cap="none" strike="noStrike">
+            <a:endParaRPr sz="1600" b="0" i="0" u="none" strike="noStrike" cap="none" dirty="0">
               <a:solidFill>
                 <a:schemeClr val="lt1"/>
               </a:solidFill>
@@ -4850,7 +4909,7 @@
             </a:endParaRPr>
           </a:p>
           <a:p>
-            <a:pPr indent="-330200" lvl="0" marL="457200" marR="0" rtl="0" algn="l">
+            <a:pPr marL="457200" marR="0" lvl="0" indent="-330200" algn="l" rtl="0">
               <a:lnSpc>
                 <a:spcPct val="100000"/>
               </a:lnSpc>
@@ -4868,7 +4927,7 @@
               <a:buChar char="●"/>
             </a:pPr>
             <a:r>
-              <a:rPr b="0" i="0" lang="en" sz="1600" u="none" cap="none" strike="noStrike">
+              <a:rPr lang="en" sz="1600" dirty="0">
                 <a:solidFill>
                   <a:schemeClr val="lt1"/>
                 </a:solidFill>
@@ -4877,9 +4936,9 @@
                 <a:cs typeface="Titillium Web"/>
                 <a:sym typeface="Titillium Web"/>
               </a:rPr>
-              <a:t>{Insert your name}</a:t>
+              <a:t>Mikaeel Naidoo</a:t>
             </a:r>
-            <a:endParaRPr b="0" i="0" sz="1600" u="none" cap="none" strike="noStrike">
+            <a:endParaRPr sz="1600" b="0" i="0" u="none" strike="noStrike" cap="none" dirty="0">
               <a:solidFill>
                 <a:schemeClr val="lt1"/>
               </a:solidFill>
@@ -4890,7 +4949,7 @@
             </a:endParaRPr>
           </a:p>
           <a:p>
-            <a:pPr indent="-330200" lvl="0" marL="457200" marR="0" rtl="0" algn="l">
+            <a:pPr marL="457200" marR="0" lvl="0" indent="-330200" algn="l" rtl="0">
               <a:lnSpc>
                 <a:spcPct val="100000"/>
               </a:lnSpc>
@@ -4908,7 +4967,7 @@
               <a:buChar char="●"/>
             </a:pPr>
             <a:r>
-              <a:rPr b="0" i="0" lang="en" sz="1600" u="none" cap="none" strike="noStrike">
+              <a:rPr lang="en" sz="1600" dirty="0">
                 <a:solidFill>
                   <a:schemeClr val="lt1"/>
                 </a:solidFill>
@@ -4917,9 +4976,9 @@
                 <a:cs typeface="Titillium Web"/>
                 <a:sym typeface="Titillium Web"/>
               </a:rPr>
-              <a:t>{Insert your name}</a:t>
+              <a:t>Zahra Salie</a:t>
             </a:r>
-            <a:endParaRPr b="0" i="0" sz="1600" u="none" cap="none" strike="noStrike">
+            <a:endParaRPr sz="1600" b="0" i="0" u="none" strike="noStrike" cap="none" dirty="0">
               <a:solidFill>
                 <a:schemeClr val="lt1"/>
               </a:solidFill>
@@ -4930,7 +4989,7 @@
             </a:endParaRPr>
           </a:p>
           <a:p>
-            <a:pPr indent="-330200" lvl="0" marL="457200" marR="0" rtl="0" algn="l">
+            <a:pPr marL="457200" marR="0" lvl="0" indent="-330200" algn="l" rtl="0">
               <a:lnSpc>
                 <a:spcPct val="100000"/>
               </a:lnSpc>
@@ -4948,7 +5007,7 @@
               <a:buChar char="●"/>
             </a:pPr>
             <a:r>
-              <a:rPr b="0" i="0" lang="en" sz="1600" u="none" cap="none" strike="noStrike">
+              <a:rPr lang="en" sz="1600" dirty="0">
                 <a:solidFill>
                   <a:schemeClr val="lt1"/>
                 </a:solidFill>
@@ -4957,49 +5016,9 @@
                 <a:cs typeface="Titillium Web"/>
                 <a:sym typeface="Titillium Web"/>
               </a:rPr>
-              <a:t>{Insert your name}</a:t>
+              <a:t>Moegamat Rashaad Samsodien</a:t>
             </a:r>
-            <a:endParaRPr b="0" i="0" sz="1600" u="none" cap="none" strike="noStrike">
-              <a:solidFill>
-                <a:schemeClr val="lt1"/>
-              </a:solidFill>
-              <a:latin typeface="Titillium Web"/>
-              <a:ea typeface="Titillium Web"/>
-              <a:cs typeface="Titillium Web"/>
-              <a:sym typeface="Titillium Web"/>
-            </a:endParaRPr>
-          </a:p>
-          <a:p>
-            <a:pPr indent="-330200" lvl="0" marL="457200" marR="0" rtl="0" algn="l">
-              <a:lnSpc>
-                <a:spcPct val="100000"/>
-              </a:lnSpc>
-              <a:spcBef>
-                <a:spcPts val="0"/>
-              </a:spcBef>
-              <a:spcAft>
-                <a:spcPts val="0"/>
-              </a:spcAft>
-              <a:buClr>
-                <a:schemeClr val="lt1"/>
-              </a:buClr>
-              <a:buSzPts val="1600"/>
-              <a:buFont typeface="Titillium Web"/>
-              <a:buChar char="●"/>
-            </a:pPr>
-            <a:r>
-              <a:rPr b="0" i="0" lang="en" sz="1600" u="none" cap="none" strike="noStrike">
-                <a:solidFill>
-                  <a:schemeClr val="lt1"/>
-                </a:solidFill>
-                <a:latin typeface="Titillium Web"/>
-                <a:ea typeface="Titillium Web"/>
-                <a:cs typeface="Titillium Web"/>
-                <a:sym typeface="Titillium Web"/>
-              </a:rPr>
-              <a:t>{Insert your name}</a:t>
-            </a:r>
-            <a:endParaRPr b="0" i="0" sz="1600" u="none" cap="none" strike="noStrike">
+            <a:endParaRPr sz="1600" b="0" i="0" u="none" strike="noStrike" cap="none" dirty="0">
               <a:solidFill>
                 <a:schemeClr val="lt1"/>
               </a:solidFill>
@@ -5026,14 +5045,14 @@
             <a:avLst/>
           </a:prstGeom>
           <a:noFill/>
-          <a:ln cap="flat" cmpd="sng" w="9525">
+          <a:ln w="9525" cap="flat" cmpd="sng">
             <a:solidFill>
               <a:srgbClr val="00E296"/>
             </a:solidFill>
             <a:prstDash val="solid"/>
             <a:round/>
-            <a:headEnd len="sm" w="sm" type="none"/>
-            <a:tailEnd len="med" w="med" type="stealth"/>
+            <a:headEnd type="none" w="sm" len="sm"/>
+            <a:tailEnd type="stealth" w="med" len="med"/>
           </a:ln>
         </p:spPr>
       </p:cxnSp>
@@ -5054,23 +5073,23 @@
           <a:solidFill>
             <a:srgbClr val="FFFFFF"/>
           </a:solidFill>
-          <a:ln cap="flat" cmpd="sng" w="9525">
+          <a:ln w="9525" cap="flat" cmpd="sng">
             <a:solidFill>
               <a:srgbClr val="595959"/>
             </a:solidFill>
             <a:prstDash val="solid"/>
             <a:round/>
-            <a:headEnd len="sm" w="sm" type="none"/>
-            <a:tailEnd len="sm" w="sm" type="none"/>
+            <a:headEnd type="none" w="sm" len="sm"/>
+            <a:tailEnd type="none" w="sm" len="sm"/>
           </a:ln>
         </p:spPr>
         <p:txBody>
-          <a:bodyPr anchorCtr="0" anchor="ctr" bIns="91425" lIns="91425" spcFirstLastPara="1" rIns="91425" wrap="square" tIns="91425">
+          <a:bodyPr spcFirstLastPara="1" wrap="square" lIns="91425" tIns="91425" rIns="91425" bIns="91425" anchor="ctr" anchorCtr="0">
             <a:noAutofit/>
           </a:bodyPr>
           <a:lstStyle/>
           <a:p>
-            <a:pPr indent="0" lvl="0" marL="0" marR="0" rtl="0" algn="ctr">
+            <a:pPr marL="0" marR="0" lvl="0" indent="0" algn="ctr" rtl="0">
               <a:lnSpc>
                 <a:spcPct val="100000"/>
               </a:lnSpc>
@@ -5088,7 +5107,7 @@
               <a:buNone/>
             </a:pPr>
             <a:r>
-              <a:rPr b="0" i="0" lang="en" sz="1600" u="none" cap="none" strike="noStrike">
+              <a:rPr lang="en" sz="1600" b="0" i="0" u="none" strike="noStrike" cap="none">
                 <a:solidFill>
                   <a:srgbClr val="374151"/>
                 </a:solidFill>
@@ -5099,7 +5118,7 @@
               </a:rPr>
               <a:t>{Insert photo of your team}</a:t>
             </a:r>
-            <a:endParaRPr b="0" i="0" sz="1600" u="none" cap="none" strike="noStrike">
+            <a:endParaRPr sz="1600" b="0" i="0" u="none" strike="noStrike" cap="none">
               <a:solidFill>
                 <a:srgbClr val="374151"/>
               </a:solidFill>
@@ -5121,7 +5140,7 @@
           <a:blip r:embed="rId3">
             <a:alphaModFix/>
           </a:blip>
-          <a:srcRect b="0" l="0" r="0" t="0"/>
+          <a:srcRect/>
           <a:stretch/>
         </p:blipFill>
         <p:spPr>
@@ -5147,11 +5166,11 @@
 </file>
 
 <file path=ppt/slides/slide3.xml><?xml version="1.0" encoding="utf-8"?>
-<p:sld xmlns:a="http://schemas.openxmlformats.org/drawingml/2006/main" xmlns:r="http://schemas.openxmlformats.org/officeDocument/2006/relationships" xmlns:mc="http://schemas.openxmlformats.org/markup-compatibility/2006" xmlns:mv="urn:schemas-microsoft-com:mac:vml" xmlns:p="http://schemas.openxmlformats.org/presentationml/2006/main" xmlns:c="http://schemas.openxmlformats.org/drawingml/2006/chart" xmlns:dgm="http://schemas.openxmlformats.org/drawingml/2006/diagram" xmlns:o="urn:schemas-microsoft-com:office:office" xmlns:v="urn:schemas-microsoft-com:vml" xmlns:pvml="urn:schemas-microsoft-com:office:powerpoint" xmlns:com="http://schemas.openxmlformats.org/drawingml/2006/compatibility" xmlns:p14="http://schemas.microsoft.com/office/powerpoint/2010/main" xmlns:p15="http://schemas.microsoft.com/office/powerpoint/2012/main" xmlns:ahyp="http://schemas.microsoft.com/office/drawing/2018/hyperlinkcolor">
+<p:sld xmlns:a="http://schemas.openxmlformats.org/drawingml/2006/main" xmlns:r="http://schemas.openxmlformats.org/officeDocument/2006/relationships" xmlns:p="http://schemas.openxmlformats.org/presentationml/2006/main">
   <p:cSld>
     <p:spTree>
       <p:nvGrpSpPr>
-        <p:cNvPr id="49" name="Shape 49"/>
+        <p:cNvPr id="1" name="Shape 49"/>
         <p:cNvGrpSpPr/>
         <p:nvPr/>
       </p:nvGrpSpPr>
@@ -5183,12 +5202,12 @@
           </a:ln>
         </p:spPr>
         <p:txBody>
-          <a:bodyPr anchorCtr="0" anchor="t" bIns="19050" lIns="19050" spcFirstLastPara="1" rIns="19050" wrap="square" tIns="19050">
+          <a:bodyPr spcFirstLastPara="1" wrap="square" lIns="19050" tIns="19050" rIns="19050" bIns="19050" anchor="t" anchorCtr="0">
             <a:normAutofit/>
           </a:bodyPr>
           <a:lstStyle/>
           <a:p>
-            <a:pPr indent="0" lvl="0" marL="0" marR="0" rtl="0" algn="l">
+            <a:pPr marL="0" marR="0" lvl="0" indent="0" algn="l" rtl="0">
               <a:lnSpc>
                 <a:spcPct val="90000"/>
               </a:lnSpc>
@@ -5206,7 +5225,7 @@
               <a:buNone/>
             </a:pPr>
             <a:r>
-              <a:rPr b="1" i="0" lang="en" sz="3900" u="none" cap="none" strike="noStrike">
+              <a:rPr lang="en" sz="3900" b="1" i="0" u="none" strike="noStrike" cap="none">
                 <a:solidFill>
                   <a:srgbClr val="00E296"/>
                 </a:solidFill>
@@ -5217,7 +5236,7 @@
               </a:rPr>
               <a:t>Problem statement</a:t>
             </a:r>
-            <a:endParaRPr b="0" i="0" sz="500" u="none" cap="none" strike="noStrike">
+            <a:endParaRPr sz="500" b="0" i="0" u="none" strike="noStrike" cap="none">
               <a:solidFill>
                 <a:srgbClr val="00E296"/>
               </a:solidFill>
@@ -5249,12 +5268,12 @@
           </a:ln>
         </p:spPr>
         <p:txBody>
-          <a:bodyPr anchorCtr="0" anchor="t" bIns="91425" lIns="91425" spcFirstLastPara="1" rIns="91425" wrap="square" tIns="91425">
+          <a:bodyPr spcFirstLastPara="1" wrap="square" lIns="91425" tIns="91425" rIns="91425" bIns="91425" anchor="t" anchorCtr="0">
             <a:noAutofit/>
           </a:bodyPr>
           <a:lstStyle/>
           <a:p>
-            <a:pPr indent="-330200" lvl="0" marL="457200" marR="0" rtl="0" algn="l">
+            <a:pPr marL="457200" marR="0" lvl="0" indent="-330200" algn="l" rtl="0">
               <a:lnSpc>
                 <a:spcPct val="100000"/>
               </a:lnSpc>
@@ -5272,7 +5291,7 @@
               <a:buChar char="●"/>
             </a:pPr>
             <a:r>
-              <a:rPr b="0" i="0" lang="en" sz="1600" u="none" cap="none" strike="noStrike">
+              <a:rPr lang="en" sz="1600" b="0" i="0" u="none" strike="noStrike" cap="none">
                 <a:solidFill>
                   <a:schemeClr val="lt1"/>
                 </a:solidFill>
@@ -5284,7 +5303,7 @@
               <a:t>{Insert </a:t>
             </a:r>
             <a:r>
-              <a:rPr b="1" i="0" lang="en" sz="1600" u="none" cap="none" strike="noStrike">
+              <a:rPr lang="en" sz="1600" b="1" i="0" u="none" strike="noStrike" cap="none">
                 <a:solidFill>
                   <a:schemeClr val="lt1"/>
                 </a:solidFill>
@@ -5296,7 +5315,7 @@
               <a:t>the problem</a:t>
             </a:r>
             <a:r>
-              <a:rPr b="0" i="0" lang="en" sz="1600" u="none" cap="none" strike="noStrike">
+              <a:rPr lang="en" sz="1600" b="0" i="0" u="none" strike="noStrike" cap="none">
                 <a:solidFill>
                   <a:schemeClr val="lt1"/>
                 </a:solidFill>
@@ -5307,7 +5326,7 @@
               </a:rPr>
               <a:t> that your hackathon solution solves}</a:t>
             </a:r>
-            <a:endParaRPr b="0" i="0" sz="1600" u="none" cap="none" strike="noStrike">
+            <a:endParaRPr sz="1600" b="0" i="0" u="none" strike="noStrike" cap="none">
               <a:solidFill>
                 <a:schemeClr val="lt1"/>
               </a:solidFill>
@@ -5318,7 +5337,7 @@
             </a:endParaRPr>
           </a:p>
           <a:p>
-            <a:pPr indent="0" lvl="0" marL="457200" marR="0" rtl="0" algn="l">
+            <a:pPr marL="457200" marR="0" lvl="0" indent="0" algn="l" rtl="0">
               <a:lnSpc>
                 <a:spcPct val="100000"/>
               </a:lnSpc>
@@ -5335,10 +5354,7 @@
               <a:buFont typeface="Arial"/>
               <a:buNone/>
             </a:pPr>
-            <a:r>
-              <a:t/>
-            </a:r>
-            <a:endParaRPr b="0" i="0" sz="1600" u="none" cap="none" strike="noStrike">
+            <a:endParaRPr sz="1600" b="0" i="0" u="none" strike="noStrike" cap="none">
               <a:solidFill>
                 <a:schemeClr val="lt1"/>
               </a:solidFill>
@@ -5349,7 +5365,7 @@
             </a:endParaRPr>
           </a:p>
           <a:p>
-            <a:pPr indent="-330200" lvl="0" marL="457200" marR="0" rtl="0" algn="l">
+            <a:pPr marL="457200" marR="0" lvl="0" indent="-330200" algn="l" rtl="0">
               <a:lnSpc>
                 <a:spcPct val="100000"/>
               </a:lnSpc>
@@ -5367,7 +5383,7 @@
               <a:buChar char="●"/>
             </a:pPr>
             <a:r>
-              <a:rPr b="0" i="0" lang="en" sz="1600" u="none" cap="none" strike="noStrike">
+              <a:rPr lang="en" sz="1600" b="0" i="0" u="none" strike="noStrike" cap="none">
                 <a:solidFill>
                   <a:schemeClr val="lt1"/>
                 </a:solidFill>
@@ -5379,7 +5395,7 @@
               <a:t>{Insert </a:t>
             </a:r>
             <a:r>
-              <a:rPr b="1" i="0" lang="en" sz="1600" u="none" cap="none" strike="noStrike">
+              <a:rPr lang="en" sz="1600" b="1" i="0" u="none" strike="noStrike" cap="none">
                 <a:solidFill>
                   <a:schemeClr val="lt1"/>
                 </a:solidFill>
@@ -5391,7 +5407,7 @@
               <a:t>why</a:t>
             </a:r>
             <a:r>
-              <a:rPr b="0" i="0" lang="en" sz="1600" u="none" cap="none" strike="noStrike">
+              <a:rPr lang="en" sz="1600" b="0" i="0" u="none" strike="noStrike" cap="none">
                 <a:solidFill>
                   <a:schemeClr val="lt1"/>
                 </a:solidFill>
@@ -5402,7 +5418,7 @@
               </a:rPr>
               <a:t> your team is tackling it, what are the benefits?} </a:t>
             </a:r>
-            <a:endParaRPr b="0" i="0" sz="1600" u="none" cap="none" strike="noStrike">
+            <a:endParaRPr sz="1600" b="0" i="0" u="none" strike="noStrike" cap="none">
               <a:solidFill>
                 <a:schemeClr val="lt1"/>
               </a:solidFill>
@@ -5429,14 +5445,14 @@
             <a:avLst/>
           </a:prstGeom>
           <a:noFill/>
-          <a:ln cap="flat" cmpd="sng" w="9525">
+          <a:ln w="9525" cap="flat" cmpd="sng">
             <a:solidFill>
               <a:srgbClr val="00E296"/>
             </a:solidFill>
             <a:prstDash val="solid"/>
             <a:round/>
-            <a:headEnd len="sm" w="sm" type="none"/>
-            <a:tailEnd len="med" w="med" type="stealth"/>
+            <a:headEnd type="none" w="sm" len="sm"/>
+            <a:tailEnd type="stealth" w="med" len="med"/>
           </a:ln>
         </p:spPr>
       </p:cxnSp>
@@ -5450,7 +5466,7 @@
           <a:blip r:embed="rId3">
             <a:alphaModFix/>
           </a:blip>
-          <a:srcRect b="0" l="0" r="0" t="0"/>
+          <a:srcRect/>
           <a:stretch/>
         </p:blipFill>
         <p:spPr>
@@ -5476,11 +5492,11 @@
 </file>
 
 <file path=ppt/slides/slide4.xml><?xml version="1.0" encoding="utf-8"?>
-<p:sld xmlns:a="http://schemas.openxmlformats.org/drawingml/2006/main" xmlns:r="http://schemas.openxmlformats.org/officeDocument/2006/relationships" xmlns:mc="http://schemas.openxmlformats.org/markup-compatibility/2006" xmlns:mv="urn:schemas-microsoft-com:mac:vml" xmlns:p="http://schemas.openxmlformats.org/presentationml/2006/main" xmlns:c="http://schemas.openxmlformats.org/drawingml/2006/chart" xmlns:dgm="http://schemas.openxmlformats.org/drawingml/2006/diagram" xmlns:o="urn:schemas-microsoft-com:office:office" xmlns:v="urn:schemas-microsoft-com:vml" xmlns:pvml="urn:schemas-microsoft-com:office:powerpoint" xmlns:com="http://schemas.openxmlformats.org/drawingml/2006/compatibility" xmlns:p14="http://schemas.microsoft.com/office/powerpoint/2010/main" xmlns:p15="http://schemas.microsoft.com/office/powerpoint/2012/main" xmlns:ahyp="http://schemas.microsoft.com/office/drawing/2018/hyperlinkcolor">
+<p:sld xmlns:a="http://schemas.openxmlformats.org/drawingml/2006/main" xmlns:r="http://schemas.openxmlformats.org/officeDocument/2006/relationships" xmlns:p="http://schemas.openxmlformats.org/presentationml/2006/main">
   <p:cSld>
     <p:spTree>
       <p:nvGrpSpPr>
-        <p:cNvPr id="57" name="Shape 57"/>
+        <p:cNvPr id="1" name="Shape 57"/>
         <p:cNvGrpSpPr/>
         <p:nvPr/>
       </p:nvGrpSpPr>
@@ -5512,12 +5528,12 @@
           </a:ln>
         </p:spPr>
         <p:txBody>
-          <a:bodyPr anchorCtr="0" anchor="t" bIns="19050" lIns="19050" spcFirstLastPara="1" rIns="19050" wrap="square" tIns="19050">
+          <a:bodyPr spcFirstLastPara="1" wrap="square" lIns="19050" tIns="19050" rIns="19050" bIns="19050" anchor="t" anchorCtr="0">
             <a:normAutofit/>
           </a:bodyPr>
           <a:lstStyle/>
           <a:p>
-            <a:pPr indent="0" lvl="0" marL="0" marR="0" rtl="0" algn="l">
+            <a:pPr marL="0" marR="0" lvl="0" indent="0" algn="l" rtl="0">
               <a:lnSpc>
                 <a:spcPct val="90000"/>
               </a:lnSpc>
@@ -5535,7 +5551,7 @@
               <a:buNone/>
             </a:pPr>
             <a:r>
-              <a:rPr b="1" i="0" lang="en" sz="3900" u="none" cap="none" strike="noStrike">
+              <a:rPr lang="en" sz="3900" b="1" i="0" u="none" strike="noStrike" cap="none">
                 <a:solidFill>
                   <a:srgbClr val="00E296"/>
                 </a:solidFill>
@@ -5546,7 +5562,7 @@
               </a:rPr>
               <a:t>Solution</a:t>
             </a:r>
-            <a:endParaRPr b="0" i="0" sz="500" u="none" cap="none" strike="noStrike">
+            <a:endParaRPr sz="500" b="0" i="0" u="none" strike="noStrike" cap="none">
               <a:solidFill>
                 <a:srgbClr val="00E296"/>
               </a:solidFill>
@@ -5578,12 +5594,12 @@
           </a:ln>
         </p:spPr>
         <p:txBody>
-          <a:bodyPr anchorCtr="0" anchor="t" bIns="91425" lIns="91425" spcFirstLastPara="1" rIns="91425" wrap="square" tIns="91425">
+          <a:bodyPr spcFirstLastPara="1" wrap="square" lIns="91425" tIns="91425" rIns="91425" bIns="91425" anchor="t" anchorCtr="0">
             <a:noAutofit/>
           </a:bodyPr>
           <a:lstStyle/>
           <a:p>
-            <a:pPr indent="0" lvl="0" marL="0" marR="0" rtl="0" algn="l">
+            <a:pPr marL="0" marR="0" lvl="0" indent="0" algn="l" rtl="0">
               <a:lnSpc>
                 <a:spcPct val="100000"/>
               </a:lnSpc>
@@ -5601,7 +5617,7 @@
               <a:buNone/>
             </a:pPr>
             <a:r>
-              <a:rPr b="1" i="0" lang="en" sz="1600" u="none" cap="none" strike="noStrike">
+              <a:rPr lang="en" sz="1600" b="1" i="0" u="none" strike="noStrike" cap="none">
                 <a:solidFill>
                   <a:schemeClr val="lt1"/>
                 </a:solidFill>
@@ -5612,7 +5628,7 @@
               </a:rPr>
               <a:t>{Describe how your solutions works</a:t>
             </a:r>
-            <a:endParaRPr b="1" i="0" sz="1600" u="none" cap="none" strike="noStrike">
+            <a:endParaRPr sz="1600" b="1" i="0" u="none" strike="noStrike" cap="none">
               <a:solidFill>
                 <a:schemeClr val="lt1"/>
               </a:solidFill>
@@ -5623,7 +5639,7 @@
             </a:endParaRPr>
           </a:p>
           <a:p>
-            <a:pPr indent="-330200" lvl="0" marL="457200" marR="0" rtl="0" algn="l">
+            <a:pPr marL="457200" marR="0" lvl="0" indent="-330200" algn="l" rtl="0">
               <a:lnSpc>
                 <a:spcPct val="100000"/>
               </a:lnSpc>
@@ -5641,7 +5657,7 @@
               <a:buChar char="●"/>
             </a:pPr>
             <a:r>
-              <a:rPr b="0" i="0" lang="en" sz="1600" u="none" cap="none" strike="noStrike">
+              <a:rPr lang="en" sz="1600" b="0" i="0" u="none" strike="noStrike" cap="none">
                 <a:solidFill>
                   <a:schemeClr val="lt1"/>
                 </a:solidFill>
@@ -5652,7 +5668,7 @@
               </a:rPr>
               <a:t>Include a one-page diagram/workflow of your solution</a:t>
             </a:r>
-            <a:endParaRPr b="0" i="0" sz="1600" u="none" cap="none" strike="noStrike">
+            <a:endParaRPr sz="1600" b="0" i="0" u="none" strike="noStrike" cap="none">
               <a:solidFill>
                 <a:schemeClr val="lt1"/>
               </a:solidFill>
@@ -5663,7 +5679,7 @@
             </a:endParaRPr>
           </a:p>
           <a:p>
-            <a:pPr indent="-330200" lvl="0" marL="457200" marR="0" rtl="0" algn="l">
+            <a:pPr marL="457200" marR="0" lvl="0" indent="-330200" algn="l" rtl="0">
               <a:lnSpc>
                 <a:spcPct val="100000"/>
               </a:lnSpc>
@@ -5681,7 +5697,7 @@
               <a:buChar char="●"/>
             </a:pPr>
             <a:r>
-              <a:rPr b="0" i="0" lang="en" sz="1600" u="none" cap="none" strike="noStrike">
+              <a:rPr lang="en" sz="1600" b="0" i="0" u="none" strike="noStrike" cap="none">
                 <a:solidFill>
                   <a:schemeClr val="lt1"/>
                 </a:solidFill>
@@ -5692,7 +5708,7 @@
               </a:rPr>
               <a:t>Include the tools you used </a:t>
             </a:r>
-            <a:endParaRPr b="0" i="0" sz="1600" u="none" cap="none" strike="noStrike">
+            <a:endParaRPr sz="1600" b="0" i="0" u="none" strike="noStrike" cap="none">
               <a:solidFill>
                 <a:schemeClr val="lt1"/>
               </a:solidFill>
@@ -5703,7 +5719,7 @@
             </a:endParaRPr>
           </a:p>
           <a:p>
-            <a:pPr indent="-330200" lvl="0" marL="457200" marR="0" rtl="0" algn="l">
+            <a:pPr marL="457200" marR="0" lvl="0" indent="-330200" algn="l" rtl="0">
               <a:lnSpc>
                 <a:spcPct val="100000"/>
               </a:lnSpc>
@@ -5721,7 +5737,7 @@
               <a:buChar char="●"/>
             </a:pPr>
             <a:r>
-              <a:rPr b="0" i="0" lang="en" sz="1600" u="none" cap="none" strike="noStrike">
+              <a:rPr lang="en" sz="1600" b="0" i="0" u="none" strike="noStrike" cap="none">
                 <a:solidFill>
                   <a:schemeClr val="lt1"/>
                 </a:solidFill>
@@ -5732,7 +5748,7 @@
               </a:rPr>
               <a:t>Describe why your solution is unique}</a:t>
             </a:r>
-            <a:endParaRPr b="0" i="0" sz="1600" u="none" cap="none" strike="noStrike">
+            <a:endParaRPr sz="1600" b="0" i="0" u="none" strike="noStrike" cap="none">
               <a:solidFill>
                 <a:schemeClr val="lt1"/>
               </a:solidFill>
@@ -5759,14 +5775,14 @@
             <a:avLst/>
           </a:prstGeom>
           <a:noFill/>
-          <a:ln cap="flat" cmpd="sng" w="9525">
+          <a:ln w="9525" cap="flat" cmpd="sng">
             <a:solidFill>
               <a:srgbClr val="00E296"/>
             </a:solidFill>
             <a:prstDash val="solid"/>
             <a:round/>
-            <a:headEnd len="sm" w="sm" type="none"/>
-            <a:tailEnd len="med" w="med" type="stealth"/>
+            <a:headEnd type="none" w="sm" len="sm"/>
+            <a:tailEnd type="stealth" w="med" len="med"/>
           </a:ln>
         </p:spPr>
       </p:cxnSp>
@@ -5780,7 +5796,7 @@
           <a:blip r:embed="rId3">
             <a:alphaModFix/>
           </a:blip>
-          <a:srcRect b="0" l="0" r="0" t="0"/>
+          <a:srcRect/>
           <a:stretch/>
         </p:blipFill>
         <p:spPr>
@@ -5806,11 +5822,11 @@
 </file>
 
 <file path=ppt/slides/slide5.xml><?xml version="1.0" encoding="utf-8"?>
-<p:sld xmlns:a="http://schemas.openxmlformats.org/drawingml/2006/main" xmlns:r="http://schemas.openxmlformats.org/officeDocument/2006/relationships" xmlns:mc="http://schemas.openxmlformats.org/markup-compatibility/2006" xmlns:mv="urn:schemas-microsoft-com:mac:vml" xmlns:p="http://schemas.openxmlformats.org/presentationml/2006/main" xmlns:c="http://schemas.openxmlformats.org/drawingml/2006/chart" xmlns:dgm="http://schemas.openxmlformats.org/drawingml/2006/diagram" xmlns:o="urn:schemas-microsoft-com:office:office" xmlns:v="urn:schemas-microsoft-com:vml" xmlns:pvml="urn:schemas-microsoft-com:office:powerpoint" xmlns:com="http://schemas.openxmlformats.org/drawingml/2006/compatibility" xmlns:p14="http://schemas.microsoft.com/office/powerpoint/2010/main" xmlns:p15="http://schemas.microsoft.com/office/powerpoint/2012/main" xmlns:ahyp="http://schemas.microsoft.com/office/drawing/2018/hyperlinkcolor">
+<p:sld xmlns:a="http://schemas.openxmlformats.org/drawingml/2006/main" xmlns:r="http://schemas.openxmlformats.org/officeDocument/2006/relationships" xmlns:p="http://schemas.openxmlformats.org/presentationml/2006/main">
   <p:cSld>
     <p:spTree>
       <p:nvGrpSpPr>
-        <p:cNvPr id="65" name="Shape 65"/>
+        <p:cNvPr id="1" name="Shape 65"/>
         <p:cNvGrpSpPr/>
         <p:nvPr/>
       </p:nvGrpSpPr>
@@ -5842,12 +5858,12 @@
           </a:ln>
         </p:spPr>
         <p:txBody>
-          <a:bodyPr anchorCtr="0" anchor="t" bIns="19050" lIns="19050" spcFirstLastPara="1" rIns="19050" wrap="square" tIns="19050">
+          <a:bodyPr spcFirstLastPara="1" wrap="square" lIns="19050" tIns="19050" rIns="19050" bIns="19050" anchor="t" anchorCtr="0">
             <a:normAutofit/>
           </a:bodyPr>
           <a:lstStyle/>
           <a:p>
-            <a:pPr indent="0" lvl="0" marL="0" marR="0" rtl="0" algn="l">
+            <a:pPr marL="0" marR="0" lvl="0" indent="0" algn="l" rtl="0">
               <a:lnSpc>
                 <a:spcPct val="90000"/>
               </a:lnSpc>
@@ -5865,7 +5881,7 @@
               <a:buNone/>
             </a:pPr>
             <a:r>
-              <a:rPr b="1" i="0" lang="en" sz="3900" u="none" cap="none" strike="noStrike">
+              <a:rPr lang="en" sz="3900" b="1" i="0" u="none" strike="noStrike" cap="none">
                 <a:solidFill>
                   <a:schemeClr val="accent6"/>
                 </a:solidFill>
@@ -5876,7 +5892,7 @@
               </a:rPr>
               <a:t>Demo</a:t>
             </a:r>
-            <a:endParaRPr b="0" i="0" sz="500" u="none" cap="none" strike="noStrike">
+            <a:endParaRPr sz="500" b="0" i="0" u="none" strike="noStrike" cap="none">
               <a:solidFill>
                 <a:schemeClr val="accent6"/>
               </a:solidFill>
@@ -5908,12 +5924,12 @@
           </a:ln>
         </p:spPr>
         <p:txBody>
-          <a:bodyPr anchorCtr="0" anchor="t" bIns="91425" lIns="91425" spcFirstLastPara="1" rIns="91425" wrap="square" tIns="91425">
+          <a:bodyPr spcFirstLastPara="1" wrap="square" lIns="91425" tIns="91425" rIns="91425" bIns="91425" anchor="t" anchorCtr="0">
             <a:noAutofit/>
           </a:bodyPr>
           <a:lstStyle/>
           <a:p>
-            <a:pPr indent="-330200" lvl="0" marL="457200" marR="0" rtl="0" algn="l">
+            <a:pPr marL="457200" marR="0" lvl="0" indent="-330200" algn="l" rtl="0">
               <a:lnSpc>
                 <a:spcPct val="100000"/>
               </a:lnSpc>
@@ -5931,7 +5947,7 @@
               <a:buChar char="●"/>
             </a:pPr>
             <a:r>
-              <a:rPr b="0" i="0" lang="en" sz="1600" u="none" cap="none" strike="noStrike">
+              <a:rPr lang="en" sz="1600" b="0" i="0" u="none" strike="noStrike" cap="none">
                 <a:solidFill>
                   <a:schemeClr val="lt1"/>
                 </a:solidFill>
@@ -5943,7 +5959,7 @@
               <a:t>{Showcase </a:t>
             </a:r>
             <a:r>
-              <a:rPr b="1" i="0" lang="en" sz="1600" u="none" cap="none" strike="noStrike">
+              <a:rPr lang="en" sz="1600" b="1" i="0" u="none" strike="noStrike" cap="none">
                 <a:solidFill>
                   <a:schemeClr val="lt1"/>
                 </a:solidFill>
@@ -5955,7 +5971,7 @@
               <a:t>a demo</a:t>
             </a:r>
             <a:r>
-              <a:rPr b="0" i="0" lang="en" sz="1600" u="none" cap="none" strike="noStrike">
+              <a:rPr lang="en" sz="1600" b="0" i="0" u="none" strike="noStrike" cap="none">
                 <a:solidFill>
                   <a:schemeClr val="lt1"/>
                 </a:solidFill>
@@ -5966,7 +5982,7 @@
               </a:rPr>
               <a:t> of your project [max 2 min] </a:t>
             </a:r>
-            <a:endParaRPr b="0" i="0" sz="1600" u="none" cap="none" strike="noStrike">
+            <a:endParaRPr sz="1600" b="0" i="0" u="none" strike="noStrike" cap="none">
               <a:solidFill>
                 <a:schemeClr val="lt1"/>
               </a:solidFill>
@@ -5977,7 +5993,7 @@
             </a:endParaRPr>
           </a:p>
           <a:p>
-            <a:pPr indent="-330200" lvl="0" marL="457200" marR="0" rtl="0" algn="l">
+            <a:pPr marL="457200" marR="0" lvl="0" indent="-330200" algn="l" rtl="0">
               <a:lnSpc>
                 <a:spcPct val="100000"/>
               </a:lnSpc>
@@ -5995,7 +6011,7 @@
               <a:buChar char="●"/>
             </a:pPr>
             <a:r>
-              <a:rPr b="0" i="0" lang="en" sz="1600" u="none" cap="none" strike="noStrike">
+              <a:rPr lang="en" sz="1600" b="0" i="0" u="none" strike="noStrike" cap="none">
                 <a:solidFill>
                   <a:schemeClr val="lt1"/>
                 </a:solidFill>
@@ -6007,7 +6023,7 @@
               <a:t>Tip: pre-record it in case of technical difficulties on stage BUT </a:t>
             </a:r>
             <a:r>
-              <a:rPr b="1" i="0" lang="en" sz="1600" u="none" cap="none" strike="noStrike">
+              <a:rPr lang="en" sz="1600" b="1" i="0" u="none" strike="noStrike" cap="none">
                 <a:solidFill>
                   <a:schemeClr val="lt1"/>
                 </a:solidFill>
@@ -6019,7 +6035,7 @@
               <a:t>live demo is preferred</a:t>
             </a:r>
             <a:r>
-              <a:rPr b="0" i="0" lang="en" sz="1600" u="none" cap="none" strike="noStrike">
+              <a:rPr lang="en" sz="1600" b="0" i="0" u="none" strike="noStrike" cap="none">
                 <a:solidFill>
                   <a:schemeClr val="lt1"/>
                 </a:solidFill>
@@ -6030,7 +6046,7 @@
               </a:rPr>
               <a:t>}</a:t>
             </a:r>
-            <a:endParaRPr b="0" i="0" sz="1600" u="none" cap="none" strike="noStrike">
+            <a:endParaRPr sz="1600" b="0" i="0" u="none" strike="noStrike" cap="none">
               <a:solidFill>
                 <a:schemeClr val="lt1"/>
               </a:solidFill>
@@ -6057,14 +6073,14 @@
             <a:avLst/>
           </a:prstGeom>
           <a:noFill/>
-          <a:ln cap="flat" cmpd="sng" w="9525">
+          <a:ln w="9525" cap="flat" cmpd="sng">
             <a:solidFill>
               <a:schemeClr val="accent6"/>
             </a:solidFill>
             <a:prstDash val="solid"/>
             <a:round/>
-            <a:headEnd len="sm" w="sm" type="none"/>
-            <a:tailEnd len="med" w="med" type="stealth"/>
+            <a:headEnd type="none" w="sm" len="sm"/>
+            <a:tailEnd type="stealth" w="med" len="med"/>
           </a:ln>
         </p:spPr>
       </p:cxnSp>
@@ -6078,7 +6094,7 @@
           <a:blip r:embed="rId3">
             <a:alphaModFix/>
           </a:blip>
-          <a:srcRect b="0" l="0" r="0" t="0"/>
+          <a:srcRect/>
           <a:stretch/>
         </p:blipFill>
         <p:spPr>
@@ -6104,11 +6120,11 @@
 </file>
 
 <file path=ppt/slides/slide6.xml><?xml version="1.0" encoding="utf-8"?>
-<p:sld xmlns:a="http://schemas.openxmlformats.org/drawingml/2006/main" xmlns:r="http://schemas.openxmlformats.org/officeDocument/2006/relationships" xmlns:mc="http://schemas.openxmlformats.org/markup-compatibility/2006" xmlns:mv="urn:schemas-microsoft-com:mac:vml" xmlns:p="http://schemas.openxmlformats.org/presentationml/2006/main" xmlns:c="http://schemas.openxmlformats.org/drawingml/2006/chart" xmlns:dgm="http://schemas.openxmlformats.org/drawingml/2006/diagram" xmlns:o="urn:schemas-microsoft-com:office:office" xmlns:v="urn:schemas-microsoft-com:vml" xmlns:pvml="urn:schemas-microsoft-com:office:powerpoint" xmlns:com="http://schemas.openxmlformats.org/drawingml/2006/compatibility" xmlns:p14="http://schemas.microsoft.com/office/powerpoint/2010/main" xmlns:p15="http://schemas.microsoft.com/office/powerpoint/2012/main" xmlns:ahyp="http://schemas.microsoft.com/office/drawing/2018/hyperlinkcolor">
+<p:sld xmlns:a="http://schemas.openxmlformats.org/drawingml/2006/main" xmlns:r="http://schemas.openxmlformats.org/officeDocument/2006/relationships" xmlns:p="http://schemas.openxmlformats.org/presentationml/2006/main">
   <p:cSld>
     <p:spTree>
       <p:nvGrpSpPr>
-        <p:cNvPr id="73" name="Shape 73"/>
+        <p:cNvPr id="1" name="Shape 73"/>
         <p:cNvGrpSpPr/>
         <p:nvPr/>
       </p:nvGrpSpPr>
@@ -6140,12 +6156,12 @@
           </a:ln>
         </p:spPr>
         <p:txBody>
-          <a:bodyPr anchorCtr="0" anchor="t" bIns="19050" lIns="19050" spcFirstLastPara="1" rIns="19050" wrap="square" tIns="19050">
+          <a:bodyPr spcFirstLastPara="1" wrap="square" lIns="19050" tIns="19050" rIns="19050" bIns="19050" anchor="t" anchorCtr="0">
             <a:normAutofit/>
           </a:bodyPr>
           <a:lstStyle/>
           <a:p>
-            <a:pPr indent="0" lvl="0" marL="0" marR="0" rtl="0" algn="l">
+            <a:pPr marL="0" marR="0" lvl="0" indent="0" algn="l" rtl="0">
               <a:lnSpc>
                 <a:spcPct val="90000"/>
               </a:lnSpc>
@@ -6163,7 +6179,7 @@
               <a:buNone/>
             </a:pPr>
             <a:r>
-              <a:rPr b="1" i="0" lang="en" sz="3900" u="none" cap="none" strike="noStrike">
+              <a:rPr lang="en" sz="3900" b="1" i="0" u="none" strike="noStrike" cap="none">
                 <a:solidFill>
                   <a:srgbClr val="00E296"/>
                 </a:solidFill>
@@ -6174,7 +6190,7 @@
               </a:rPr>
               <a:t>Conclusion</a:t>
             </a:r>
-            <a:endParaRPr b="0" i="0" sz="500" u="none" cap="none" strike="noStrike">
+            <a:endParaRPr sz="500" b="0" i="0" u="none" strike="noStrike" cap="none">
               <a:solidFill>
                 <a:srgbClr val="00E296"/>
               </a:solidFill>
@@ -6206,12 +6222,12 @@
           </a:ln>
         </p:spPr>
         <p:txBody>
-          <a:bodyPr anchorCtr="0" anchor="t" bIns="91425" lIns="91425" spcFirstLastPara="1" rIns="91425" wrap="square" tIns="91425">
+          <a:bodyPr spcFirstLastPara="1" wrap="square" lIns="91425" tIns="91425" rIns="91425" bIns="91425" anchor="t" anchorCtr="0">
             <a:noAutofit/>
           </a:bodyPr>
           <a:lstStyle/>
           <a:p>
-            <a:pPr indent="-330200" lvl="0" marL="457200" marR="0" rtl="0" algn="l">
+            <a:pPr marL="457200" marR="0" lvl="0" indent="-330200" algn="l" rtl="0">
               <a:lnSpc>
                 <a:spcPct val="100000"/>
               </a:lnSpc>
@@ -6229,7 +6245,7 @@
               <a:buChar char="●"/>
             </a:pPr>
             <a:r>
-              <a:rPr b="0" i="0" lang="en" sz="1600" u="none" cap="none" strike="noStrike">
+              <a:rPr lang="en" sz="1600" b="0" i="0" u="none" strike="noStrike" cap="none">
                 <a:solidFill>
                   <a:schemeClr val="lt1"/>
                 </a:solidFill>
@@ -6241,7 +6257,7 @@
               <a:t>{Summarise and share </a:t>
             </a:r>
             <a:r>
-              <a:rPr b="1" i="0" lang="en" sz="1600" u="none" cap="none" strike="noStrike">
+              <a:rPr lang="en" sz="1600" b="1" i="0" u="none" strike="noStrike" cap="none">
                 <a:solidFill>
                   <a:schemeClr val="lt1"/>
                 </a:solidFill>
@@ -6253,7 +6269,7 @@
               <a:t>what you would like to do</a:t>
             </a:r>
             <a:r>
-              <a:rPr b="0" i="0" lang="en" sz="1600" u="none" cap="none" strike="noStrike">
+              <a:rPr lang="en" sz="1600" b="0" i="0" u="none" strike="noStrike" cap="none">
                 <a:solidFill>
                   <a:schemeClr val="lt1"/>
                 </a:solidFill>
@@ -6264,7 +6280,7 @@
               </a:rPr>
               <a:t> next}</a:t>
             </a:r>
-            <a:endParaRPr b="0" i="0" sz="1600" u="none" cap="none" strike="noStrike">
+            <a:endParaRPr sz="1600" b="0" i="0" u="none" strike="noStrike" cap="none">
               <a:solidFill>
                 <a:schemeClr val="lt1"/>
               </a:solidFill>
@@ -6291,14 +6307,14 @@
             <a:avLst/>
           </a:prstGeom>
           <a:noFill/>
-          <a:ln cap="flat" cmpd="sng" w="9525">
+          <a:ln w="9525" cap="flat" cmpd="sng">
             <a:solidFill>
               <a:srgbClr val="00E296"/>
             </a:solidFill>
             <a:prstDash val="solid"/>
             <a:round/>
-            <a:headEnd len="sm" w="sm" type="none"/>
-            <a:tailEnd len="med" w="med" type="stealth"/>
+            <a:headEnd type="none" w="sm" len="sm"/>
+            <a:tailEnd type="stealth" w="med" len="med"/>
           </a:ln>
         </p:spPr>
       </p:cxnSp>
@@ -6312,7 +6328,7 @@
           <a:blip r:embed="rId3">
             <a:alphaModFix/>
           </a:blip>
-          <a:srcRect b="0" l="0" r="0" t="0"/>
+          <a:srcRect/>
           <a:stretch/>
         </p:blipFill>
         <p:spPr>
@@ -6338,11 +6354,11 @@
 </file>
 
 <file path=ppt/slides/slide7.xml><?xml version="1.0" encoding="utf-8"?>
-<p:sld xmlns:a="http://schemas.openxmlformats.org/drawingml/2006/main" xmlns:r="http://schemas.openxmlformats.org/officeDocument/2006/relationships" xmlns:mc="http://schemas.openxmlformats.org/markup-compatibility/2006" xmlns:mv="urn:schemas-microsoft-com:mac:vml" xmlns:p="http://schemas.openxmlformats.org/presentationml/2006/main" xmlns:c="http://schemas.openxmlformats.org/drawingml/2006/chart" xmlns:dgm="http://schemas.openxmlformats.org/drawingml/2006/diagram" xmlns:o="urn:schemas-microsoft-com:office:office" xmlns:v="urn:schemas-microsoft-com:vml" xmlns:pvml="urn:schemas-microsoft-com:office:powerpoint" xmlns:com="http://schemas.openxmlformats.org/drawingml/2006/compatibility" xmlns:p14="http://schemas.microsoft.com/office/powerpoint/2010/main" xmlns:p15="http://schemas.microsoft.com/office/powerpoint/2012/main" xmlns:ahyp="http://schemas.microsoft.com/office/drawing/2018/hyperlinkcolor">
+<p:sld xmlns:a="http://schemas.openxmlformats.org/drawingml/2006/main" xmlns:r="http://schemas.openxmlformats.org/officeDocument/2006/relationships" xmlns:p="http://schemas.openxmlformats.org/presentationml/2006/main">
   <p:cSld>
     <p:spTree>
       <p:nvGrpSpPr>
-        <p:cNvPr id="81" name="Shape 81"/>
+        <p:cNvPr id="1" name="Shape 81"/>
         <p:cNvGrpSpPr/>
         <p:nvPr/>
       </p:nvGrpSpPr>
@@ -6374,12 +6390,12 @@
           </a:ln>
         </p:spPr>
         <p:txBody>
-          <a:bodyPr anchorCtr="0" anchor="t" bIns="91425" lIns="91425" spcFirstLastPara="1" rIns="91425" wrap="square" tIns="91425">
+          <a:bodyPr spcFirstLastPara="1" wrap="square" lIns="91425" tIns="91425" rIns="91425" bIns="91425" anchor="t" anchorCtr="0">
             <a:noAutofit/>
           </a:bodyPr>
           <a:lstStyle/>
           <a:p>
-            <a:pPr indent="0" lvl="0" marL="0" marR="0" rtl="0" algn="ctr">
+            <a:pPr marL="0" marR="0" lvl="0" indent="0" algn="ctr" rtl="0">
               <a:lnSpc>
                 <a:spcPct val="100000"/>
               </a:lnSpc>
@@ -6397,7 +6413,7 @@
               <a:buNone/>
             </a:pPr>
             <a:r>
-              <a:rPr b="0" i="0" lang="en" sz="3000" u="none" cap="none" strike="noStrike">
+              <a:rPr lang="en" sz="3000" b="0" i="0" u="none" strike="noStrike" cap="none">
                 <a:solidFill>
                   <a:schemeClr val="lt1"/>
                 </a:solidFill>
@@ -6408,7 +6424,7 @@
               </a:rPr>
               <a:t>Thank you.</a:t>
             </a:r>
-            <a:endParaRPr b="0" i="0" sz="3000" u="none" cap="none" strike="noStrike">
+            <a:endParaRPr sz="3000" b="0" i="0" u="none" strike="noStrike" cap="none">
               <a:solidFill>
                 <a:schemeClr val="lt1"/>
               </a:solidFill>
@@ -6430,7 +6446,7 @@
           <a:blip r:embed="rId3">
             <a:alphaModFix/>
           </a:blip>
-          <a:srcRect b="0" l="0" r="0" t="0"/>
+          <a:srcRect/>
           <a:stretch/>
         </p:blipFill>
         <p:spPr>
@@ -6456,7 +6472,288 @@
 </file>
 
 <file path=ppt/theme/theme1.xml><?xml version="1.0" encoding="utf-8"?>
-<a:theme xmlns:a="http://schemas.openxmlformats.org/drawingml/2006/main" xmlns:r="http://schemas.openxmlformats.org/officeDocument/2006/relationships">
+<a:theme xmlns:a="http://schemas.openxmlformats.org/drawingml/2006/main" name="Interledger">
+  <a:themeElements>
+    <a:clrScheme name="Simple Light">
+      <a:dk1>
+        <a:srgbClr val="000000"/>
+      </a:dk1>
+      <a:lt1>
+        <a:srgbClr val="FFFFFF"/>
+      </a:lt1>
+      <a:dk2>
+        <a:srgbClr val="595959"/>
+      </a:dk2>
+      <a:lt2>
+        <a:srgbClr val="EEEEEE"/>
+      </a:lt2>
+      <a:accent1>
+        <a:srgbClr val="4285F4"/>
+      </a:accent1>
+      <a:accent2>
+        <a:srgbClr val="212121"/>
+      </a:accent2>
+      <a:accent3>
+        <a:srgbClr val="78909C"/>
+      </a:accent3>
+      <a:accent4>
+        <a:srgbClr val="FFAB40"/>
+      </a:accent4>
+      <a:accent5>
+        <a:srgbClr val="0097A7"/>
+      </a:accent5>
+      <a:accent6>
+        <a:srgbClr val="EEFF41"/>
+      </a:accent6>
+      <a:hlink>
+        <a:srgbClr val="0097A7"/>
+      </a:hlink>
+      <a:folHlink>
+        <a:srgbClr val="0097A7"/>
+      </a:folHlink>
+    </a:clrScheme>
+    <a:fontScheme name="Office">
+      <a:majorFont>
+        <a:latin typeface="Arial"/>
+        <a:ea typeface=""/>
+        <a:cs typeface=""/>
+        <a:font script="Jpan" typeface="ＭＳ Ｐゴシック"/>
+        <a:font script="Hang" typeface="맑은 고딕"/>
+        <a:font script="Hans" typeface="宋体"/>
+        <a:font script="Hant" typeface="新細明體"/>
+        <a:font script="Arab" typeface="Times New Roman"/>
+        <a:font script="Hebr" typeface="Times New Roman"/>
+        <a:font script="Thai" typeface="Angsana New"/>
+        <a:font script="Ethi" typeface="Nyala"/>
+        <a:font script="Beng" typeface="Vrinda"/>
+        <a:font script="Gujr" typeface="Shruti"/>
+        <a:font script="Khmr" typeface="MoolBoran"/>
+        <a:font script="Knda" typeface="Tunga"/>
+        <a:font script="Guru" typeface="Raavi"/>
+        <a:font script="Cans" typeface="Euphemia"/>
+        <a:font script="Cher" typeface="Plantagenet Cherokee"/>
+        <a:font script="Yiii" typeface="Microsoft Yi Baiti"/>
+        <a:font script="Tibt" typeface="Microsoft Himalaya"/>
+        <a:font script="Thaa" typeface="MV Boli"/>
+        <a:font script="Deva" typeface="Mangal"/>
+        <a:font script="Telu" typeface="Gautami"/>
+        <a:font script="Taml" typeface="Latha"/>
+        <a:font script="Syrc" typeface="Estrangelo Edessa"/>
+        <a:font script="Orya" typeface="Kalinga"/>
+        <a:font script="Mlym" typeface="Kartika"/>
+        <a:font script="Laoo" typeface="DokChampa"/>
+        <a:font script="Sinh" typeface="Iskoola Pota"/>
+        <a:font script="Mong" typeface="Mongolian Baiti"/>
+        <a:font script="Viet" typeface="Times New Roman"/>
+        <a:font script="Uigh" typeface="Microsoft Uighur"/>
+        <a:font script="Geor" typeface="Sylfaen"/>
+      </a:majorFont>
+      <a:minorFont>
+        <a:latin typeface="Arial"/>
+        <a:ea typeface=""/>
+        <a:cs typeface=""/>
+        <a:font script="Jpan" typeface="ＭＳ Ｐゴシック"/>
+        <a:font script="Hang" typeface="맑은 고딕"/>
+        <a:font script="Hans" typeface="宋体"/>
+        <a:font script="Hant" typeface="新細明體"/>
+        <a:font script="Arab" typeface="Arial"/>
+        <a:font script="Hebr" typeface="Arial"/>
+        <a:font script="Thai" typeface="Cordia New"/>
+        <a:font script="Ethi" typeface="Nyala"/>
+        <a:font script="Beng" typeface="Vrinda"/>
+        <a:font script="Gujr" typeface="Shruti"/>
+        <a:font script="Khmr" typeface="DaunPenh"/>
+        <a:font script="Knda" typeface="Tunga"/>
+        <a:font script="Guru" typeface="Raavi"/>
+        <a:font script="Cans" typeface="Euphemia"/>
+        <a:font script="Cher" typeface="Plantagenet Cherokee"/>
+        <a:font script="Yiii" typeface="Microsoft Yi Baiti"/>
+        <a:font script="Tibt" typeface="Microsoft Himalaya"/>
+        <a:font script="Thaa" typeface="MV Boli"/>
+        <a:font script="Deva" typeface="Mangal"/>
+        <a:font script="Telu" typeface="Gautami"/>
+        <a:font script="Taml" typeface="Latha"/>
+        <a:font script="Syrc" typeface="Estrangelo Edessa"/>
+        <a:font script="Orya" typeface="Kalinga"/>
+        <a:font script="Mlym" typeface="Kartika"/>
+        <a:font script="Laoo" typeface="DokChampa"/>
+        <a:font script="Sinh" typeface="Iskoola Pota"/>
+        <a:font script="Mong" typeface="Mongolian Baiti"/>
+        <a:font script="Viet" typeface="Arial"/>
+        <a:font script="Uigh" typeface="Microsoft Uighur"/>
+        <a:font script="Geor" typeface="Sylfaen"/>
+      </a:minorFont>
+    </a:fontScheme>
+    <a:fmtScheme name="Office">
+      <a:fillStyleLst>
+        <a:solidFill>
+          <a:schemeClr val="phClr"/>
+        </a:solidFill>
+        <a:gradFill rotWithShape="1">
+          <a:gsLst>
+            <a:gs pos="0">
+              <a:schemeClr val="phClr">
+                <a:tint val="50000"/>
+                <a:satMod val="300000"/>
+              </a:schemeClr>
+            </a:gs>
+            <a:gs pos="35000">
+              <a:schemeClr val="phClr">
+                <a:tint val="37000"/>
+                <a:satMod val="300000"/>
+              </a:schemeClr>
+            </a:gs>
+            <a:gs pos="100000">
+              <a:schemeClr val="phClr">
+                <a:tint val="15000"/>
+                <a:satMod val="350000"/>
+              </a:schemeClr>
+            </a:gs>
+          </a:gsLst>
+          <a:lin ang="16200000" scaled="1"/>
+        </a:gradFill>
+        <a:gradFill rotWithShape="1">
+          <a:gsLst>
+            <a:gs pos="0">
+              <a:schemeClr val="phClr">
+                <a:tint val="100000"/>
+                <a:shade val="100000"/>
+                <a:satMod val="130000"/>
+              </a:schemeClr>
+            </a:gs>
+            <a:gs pos="100000">
+              <a:schemeClr val="phClr">
+                <a:tint val="50000"/>
+                <a:shade val="100000"/>
+                <a:satMod val="350000"/>
+              </a:schemeClr>
+            </a:gs>
+          </a:gsLst>
+          <a:lin ang="16200000" scaled="0"/>
+        </a:gradFill>
+      </a:fillStyleLst>
+      <a:lnStyleLst>
+        <a:ln w="9525" cap="flat" cmpd="sng" algn="ctr">
+          <a:solidFill>
+            <a:schemeClr val="phClr">
+              <a:shade val="95000"/>
+              <a:satMod val="105000"/>
+            </a:schemeClr>
+          </a:solidFill>
+          <a:prstDash val="solid"/>
+        </a:ln>
+        <a:ln w="25400" cap="flat" cmpd="sng" algn="ctr">
+          <a:solidFill>
+            <a:schemeClr val="phClr"/>
+          </a:solidFill>
+          <a:prstDash val="solid"/>
+        </a:ln>
+        <a:ln w="38100" cap="flat" cmpd="sng" algn="ctr">
+          <a:solidFill>
+            <a:schemeClr val="phClr"/>
+          </a:solidFill>
+          <a:prstDash val="solid"/>
+        </a:ln>
+      </a:lnStyleLst>
+      <a:effectStyleLst>
+        <a:effectStyle>
+          <a:effectLst>
+            <a:outerShdw blurRad="40000" dist="20000" dir="5400000" rotWithShape="0">
+              <a:srgbClr val="000000">
+                <a:alpha val="38000"/>
+              </a:srgbClr>
+            </a:outerShdw>
+          </a:effectLst>
+        </a:effectStyle>
+        <a:effectStyle>
+          <a:effectLst>
+            <a:outerShdw blurRad="40000" dist="23000" dir="5400000" rotWithShape="0">
+              <a:srgbClr val="000000">
+                <a:alpha val="35000"/>
+              </a:srgbClr>
+            </a:outerShdw>
+          </a:effectLst>
+        </a:effectStyle>
+        <a:effectStyle>
+          <a:effectLst>
+            <a:outerShdw blurRad="40000" dist="23000" dir="5400000" rotWithShape="0">
+              <a:srgbClr val="000000">
+                <a:alpha val="35000"/>
+              </a:srgbClr>
+            </a:outerShdw>
+          </a:effectLst>
+          <a:scene3d>
+            <a:camera prst="orthographicFront">
+              <a:rot lat="0" lon="0" rev="0"/>
+            </a:camera>
+            <a:lightRig rig="threePt" dir="t">
+              <a:rot lat="0" lon="0" rev="1200000"/>
+            </a:lightRig>
+          </a:scene3d>
+          <a:sp3d>
+            <a:bevelT w="63500" h="25400"/>
+          </a:sp3d>
+        </a:effectStyle>
+      </a:effectStyleLst>
+      <a:bgFillStyleLst>
+        <a:solidFill>
+          <a:schemeClr val="phClr"/>
+        </a:solidFill>
+        <a:gradFill rotWithShape="1">
+          <a:gsLst>
+            <a:gs pos="0">
+              <a:schemeClr val="phClr">
+                <a:tint val="40000"/>
+                <a:satMod val="350000"/>
+              </a:schemeClr>
+            </a:gs>
+            <a:gs pos="40000">
+              <a:schemeClr val="phClr">
+                <a:tint val="45000"/>
+                <a:shade val="99000"/>
+                <a:satMod val="350000"/>
+              </a:schemeClr>
+            </a:gs>
+            <a:gs pos="100000">
+              <a:schemeClr val="phClr">
+                <a:shade val="20000"/>
+                <a:satMod val="255000"/>
+              </a:schemeClr>
+            </a:gs>
+          </a:gsLst>
+          <a:path path="circle">
+            <a:fillToRect l="50000" t="-80000" r="50000" b="180000"/>
+          </a:path>
+        </a:gradFill>
+        <a:gradFill rotWithShape="1">
+          <a:gsLst>
+            <a:gs pos="0">
+              <a:schemeClr val="phClr">
+                <a:tint val="80000"/>
+                <a:satMod val="300000"/>
+              </a:schemeClr>
+            </a:gs>
+            <a:gs pos="100000">
+              <a:schemeClr val="phClr">
+                <a:shade val="30000"/>
+                <a:satMod val="200000"/>
+              </a:schemeClr>
+            </a:gs>
+          </a:gsLst>
+          <a:path path="circle">
+            <a:fillToRect l="50000" t="50000" r="50000" b="50000"/>
+          </a:path>
+        </a:gradFill>
+      </a:bgFillStyleLst>
+    </a:fmtScheme>
+  </a:themeElements>
+  <a:objectDefaults/>
+  <a:extraClrSchemeLst/>
+</a:theme>
+</file>
+
+<file path=ppt/theme/theme2.xml><?xml version="1.0" encoding="utf-8"?>
+<a:theme xmlns:a="http://schemas.openxmlformats.org/drawingml/2006/main">
   <a:themeElements>
     <a:clrScheme name="Default">
       <a:dk1>
@@ -6731,284 +7028,7 @@
       </a:bgFillStyleLst>
     </a:fmtScheme>
   </a:themeElements>
-</a:theme>
-</file>
-
-<file path=ppt/theme/theme2.xml><?xml version="1.0" encoding="utf-8"?>
-<a:theme xmlns:a="http://schemas.openxmlformats.org/drawingml/2006/main" xmlns:r="http://schemas.openxmlformats.org/officeDocument/2006/relationships" name="Interledger">
-  <a:themeElements>
-    <a:clrScheme name="Simple Light">
-      <a:dk1>
-        <a:srgbClr val="000000"/>
-      </a:dk1>
-      <a:lt1>
-        <a:srgbClr val="FFFFFF"/>
-      </a:lt1>
-      <a:dk2>
-        <a:srgbClr val="595959"/>
-      </a:dk2>
-      <a:lt2>
-        <a:srgbClr val="EEEEEE"/>
-      </a:lt2>
-      <a:accent1>
-        <a:srgbClr val="4285F4"/>
-      </a:accent1>
-      <a:accent2>
-        <a:srgbClr val="212121"/>
-      </a:accent2>
-      <a:accent3>
-        <a:srgbClr val="78909C"/>
-      </a:accent3>
-      <a:accent4>
-        <a:srgbClr val="FFAB40"/>
-      </a:accent4>
-      <a:accent5>
-        <a:srgbClr val="0097A7"/>
-      </a:accent5>
-      <a:accent6>
-        <a:srgbClr val="EEFF41"/>
-      </a:accent6>
-      <a:hlink>
-        <a:srgbClr val="0097A7"/>
-      </a:hlink>
-      <a:folHlink>
-        <a:srgbClr val="0097A7"/>
-      </a:folHlink>
-    </a:clrScheme>
-    <a:fontScheme name="Office">
-      <a:majorFont>
-        <a:latin typeface="Arial"/>
-        <a:ea typeface=""/>
-        <a:cs typeface=""/>
-        <a:font script="Jpan" typeface="ＭＳ Ｐゴシック"/>
-        <a:font script="Hang" typeface="맑은 고딕"/>
-        <a:font script="Hans" typeface="宋体"/>
-        <a:font script="Hant" typeface="新細明體"/>
-        <a:font script="Arab" typeface="Times New Roman"/>
-        <a:font script="Hebr" typeface="Times New Roman"/>
-        <a:font script="Thai" typeface="Angsana New"/>
-        <a:font script="Ethi" typeface="Nyala"/>
-        <a:font script="Beng" typeface="Vrinda"/>
-        <a:font script="Gujr" typeface="Shruti"/>
-        <a:font script="Khmr" typeface="MoolBoran"/>
-        <a:font script="Knda" typeface="Tunga"/>
-        <a:font script="Guru" typeface="Raavi"/>
-        <a:font script="Cans" typeface="Euphemia"/>
-        <a:font script="Cher" typeface="Plantagenet Cherokee"/>
-        <a:font script="Yiii" typeface="Microsoft Yi Baiti"/>
-        <a:font script="Tibt" typeface="Microsoft Himalaya"/>
-        <a:font script="Thaa" typeface="MV Boli"/>
-        <a:font script="Deva" typeface="Mangal"/>
-        <a:font script="Telu" typeface="Gautami"/>
-        <a:font script="Taml" typeface="Latha"/>
-        <a:font script="Syrc" typeface="Estrangelo Edessa"/>
-        <a:font script="Orya" typeface="Kalinga"/>
-        <a:font script="Mlym" typeface="Kartika"/>
-        <a:font script="Laoo" typeface="DokChampa"/>
-        <a:font script="Sinh" typeface="Iskoola Pota"/>
-        <a:font script="Mong" typeface="Mongolian Baiti"/>
-        <a:font script="Viet" typeface="Times New Roman"/>
-        <a:font script="Uigh" typeface="Microsoft Uighur"/>
-        <a:font script="Geor" typeface="Sylfaen"/>
-      </a:majorFont>
-      <a:minorFont>
-        <a:latin typeface="Arial"/>
-        <a:ea typeface=""/>
-        <a:cs typeface=""/>
-        <a:font script="Jpan" typeface="ＭＳ Ｐゴシック"/>
-        <a:font script="Hang" typeface="맑은 고딕"/>
-        <a:font script="Hans" typeface="宋体"/>
-        <a:font script="Hant" typeface="新細明體"/>
-        <a:font script="Arab" typeface="Arial"/>
-        <a:font script="Hebr" typeface="Arial"/>
-        <a:font script="Thai" typeface="Cordia New"/>
-        <a:font script="Ethi" typeface="Nyala"/>
-        <a:font script="Beng" typeface="Vrinda"/>
-        <a:font script="Gujr" typeface="Shruti"/>
-        <a:font script="Khmr" typeface="DaunPenh"/>
-        <a:font script="Knda" typeface="Tunga"/>
-        <a:font script="Guru" typeface="Raavi"/>
-        <a:font script="Cans" typeface="Euphemia"/>
-        <a:font script="Cher" typeface="Plantagenet Cherokee"/>
-        <a:font script="Yiii" typeface="Microsoft Yi Baiti"/>
-        <a:font script="Tibt" typeface="Microsoft Himalaya"/>
-        <a:font script="Thaa" typeface="MV Boli"/>
-        <a:font script="Deva" typeface="Mangal"/>
-        <a:font script="Telu" typeface="Gautami"/>
-        <a:font script="Taml" typeface="Latha"/>
-        <a:font script="Syrc" typeface="Estrangelo Edessa"/>
-        <a:font script="Orya" typeface="Kalinga"/>
-        <a:font script="Mlym" typeface="Kartika"/>
-        <a:font script="Laoo" typeface="DokChampa"/>
-        <a:font script="Sinh" typeface="Iskoola Pota"/>
-        <a:font script="Mong" typeface="Mongolian Baiti"/>
-        <a:font script="Viet" typeface="Arial"/>
-        <a:font script="Uigh" typeface="Microsoft Uighur"/>
-        <a:font script="Geor" typeface="Sylfaen"/>
-      </a:minorFont>
-    </a:fontScheme>
-    <a:fmtScheme name="Office">
-      <a:fillStyleLst>
-        <a:solidFill>
-          <a:schemeClr val="phClr"/>
-        </a:solidFill>
-        <a:gradFill rotWithShape="1">
-          <a:gsLst>
-            <a:gs pos="0">
-              <a:schemeClr val="phClr">
-                <a:tint val="50000"/>
-                <a:satMod val="300000"/>
-              </a:schemeClr>
-            </a:gs>
-            <a:gs pos="35000">
-              <a:schemeClr val="phClr">
-                <a:tint val="37000"/>
-                <a:satMod val="300000"/>
-              </a:schemeClr>
-            </a:gs>
-            <a:gs pos="100000">
-              <a:schemeClr val="phClr">
-                <a:tint val="15000"/>
-                <a:satMod val="350000"/>
-              </a:schemeClr>
-            </a:gs>
-          </a:gsLst>
-          <a:lin ang="16200000" scaled="1"/>
-        </a:gradFill>
-        <a:gradFill rotWithShape="1">
-          <a:gsLst>
-            <a:gs pos="0">
-              <a:schemeClr val="phClr">
-                <a:tint val="100000"/>
-                <a:shade val="100000"/>
-                <a:satMod val="130000"/>
-              </a:schemeClr>
-            </a:gs>
-            <a:gs pos="100000">
-              <a:schemeClr val="phClr">
-                <a:tint val="50000"/>
-                <a:shade val="100000"/>
-                <a:satMod val="350000"/>
-              </a:schemeClr>
-            </a:gs>
-          </a:gsLst>
-          <a:lin ang="16200000" scaled="0"/>
-        </a:gradFill>
-      </a:fillStyleLst>
-      <a:lnStyleLst>
-        <a:ln w="9525" cap="flat" cmpd="sng" algn="ctr">
-          <a:solidFill>
-            <a:schemeClr val="phClr">
-              <a:shade val="95000"/>
-              <a:satMod val="105000"/>
-            </a:schemeClr>
-          </a:solidFill>
-          <a:prstDash val="solid"/>
-        </a:ln>
-        <a:ln w="25400" cap="flat" cmpd="sng" algn="ctr">
-          <a:solidFill>
-            <a:schemeClr val="phClr"/>
-          </a:solidFill>
-          <a:prstDash val="solid"/>
-        </a:ln>
-        <a:ln w="38100" cap="flat" cmpd="sng" algn="ctr">
-          <a:solidFill>
-            <a:schemeClr val="phClr"/>
-          </a:solidFill>
-          <a:prstDash val="solid"/>
-        </a:ln>
-      </a:lnStyleLst>
-      <a:effectStyleLst>
-        <a:effectStyle>
-          <a:effectLst>
-            <a:outerShdw blurRad="40000" dist="20000" dir="5400000" rotWithShape="0">
-              <a:srgbClr val="000000">
-                <a:alpha val="38000"/>
-              </a:srgbClr>
-            </a:outerShdw>
-          </a:effectLst>
-        </a:effectStyle>
-        <a:effectStyle>
-          <a:effectLst>
-            <a:outerShdw blurRad="40000" dist="23000" dir="5400000" rotWithShape="0">
-              <a:srgbClr val="000000">
-                <a:alpha val="35000"/>
-              </a:srgbClr>
-            </a:outerShdw>
-          </a:effectLst>
-        </a:effectStyle>
-        <a:effectStyle>
-          <a:effectLst>
-            <a:outerShdw blurRad="40000" dist="23000" dir="5400000" rotWithShape="0">
-              <a:srgbClr val="000000">
-                <a:alpha val="35000"/>
-              </a:srgbClr>
-            </a:outerShdw>
-          </a:effectLst>
-          <a:scene3d>
-            <a:camera prst="orthographicFront">
-              <a:rot lat="0" lon="0" rev="0"/>
-            </a:camera>
-            <a:lightRig rig="threePt" dir="t">
-              <a:rot lat="0" lon="0" rev="1200000"/>
-            </a:lightRig>
-          </a:scene3d>
-          <a:sp3d>
-            <a:bevelT w="63500" h="25400"/>
-          </a:sp3d>
-        </a:effectStyle>
-      </a:effectStyleLst>
-      <a:bgFillStyleLst>
-        <a:solidFill>
-          <a:schemeClr val="phClr"/>
-        </a:solidFill>
-        <a:gradFill rotWithShape="1">
-          <a:gsLst>
-            <a:gs pos="0">
-              <a:schemeClr val="phClr">
-                <a:tint val="40000"/>
-                <a:satMod val="350000"/>
-              </a:schemeClr>
-            </a:gs>
-            <a:gs pos="40000">
-              <a:schemeClr val="phClr">
-                <a:tint val="45000"/>
-                <a:shade val="99000"/>
-                <a:satMod val="350000"/>
-              </a:schemeClr>
-            </a:gs>
-            <a:gs pos="100000">
-              <a:schemeClr val="phClr">
-                <a:shade val="20000"/>
-                <a:satMod val="255000"/>
-              </a:schemeClr>
-            </a:gs>
-          </a:gsLst>
-          <a:path path="circle">
-            <a:fillToRect l="50000" t="-80000" r="50000" b="180000"/>
-          </a:path>
-        </a:gradFill>
-        <a:gradFill rotWithShape="1">
-          <a:gsLst>
-            <a:gs pos="0">
-              <a:schemeClr val="phClr">
-                <a:tint val="80000"/>
-                <a:satMod val="300000"/>
-              </a:schemeClr>
-            </a:gs>
-            <a:gs pos="100000">
-              <a:schemeClr val="phClr">
-                <a:shade val="30000"/>
-                <a:satMod val="200000"/>
-              </a:schemeClr>
-            </a:gs>
-          </a:gsLst>
-          <a:path path="circle">
-            <a:fillToRect l="50000" t="50000" r="50000" b="50000"/>
-          </a:path>
-        </a:gradFill>
-      </a:bgFillStyleLst>
-    </a:fmtScheme>
-  </a:themeElements>
+  <a:objectDefaults/>
+  <a:extraClrSchemeLst/>
 </a:theme>
 </file>
</xml_diff>